<commit_message>
Publish final October science-literacy materials
Replaces the October 26, 27, 28, and 30 editable decks and one-page agendas with the finalized CUBS source annotation, CER mastery, feedback/revision, calibration, and Friday student-work analysis cycle.
</commit_message>
<xml_diff>
--- a/assets/plc/2026-10-26_Lesson_Internalization_Analyze_Science_Articles_and_Responses_CUBS_CER.pptx
+++ b/assets/plc/2026-10-26_Lesson_Internalization_Analyze_Science_Articles_and_Responses_CUBS_CER.pptx
@@ -2969,7 +2969,7 @@
                 <a:ea typeface="Inter" pitchFamily="34" charset="-122"/>
                 <a:cs typeface="Inter" pitchFamily="34" charset="-120"/>
               </a:rPr>
-              <a:t>Use CUBS to Analyze the Source Students Will Use</a:t>
+              <a:t>Student-Facing CUBS: Read and Annotate Before CER</a:t>
             </a:r>
             <a:endParaRPr lang="en-US" sz="3000" dirty="0"/>
           </a:p>
@@ -3023,7 +3023,7 @@
         <p:spPr>
           <a:xfrm>
             <a:off x="508000" y="1397000"/>
-            <a:ext cx="14605000" cy="635000"/>
+            <a:ext cx="14732000" cy="635000"/>
           </a:xfrm>
           <a:prstGeom prst="rect">
             <a:avLst/>
@@ -3047,7 +3047,7 @@
                 <a:ea typeface="Inter" pitchFamily="34" charset="-122"/>
                 <a:cs typeface="Inter" pitchFamily="34" charset="-120"/>
               </a:rPr>
-              <a:t>Apply CUBS to the article, data display, model, investigation result, or prompt that supports the upcoming writing benchmark.</a:t>
+              <a:t>Use this student-facing example with the actual article, data display, model, investigation result, or prompt that supplies evidence for the writing benchmark.</a:t>
             </a:r>
             <a:endParaRPr lang="en-US" sz="2300" dirty="0"/>
           </a:p>
@@ -3061,8 +3061,56 @@
         </p:nvSpPr>
         <p:spPr>
           <a:xfrm>
-            <a:off x="508000" y="2463800"/>
-            <a:ext cx="3479800" cy="3708400"/>
+            <a:off x="508000" y="2387600"/>
+            <a:ext cx="7112000" cy="4279900"/>
+          </a:xfrm>
+          <a:prstGeom prst="rect">
+            <a:avLst/>
+          </a:prstGeom>
+          <a:solidFill>
+            <a:srgbClr val="F8F9FA"/>
+          </a:solidFill>
+          <a:ln w="12700">
+            <a:solidFill>
+              <a:srgbClr val="D1D5DB"/>
+            </a:solidFill>
+            <a:prstDash val="solid"/>
+          </a:ln>
+        </p:spPr>
+      </p:sp>
+      <p:pic>
+        <p:nvPicPr>
+          <p:cNvPr id="7" name="cubs-example" descr="preencoded.png">    </p:cNvPr>
+          <p:cNvPicPr>
+            <a:picLocks noChangeAspect="1"/>
+          </p:cNvPicPr>
+          <p:nvPr/>
+        </p:nvPicPr>
+        <p:blipFill>
+          <a:blip r:embed="rId1"/>
+          <a:srcRect l="0" r="0" t="-409" b="-409"/>
+          <a:stretch/>
+        </p:blipFill>
+        <p:spPr>
+          <a:xfrm>
+            <a:off x="685800" y="2565400"/>
+            <a:ext cx="6756400" cy="3924300"/>
+          </a:xfrm>
+          <a:prstGeom prst="rect">
+            <a:avLst/>
+          </a:prstGeom>
+        </p:spPr>
+      </p:pic>
+      <p:sp>
+        <p:nvSpPr>
+          <p:cNvPr id="8" name="cubs-shape-7"/>
+          <p:cNvSpPr/>
+          <p:nvPr/>
+        </p:nvSpPr>
+        <p:spPr>
+          <a:xfrm>
+            <a:off x="8001000" y="2387600"/>
+            <a:ext cx="7747000" cy="4279900"/>
           </a:xfrm>
           <a:prstGeom prst="rect">
             <a:avLst/>
@@ -3080,69 +3128,30 @@
       </p:sp>
       <p:sp>
         <p:nvSpPr>
-          <p:cNvPr id="7" name="cubs-c"/>
-          <p:cNvSpPr/>
-          <p:nvPr/>
-        </p:nvSpPr>
-        <p:spPr>
-          <a:xfrm>
-            <a:off x="787400" y="2794000"/>
-            <a:ext cx="2921000" cy="774700"/>
-          </a:xfrm>
-          <a:prstGeom prst="rect">
-            <a:avLst/>
-          </a:prstGeom>
-          <a:noFill/>
-          <a:ln/>
-        </p:spPr>
-        <p:txBody>
-          <a:bodyPr wrap="none" lIns="0" tIns="0" rIns="0" bIns="0" rtlCol="0" anchor="t"/>
+          <p:cNvPr id="9" name="cubs-title"/>
+          <p:cNvSpPr/>
+          <p:nvPr/>
+        </p:nvSpPr>
+        <p:spPr>
+          <a:xfrm>
+            <a:off x="8382000" y="2730500"/>
+            <a:ext cx="6731000" cy="381000"/>
+          </a:xfrm>
+          <a:prstGeom prst="rect">
+            <a:avLst/>
+          </a:prstGeom>
+          <a:noFill/>
+          <a:ln/>
+        </p:spPr>
+        <p:txBody>
+          <a:bodyPr wrap="square" lIns="0" tIns="0" rIns="0" bIns="0" rtlCol="0" anchor="t"/>
           <a:lstStyle/>
           <a:p>
             <a:pPr algn="l" indent="0" marL="0">
               <a:buNone/>
             </a:pPr>
             <a:r>
-              <a:rPr lang="en-US" altLang="en-US" sz="5800" dirty="0">
-                <a:solidFill>
-                  <a:srgbClr val="C41220"/>
-                </a:solidFill>
-                <a:latin typeface="Inter" pitchFamily="34" charset="0"/>
-                <a:ea typeface="Inter" pitchFamily="34" charset="-122"/>
-                <a:cs typeface="Inter" pitchFamily="34" charset="-120"/>
-              </a:rPr>
-              <a:t>C</a:t>
-            </a:r>
-            <a:endParaRPr lang="en-US" sz="5800" dirty="0"/>
-          </a:p>
-        </p:txBody>
-      </p:sp>
-      <p:sp>
-        <p:nvSpPr>
-          <p:cNvPr id="8" name="cubs-c-title"/>
-          <p:cNvSpPr/>
-          <p:nvPr/>
-        </p:nvSpPr>
-        <p:spPr>
-          <a:xfrm>
-            <a:off x="787400" y="3695700"/>
-            <a:ext cx="2921000" cy="431800"/>
-          </a:xfrm>
-          <a:prstGeom prst="rect">
-            <a:avLst/>
-          </a:prstGeom>
-          <a:noFill/>
-          <a:ln/>
-        </p:spPr>
-        <p:txBody>
-          <a:bodyPr wrap="square" lIns="0" tIns="0" rIns="0" bIns="0" rtlCol="0" anchor="t"/>
-          <a:lstStyle/>
-          <a:p>
-            <a:pPr algn="l" indent="0" marL="0">
-              <a:buNone/>
-            </a:pPr>
-            <a:r>
-              <a:rPr lang="en-US" altLang="en-US" sz="2600" dirty="0">
+              <a:rPr lang="en-US" altLang="en-US" sz="2400" dirty="0">
                 <a:solidFill>
                   <a:srgbClr val="3C4043"/>
                 </a:solidFill>
@@ -3150,22 +3159,22 @@
                 <a:ea typeface="Inter" pitchFamily="34" charset="-122"/>
                 <a:cs typeface="Inter" pitchFamily="34" charset="-120"/>
               </a:rPr>
-              <a:t>Circle</a:t>
-            </a:r>
-            <a:endParaRPr lang="en-US" sz="2600" dirty="0"/>
-          </a:p>
-        </p:txBody>
-      </p:sp>
-      <p:sp>
-        <p:nvSpPr>
-          <p:cNvPr id="9" name="cubs-c-body"/>
-          <p:cNvSpPr/>
-          <p:nvPr/>
-        </p:nvSpPr>
-        <p:spPr>
-          <a:xfrm>
-            <a:off x="787400" y="4330700"/>
-            <a:ext cx="2794000" cy="1168400"/>
+              <a:t>STUDENT ROUTINE: USE THE SOURCE TO BUILD A RESPONSE</a:t>
+            </a:r>
+            <a:endParaRPr lang="en-US" sz="2400" dirty="0"/>
+          </a:p>
+        </p:txBody>
+      </p:sp>
+      <p:sp>
+        <p:nvSpPr>
+          <p:cNvPr id="10" name="cubs-steps"/>
+          <p:cNvSpPr/>
+          <p:nvPr/>
+        </p:nvSpPr>
+        <p:spPr>
+          <a:xfrm>
+            <a:off x="8382000" y="3390900"/>
+            <a:ext cx="6731000" cy="2641600"/>
           </a:xfrm>
           <a:prstGeom prst="rect">
             <a:avLst/>
@@ -3179,11 +3188,22 @@
           <a:p>
             <a:pPr algn="l" indent="0" marL="0">
               <a:lnSpc>
-                <a:spcPts val="2562"/>
+                <a:spcPts val="2583"/>
               </a:lnSpc>
               <a:buNone/>
             </a:pPr>
             <a:r>
+              <a:rPr lang="en-US" altLang="en-US" sz="2100" b="1" dirty="0">
+                <a:solidFill>
+                  <a:srgbClr val="C41220"/>
+                </a:solidFill>
+                <a:latin typeface="Inter" pitchFamily="34" charset="0"/>
+                <a:ea typeface="Inter" pitchFamily="34" charset="-122"/>
+                <a:cs typeface="Inter" pitchFamily="34" charset="-120"/>
+              </a:rPr>
+              <a:t>C — Circle</a:t>
+            </a:r>
+            <a:r>
               <a:rPr lang="en-US" altLang="en-US" sz="2100" dirty="0">
                 <a:solidFill>
                   <a:srgbClr val="3C4043"/>
@@ -3192,143 +3212,29 @@
                 <a:ea typeface="Inter" pitchFamily="34" charset="-122"/>
                 <a:cs typeface="Inter" pitchFamily="34" charset="-120"/>
               </a:rPr>
-              <a:t>the central idea or scientific claim students need to understand before they write.</a:t>
+              <a:t> the main idea or scientific claim.</a:t>
             </a:r>
             <a:endParaRPr lang="en-US" sz="2100" dirty="0"/>
           </a:p>
-        </p:txBody>
-      </p:sp>
-      <p:sp>
-        <p:nvSpPr>
-          <p:cNvPr id="10" name="cubs-shape-9"/>
-          <p:cNvSpPr/>
-          <p:nvPr/>
-        </p:nvSpPr>
-        <p:spPr>
-          <a:xfrm>
-            <a:off x="4267200" y="2463800"/>
-            <a:ext cx="3479800" cy="3708400"/>
-          </a:xfrm>
-          <a:prstGeom prst="rect">
-            <a:avLst/>
-          </a:prstGeom>
-          <a:solidFill>
-            <a:srgbClr val="F3F4F6"/>
-          </a:solidFill>
-          <a:ln w="12700">
-            <a:solidFill>
-              <a:srgbClr val="D1D5DB"/>
-            </a:solidFill>
-            <a:prstDash val="solid"/>
-          </a:ln>
-        </p:spPr>
-      </p:sp>
-      <p:sp>
-        <p:nvSpPr>
-          <p:cNvPr id="11" name="cubs-u"/>
-          <p:cNvSpPr/>
-          <p:nvPr/>
-        </p:nvSpPr>
-        <p:spPr>
-          <a:xfrm>
-            <a:off x="4546600" y="2794000"/>
-            <a:ext cx="2921000" cy="774700"/>
-          </a:xfrm>
-          <a:prstGeom prst="rect">
-            <a:avLst/>
-          </a:prstGeom>
-          <a:noFill/>
-          <a:ln/>
-        </p:spPr>
-        <p:txBody>
-          <a:bodyPr wrap="none" lIns="0" tIns="0" rIns="0" bIns="0" rtlCol="0" anchor="t"/>
-          <a:lstStyle/>
-          <a:p>
-            <a:pPr algn="l" indent="0" marL="0">
-              <a:buNone/>
-            </a:pPr>
-            <a:r>
-              <a:rPr lang="en-US" altLang="en-US" sz="5800" dirty="0">
-                <a:solidFill>
-                  <a:srgbClr val="C41220"/>
-                </a:solidFill>
-                <a:latin typeface="Inter" pitchFamily="34" charset="0"/>
-                <a:ea typeface="Inter" pitchFamily="34" charset="-122"/>
-                <a:cs typeface="Inter" pitchFamily="34" charset="-120"/>
-              </a:rPr>
-              <a:t>U</a:t>
-            </a:r>
-            <a:endParaRPr lang="en-US" sz="5800" dirty="0"/>
-          </a:p>
-        </p:txBody>
-      </p:sp>
-      <p:sp>
-        <p:nvSpPr>
-          <p:cNvPr id="12" name="cubs-u-title"/>
-          <p:cNvSpPr/>
-          <p:nvPr/>
-        </p:nvSpPr>
-        <p:spPr>
-          <a:xfrm>
-            <a:off x="4546600" y="3695700"/>
-            <a:ext cx="2921000" cy="431800"/>
-          </a:xfrm>
-          <a:prstGeom prst="rect">
-            <a:avLst/>
-          </a:prstGeom>
-          <a:noFill/>
-          <a:ln/>
-        </p:spPr>
-        <p:txBody>
-          <a:bodyPr wrap="square" lIns="0" tIns="0" rIns="0" bIns="0" rtlCol="0" anchor="t"/>
-          <a:lstStyle/>
-          <a:p>
-            <a:pPr algn="l" indent="0" marL="0">
-              <a:buNone/>
-            </a:pPr>
-            <a:r>
-              <a:rPr lang="en-US" altLang="en-US" sz="2600" dirty="0">
-                <a:solidFill>
-                  <a:srgbClr val="3C4043"/>
-                </a:solidFill>
-                <a:latin typeface="Inter" pitchFamily="34" charset="0"/>
-                <a:ea typeface="Inter" pitchFamily="34" charset="-122"/>
-                <a:cs typeface="Inter" pitchFamily="34" charset="-120"/>
-              </a:rPr>
-              <a:t>Underline</a:t>
-            </a:r>
-            <a:endParaRPr lang="en-US" sz="2600" dirty="0"/>
-          </a:p>
-        </p:txBody>
-      </p:sp>
-      <p:sp>
-        <p:nvSpPr>
-          <p:cNvPr id="13" name="cubs-u-body"/>
-          <p:cNvSpPr/>
-          <p:nvPr/>
-        </p:nvSpPr>
-        <p:spPr>
-          <a:xfrm>
-            <a:off x="4546600" y="4330700"/>
-            <a:ext cx="2794000" cy="1168400"/>
-          </a:xfrm>
-          <a:prstGeom prst="rect">
-            <a:avLst/>
-          </a:prstGeom>
-          <a:noFill/>
-          <a:ln/>
-        </p:spPr>
-        <p:txBody>
-          <a:bodyPr wrap="square" lIns="0" tIns="0" rIns="0" bIns="0" rtlCol="0" anchor="t"/>
-          <a:lstStyle/>
           <a:p>
             <a:pPr algn="l" indent="0" marL="0">
               <a:lnSpc>
-                <a:spcPts val="2562"/>
+                <a:spcPts val="2583"/>
               </a:lnSpc>
               <a:buNone/>
             </a:pPr>
             <a:r>
+              <a:rPr lang="en-US" altLang="en-US" sz="2100" b="1" dirty="0">
+                <a:solidFill>
+                  <a:srgbClr val="C41220"/>
+                </a:solidFill>
+                <a:latin typeface="Inter" pitchFamily="34" charset="0"/>
+                <a:ea typeface="Inter" pitchFamily="34" charset="-122"/>
+                <a:cs typeface="Inter" pitchFamily="34" charset="-120"/>
+              </a:rPr>
+              <a:t>U — Underline</a:t>
+            </a:r>
+            <a:r>
               <a:rPr lang="en-US" altLang="en-US" sz="2100" dirty="0">
                 <a:solidFill>
                   <a:srgbClr val="3C4043"/>
@@ -3337,143 +3243,29 @@
                 <a:ea typeface="Inter" pitchFamily="34" charset="-122"/>
                 <a:cs typeface="Inter" pitchFamily="34" charset="-120"/>
               </a:rPr>
-              <a:t>the data, details, observations, or relationships students can use as evidence.</a:t>
+              <a:t> supporting data, observations, or details.</a:t>
             </a:r>
             <a:endParaRPr lang="en-US" sz="2100" dirty="0"/>
           </a:p>
-        </p:txBody>
-      </p:sp>
-      <p:sp>
-        <p:nvSpPr>
-          <p:cNvPr id="14" name="cubs-shape-13"/>
-          <p:cNvSpPr/>
-          <p:nvPr/>
-        </p:nvSpPr>
-        <p:spPr>
-          <a:xfrm>
-            <a:off x="8026400" y="2463800"/>
-            <a:ext cx="3479800" cy="3708400"/>
-          </a:xfrm>
-          <a:prstGeom prst="rect">
-            <a:avLst/>
-          </a:prstGeom>
-          <a:solidFill>
-            <a:srgbClr val="F3F4F6"/>
-          </a:solidFill>
-          <a:ln w="12700">
-            <a:solidFill>
-              <a:srgbClr val="D1D5DB"/>
-            </a:solidFill>
-            <a:prstDash val="solid"/>
-          </a:ln>
-        </p:spPr>
-      </p:sp>
-      <p:sp>
-        <p:nvSpPr>
-          <p:cNvPr id="15" name="cubs-b"/>
-          <p:cNvSpPr/>
-          <p:nvPr/>
-        </p:nvSpPr>
-        <p:spPr>
-          <a:xfrm>
-            <a:off x="8305800" y="2794000"/>
-            <a:ext cx="2921000" cy="774700"/>
-          </a:xfrm>
-          <a:prstGeom prst="rect">
-            <a:avLst/>
-          </a:prstGeom>
-          <a:noFill/>
-          <a:ln/>
-        </p:spPr>
-        <p:txBody>
-          <a:bodyPr wrap="none" lIns="0" tIns="0" rIns="0" bIns="0" rtlCol="0" anchor="t"/>
-          <a:lstStyle/>
-          <a:p>
-            <a:pPr algn="l" indent="0" marL="0">
-              <a:buNone/>
-            </a:pPr>
-            <a:r>
-              <a:rPr lang="en-US" altLang="en-US" sz="5800" dirty="0">
-                <a:solidFill>
-                  <a:srgbClr val="C41220"/>
-                </a:solidFill>
-                <a:latin typeface="Inter" pitchFamily="34" charset="0"/>
-                <a:ea typeface="Inter" pitchFamily="34" charset="-122"/>
-                <a:cs typeface="Inter" pitchFamily="34" charset="-120"/>
-              </a:rPr>
-              <a:t>B</a:t>
-            </a:r>
-            <a:endParaRPr lang="en-US" sz="5800" dirty="0"/>
-          </a:p>
-        </p:txBody>
-      </p:sp>
-      <p:sp>
-        <p:nvSpPr>
-          <p:cNvPr id="16" name="cubs-b-title"/>
-          <p:cNvSpPr/>
-          <p:nvPr/>
-        </p:nvSpPr>
-        <p:spPr>
-          <a:xfrm>
-            <a:off x="8305800" y="3695700"/>
-            <a:ext cx="2921000" cy="431800"/>
-          </a:xfrm>
-          <a:prstGeom prst="rect">
-            <a:avLst/>
-          </a:prstGeom>
-          <a:noFill/>
-          <a:ln/>
-        </p:spPr>
-        <p:txBody>
-          <a:bodyPr wrap="square" lIns="0" tIns="0" rIns="0" bIns="0" rtlCol="0" anchor="t"/>
-          <a:lstStyle/>
-          <a:p>
-            <a:pPr algn="l" indent="0" marL="0">
-              <a:buNone/>
-            </a:pPr>
-            <a:r>
-              <a:rPr lang="en-US" altLang="en-US" sz="2600" dirty="0">
-                <a:solidFill>
-                  <a:srgbClr val="3C4043"/>
-                </a:solidFill>
-                <a:latin typeface="Inter" pitchFamily="34" charset="0"/>
-                <a:ea typeface="Inter" pitchFamily="34" charset="-122"/>
-                <a:cs typeface="Inter" pitchFamily="34" charset="-120"/>
-              </a:rPr>
-              <a:t>Box</a:t>
-            </a:r>
-            <a:endParaRPr lang="en-US" sz="2600" dirty="0"/>
-          </a:p>
-        </p:txBody>
-      </p:sp>
-      <p:sp>
-        <p:nvSpPr>
-          <p:cNvPr id="17" name="cubs-b-body"/>
-          <p:cNvSpPr/>
-          <p:nvPr/>
-        </p:nvSpPr>
-        <p:spPr>
-          <a:xfrm>
-            <a:off x="8305800" y="4330700"/>
-            <a:ext cx="2794000" cy="1168400"/>
-          </a:xfrm>
-          <a:prstGeom prst="rect">
-            <a:avLst/>
-          </a:prstGeom>
-          <a:noFill/>
-          <a:ln/>
-        </p:spPr>
-        <p:txBody>
-          <a:bodyPr wrap="square" lIns="0" tIns="0" rIns="0" bIns="0" rtlCol="0" anchor="t"/>
-          <a:lstStyle/>
           <a:p>
             <a:pPr algn="l" indent="0" marL="0">
               <a:lnSpc>
-                <a:spcPts val="2562"/>
+                <a:spcPts val="2583"/>
               </a:lnSpc>
               <a:buNone/>
             </a:pPr>
             <a:r>
+              <a:rPr lang="en-US" altLang="en-US" sz="2100" b="1" dirty="0">
+                <a:solidFill>
+                  <a:srgbClr val="C41220"/>
+                </a:solidFill>
+                <a:latin typeface="Inter" pitchFamily="34" charset="0"/>
+                <a:ea typeface="Inter" pitchFamily="34" charset="-122"/>
+                <a:cs typeface="Inter" pitchFamily="34" charset="-120"/>
+              </a:rPr>
+              <a:t>B — Box</a:t>
+            </a:r>
+            <a:r>
               <a:rPr lang="en-US" altLang="en-US" sz="2100" dirty="0">
                 <a:solidFill>
                   <a:srgbClr val="3C4043"/>
@@ -3482,143 +3274,29 @@
                 <a:ea typeface="Inter" pitchFamily="34" charset="-122"/>
                 <a:cs typeface="Inter" pitchFamily="34" charset="-120"/>
               </a:rPr>
-              <a:t>the vocabulary, language, or representations that may prevent access to the task.</a:t>
+              <a:t> unfamiliar or important vocabulary.</a:t>
             </a:r>
             <a:endParaRPr lang="en-US" sz="2100" dirty="0"/>
           </a:p>
-        </p:txBody>
-      </p:sp>
-      <p:sp>
-        <p:nvSpPr>
-          <p:cNvPr id="18" name="cubs-shape-17"/>
-          <p:cNvSpPr/>
-          <p:nvPr/>
-        </p:nvSpPr>
-        <p:spPr>
-          <a:xfrm>
-            <a:off x="11785600" y="2463800"/>
-            <a:ext cx="3962400" cy="3708400"/>
-          </a:xfrm>
-          <a:prstGeom prst="rect">
-            <a:avLst/>
-          </a:prstGeom>
-          <a:solidFill>
-            <a:srgbClr val="FCE8EA"/>
-          </a:solidFill>
-          <a:ln w="25400">
-            <a:solidFill>
-              <a:srgbClr val="C41220"/>
-            </a:solidFill>
-            <a:prstDash val="solid"/>
-          </a:ln>
-        </p:spPr>
-      </p:sp>
-      <p:sp>
-        <p:nvSpPr>
-          <p:cNvPr id="19" name="cubs-s"/>
-          <p:cNvSpPr/>
-          <p:nvPr/>
-        </p:nvSpPr>
-        <p:spPr>
-          <a:xfrm>
-            <a:off x="12065000" y="2794000"/>
-            <a:ext cx="3175000" cy="774700"/>
-          </a:xfrm>
-          <a:prstGeom prst="rect">
-            <a:avLst/>
-          </a:prstGeom>
-          <a:noFill/>
-          <a:ln/>
-        </p:spPr>
-        <p:txBody>
-          <a:bodyPr wrap="none" lIns="0" tIns="0" rIns="0" bIns="0" rtlCol="0" anchor="t"/>
-          <a:lstStyle/>
-          <a:p>
-            <a:pPr algn="l" indent="0" marL="0">
-              <a:buNone/>
-            </a:pPr>
-            <a:r>
-              <a:rPr lang="en-US" altLang="en-US" sz="5800" dirty="0">
-                <a:solidFill>
-                  <a:srgbClr val="C41220"/>
-                </a:solidFill>
-                <a:latin typeface="Inter" pitchFamily="34" charset="0"/>
-                <a:ea typeface="Inter" pitchFamily="34" charset="-122"/>
-                <a:cs typeface="Inter" pitchFamily="34" charset="-120"/>
-              </a:rPr>
-              <a:t>S</a:t>
-            </a:r>
-            <a:endParaRPr lang="en-US" sz="5800" dirty="0"/>
-          </a:p>
-        </p:txBody>
-      </p:sp>
-      <p:sp>
-        <p:nvSpPr>
-          <p:cNvPr id="20" name="cubs-s-title"/>
-          <p:cNvSpPr/>
-          <p:nvPr/>
-        </p:nvSpPr>
-        <p:spPr>
-          <a:xfrm>
-            <a:off x="12065000" y="3695700"/>
-            <a:ext cx="3175000" cy="431800"/>
-          </a:xfrm>
-          <a:prstGeom prst="rect">
-            <a:avLst/>
-          </a:prstGeom>
-          <a:noFill/>
-          <a:ln/>
-        </p:spPr>
-        <p:txBody>
-          <a:bodyPr wrap="square" lIns="0" tIns="0" rIns="0" bIns="0" rtlCol="0" anchor="t"/>
-          <a:lstStyle/>
-          <a:p>
-            <a:pPr algn="l" indent="0" marL="0">
-              <a:buNone/>
-            </a:pPr>
-            <a:r>
-              <a:rPr lang="en-US" altLang="en-US" sz="2600" dirty="0">
-                <a:solidFill>
-                  <a:srgbClr val="3C4043"/>
-                </a:solidFill>
-                <a:latin typeface="Inter" pitchFamily="34" charset="0"/>
-                <a:ea typeface="Inter" pitchFamily="34" charset="-122"/>
-                <a:cs typeface="Inter" pitchFamily="34" charset="-120"/>
-              </a:rPr>
-              <a:t>Summarize</a:t>
-            </a:r>
-            <a:endParaRPr lang="en-US" sz="2600" dirty="0"/>
-          </a:p>
-        </p:txBody>
-      </p:sp>
-      <p:sp>
-        <p:nvSpPr>
-          <p:cNvPr id="21" name="cubs-s-body"/>
-          <p:cNvSpPr/>
-          <p:nvPr/>
-        </p:nvSpPr>
-        <p:spPr>
-          <a:xfrm>
-            <a:off x="12065000" y="4330700"/>
-            <a:ext cx="3302000" cy="1168400"/>
-          </a:xfrm>
-          <a:prstGeom prst="rect">
-            <a:avLst/>
-          </a:prstGeom>
-          <a:noFill/>
-          <a:ln/>
-        </p:spPr>
-        <p:txBody>
-          <a:bodyPr wrap="square" lIns="0" tIns="0" rIns="0" bIns="0" rtlCol="0" anchor="t"/>
-          <a:lstStyle/>
           <a:p>
             <a:pPr algn="l" indent="0" marL="0">
               <a:lnSpc>
-                <a:spcPts val="2562"/>
+                <a:spcPts val="2583"/>
               </a:lnSpc>
               <a:buNone/>
             </a:pPr>
             <a:r>
+              <a:rPr lang="en-US" altLang="en-US" sz="2100" b="1" dirty="0">
+                <a:solidFill>
+                  <a:srgbClr val="C41220"/>
+                </a:solidFill>
+                <a:latin typeface="Inter" pitchFamily="34" charset="0"/>
+                <a:ea typeface="Inter" pitchFamily="34" charset="-122"/>
+                <a:cs typeface="Inter" pitchFamily="34" charset="-120"/>
+              </a:rPr>
+              <a:t>S — Summarize</a:t>
+            </a:r>
+            <a:r>
               <a:rPr lang="en-US" altLang="en-US" sz="2100" dirty="0">
                 <a:solidFill>
                   <a:srgbClr val="3C4043"/>
@@ -3627,7 +3305,7 @@
                 <a:ea typeface="Inter" pitchFamily="34" charset="-122"/>
                 <a:cs typeface="Inter" pitchFamily="34" charset="-120"/>
               </a:rPr>
-              <a:t>what the source helps students explain—or the question they still need to resolve.</a:t>
+              <a:t> the science idea or question the source helps answer.</a:t>
             </a:r>
             <a:endParaRPr lang="en-US" sz="2100" dirty="0"/>
           </a:p>
@@ -3635,14 +3313,14 @@
       </p:sp>
       <p:sp>
         <p:nvSpPr>
-          <p:cNvPr id="22" name="cubs-shape-21"/>
-          <p:cNvSpPr/>
-          <p:nvPr/>
-        </p:nvSpPr>
-        <p:spPr>
-          <a:xfrm>
-            <a:off x="508000" y="6794500"/>
-            <a:ext cx="15240000" cy="1117600"/>
+          <p:cNvPr id="11" name="cubs-shape-10"/>
+          <p:cNvSpPr/>
+          <p:nvPr/>
+        </p:nvSpPr>
+        <p:spPr>
+          <a:xfrm>
+            <a:off x="508000" y="7035800"/>
+            <a:ext cx="15240000" cy="889000"/>
           </a:xfrm>
           <a:prstGeom prst="rect">
             <a:avLst/>
@@ -3655,14 +3333,14 @@
       </p:sp>
       <p:sp>
         <p:nvSpPr>
-          <p:cNvPr id="23" name="cubs-bottom"/>
-          <p:cNvSpPr/>
-          <p:nvPr/>
-        </p:nvSpPr>
-        <p:spPr>
-          <a:xfrm>
-            <a:off x="825500" y="6997700"/>
-            <a:ext cx="14554200" cy="609600"/>
+          <p:cNvPr id="12" name="cubs-bottom"/>
+          <p:cNvSpPr/>
+          <p:nvPr/>
+        </p:nvSpPr>
+        <p:spPr>
+          <a:xfrm>
+            <a:off x="838200" y="7239000"/>
+            <a:ext cx="14528800" cy="508000"/>
           </a:xfrm>
           <a:prstGeom prst="rect">
             <a:avLst/>
@@ -3674,9 +3352,9 @@
           <a:bodyPr wrap="square" lIns="0" tIns="0" rIns="0" bIns="0" rtlCol="0" anchor="t"/>
           <a:lstStyle/>
           <a:p>
-            <a:pPr algn="l" indent="0" marL="0">
+            <a:pPr algn="ctr" indent="0" marL="0">
               <a:lnSpc>
-                <a:spcPts val="2415"/>
+                <a:spcPts val="2436"/>
               </a:lnSpc>
               <a:buNone/>
             </a:pPr>
@@ -3689,7 +3367,7 @@
                 <a:ea typeface="Inter" pitchFamily="34" charset="-122"/>
                 <a:cs typeface="Inter" pitchFamily="34" charset="-120"/>
               </a:rPr>
-              <a:t>Use it as an access routine:</a:t>
+              <a:t>Expected student product:</a:t>
             </a:r>
             <a:r>
               <a:rPr lang="en-US" altLang="en-US" sz="2100" dirty="0">
@@ -3700,7 +3378,7 @@
                 <a:ea typeface="Inter" pitchFamily="34" charset="-122"/>
                 <a:cs typeface="Inter" pitchFamily="34" charset="-120"/>
               </a:rPr>
-              <a:t> CUBS prepares students to use the source in their science writing. It is not a separate activity or grading category.</a:t>
+              <a:t> an annotated source that helps students identify and complete a claim, evidence, and reasoning response—not a separate activity or grading category.</a:t>
             </a:r>
             <a:endParaRPr lang="en-US" sz="2100" dirty="0"/>
           </a:p>
@@ -3708,7 +3386,7 @@
       </p:sp>
       <p:sp>
         <p:nvSpPr>
-          <p:cNvPr id="24" name="page"/>
+          <p:cNvPr id="13" name="page"/>
           <p:cNvSpPr/>
           <p:nvPr/>
         </p:nvSpPr>
@@ -3747,7 +3425,7 @@
       </p:sp>
       <p:sp>
         <p:nvSpPr>
-          <p:cNvPr id="25" name="cubs-shape-24"/>
+          <p:cNvPr id="14" name="cubs-shape-13"/>
           <p:cNvSpPr/>
           <p:nvPr/>
         </p:nvSpPr>
@@ -3850,7 +3528,7 @@
                 <a:ea typeface="Inter" pitchFamily="34" charset="-122"/>
                 <a:cs typeface="Inter" pitchFamily="34" charset="-120"/>
               </a:rPr>
-              <a:t>Anticipate Student Thinking With CER</a:t>
+              <a:t>Anticipate and Judge the Student CER Response</a:t>
             </a:r>
             <a:endParaRPr lang="en-US" sz="3000" dirty="0"/>
           </a:p>
@@ -3928,7 +3606,7 @@
                 <a:ea typeface="Inter" pitchFamily="34" charset="-122"/>
                 <a:cs typeface="Inter" pitchFamily="34" charset="-120"/>
               </a:rPr>
-              <a:t>Use an exemplar or anticipated response to name what quality looks like and where students may need a prompt—not an answer.</a:t>
+              <a:t>Use an exemplar or anticipated response to define what meeting the standard looks like, what a partial CER shows, and where students need a prompt—not an answer.</a:t>
             </a:r>
             <a:endParaRPr lang="en-US" sz="2300" dirty="0"/>
           </a:p>
@@ -4034,7 +3712,7 @@
                 <a:ea typeface="Inter" pitchFamily="34" charset="-122"/>
                 <a:cs typeface="Inter" pitchFamily="34" charset="-120"/>
               </a:rPr>
-              <a:t>What conclusion, explanation, or position should the student state clearly?</a:t>
+              <a:t>Can the student identify and clearly state a conclusion, explanation, or position?</a:t>
             </a:r>
             <a:endParaRPr lang="en-US" sz="2000" dirty="0"/>
           </a:p>
@@ -4140,7 +3818,7 @@
                 <a:ea typeface="Inter" pitchFamily="34" charset="-122"/>
                 <a:cs typeface="Inter" pitchFamily="34" charset="-120"/>
               </a:rPr>
-              <a:t>Which data, observation, or source detail should students select and use accurately?</a:t>
+              <a:t>Can the student select and use accurate, relevant data, observations, or source details?</a:t>
             </a:r>
             <a:endParaRPr lang="en-US" sz="2000" dirty="0"/>
           </a:p>
@@ -4246,7 +3924,7 @@
                 <a:ea typeface="Inter" pitchFamily="34" charset="-122"/>
                 <a:cs typeface="Inter" pitchFamily="34" charset="-120"/>
               </a:rPr>
-              <a:t>Which scientific idea explains why that evidence supports the claim?</a:t>
+              <a:t>Can the student explain why the evidence supports the claim using the science idea?</a:t>
             </a:r>
             <a:endParaRPr lang="en-US" sz="2000" dirty="0"/>
           </a:p>
@@ -4352,7 +4030,7 @@
                 <a:ea typeface="Inter" pitchFamily="34" charset="-122"/>
                 <a:cs typeface="Inter" pitchFamily="34" charset="-120"/>
               </a:rPr>
-              <a:t>Which words, transitions, or representations help readers follow the science thinking?</a:t>
+              <a:t>Which language or representation makes the student’s completed thinking clear to a reader?</a:t>
             </a:r>
             <a:endParaRPr lang="en-US" sz="2000" dirty="0"/>
           </a:p>
@@ -4443,7 +4121,7 @@
                 <a:ea typeface="Inter" pitchFamily="34" charset="-122"/>
                 <a:cs typeface="Inter" pitchFamily="34" charset="-120"/>
               </a:rPr>
-              <a:t>Anticipate:</a:t>
+              <a:t>Judge the bar:</a:t>
             </a:r>
             <a:r>
               <a:rPr lang="en-US" altLang="en-US" sz="2200" dirty="0">
@@ -4454,7 +4132,7 @@
                 <a:ea typeface="Inter" pitchFamily="34" charset="-122"/>
                 <a:cs typeface="Inter" pitchFamily="34" charset="-120"/>
               </a:rPr>
-              <a:t> “What might students write, say, or leave out? Which criterion would move their thinking forward most?”</a:t>
+              <a:t> “What would a complete CER show? What would a partial response show? Which criterion would move students forward most?”</a:t>
             </a:r>
             <a:endParaRPr lang="en-US" sz="2200" dirty="0"/>
           </a:p>
@@ -4604,7 +4282,7 @@
                 <a:ea typeface="Inter" pitchFamily="34" charset="-122"/>
                 <a:cs typeface="Inter" pitchFamily="34" charset="-120"/>
               </a:rPr>
-              <a:t>Internalize the Upcoming Writing Benchmark</a:t>
+              <a:t>Anticipate the Response + Judge the Bar for Mastery</a:t>
             </a:r>
             <a:endParaRPr lang="en-US" sz="3000" dirty="0"/>
           </a:p>
@@ -5029,7 +4707,7 @@
                 <a:ea typeface="Inter" pitchFamily="34" charset="-122"/>
                 <a:cs typeface="Inter" pitchFamily="34" charset="-120"/>
               </a:rPr>
-              <a:t>2. Anticipate student thinking</a:t>
+              <a:t>2. Anticipate + judge the CER response</a:t>
             </a:r>
             <a:endParaRPr lang="en-US" sz="2600" dirty="0"/>
           </a:p>
@@ -5075,7 +4753,7 @@
                 <a:ea typeface="Inter" pitchFamily="34" charset="-122"/>
                 <a:cs typeface="Inter" pitchFamily="34" charset="-120"/>
               </a:rPr>
-              <a:t>What could a strong response include?</a:t>
+              <a:t>What claim, evidence, and reasoning would meet the standard?</a:t>
             </a:r>
             <a:endParaRPr lang="en-US" sz="2100" dirty="0"/>
           </a:p>
@@ -5147,7 +4825,7 @@
                 <a:ea typeface="Inter" pitchFamily="34" charset="-122"/>
                 <a:cs typeface="Inter" pitchFamily="34" charset="-120"/>
               </a:rPr>
-              <a:t>What feedback prompt could lead to a next move?</a:t>
+              <a:t>What feedback prompt could lead students to complete or revise CER?</a:t>
             </a:r>
             <a:endParaRPr lang="en-US" sz="2100" dirty="0"/>
           </a:p>
@@ -5691,7 +5369,7 @@
         <p:spPr>
           <a:xfrm>
             <a:off x="5181600" y="3683000"/>
-            <a:ext cx="6350000" cy="342900"/>
+            <a:ext cx="8001000" cy="342900"/>
           </a:xfrm>
           <a:prstGeom prst="rect">
             <a:avLst/>
@@ -5715,7 +5393,7 @@
                 <a:ea typeface="Inter" pitchFamily="34" charset="-122"/>
                 <a:cs typeface="Inter" pitchFamily="34" charset="-120"/>
               </a:rPr>
-              <a:t>2. ANTICIPATE ONE LIKELY STUDENT RESPONSE</a:t>
+              <a:t>2. ANTICIPATE + JUDGE A CER RESPONSE</a:t>
             </a:r>
             <a:endParaRPr lang="en-US" sz="2400" dirty="0"/>
           </a:p>
@@ -5754,7 +5432,7 @@
                 <a:ea typeface="Inter" pitchFamily="34" charset="-122"/>
                 <a:cs typeface="Inter" pitchFamily="34" charset="-120"/>
               </a:rPr>
-              <a:t>Name what may be partial, missing, or confused. Use CUBS/CER only where it helps students access the task.</a:t>
+              <a:t>Name what a complete response meeting the standard shows and what may be partial, missing, or confused.</a:t>
             </a:r>
             <a:endParaRPr lang="en-US" sz="2100" dirty="0"/>
           </a:p>
@@ -5794,7 +5472,7 @@
         <p:spPr>
           <a:xfrm>
             <a:off x="5181600" y="5524500"/>
-            <a:ext cx="6858000" cy="342900"/>
+            <a:ext cx="7874000" cy="342900"/>
           </a:xfrm>
           <a:prstGeom prst="rect">
             <a:avLst/>
@@ -5818,7 +5496,7 @@
                 <a:ea typeface="Inter" pitchFamily="34" charset="-122"/>
                 <a:cs typeface="Inter" pitchFamily="34" charset="-120"/>
               </a:rPr>
-              <a:t>3. PLAN FEEDBACK + STUDENT ACTION</a:t>
+              <a:t>3. PLAN FEEDBACK → COMPLETE OR REVISE CER</a:t>
             </a:r>
             <a:endParaRPr lang="en-US" sz="2400" dirty="0"/>
           </a:p>
@@ -5860,7 +5538,7 @@
                 <a:ea typeface="Inter" pitchFamily="34" charset="-122"/>
                 <a:cs typeface="Inter" pitchFamily="34" charset="-120"/>
               </a:rPr>
-              <a:t>Write one prompt that sends students back to the evidence or science idea, then name the visible action: revise, annotate, add, explain, compare, or correct.</a:t>
+              <a:t>Write one prompt that sends students back to the evidence or science idea, then name the visible action: identify, complete, revise, add, explain, compare, or correct.</a:t>
             </a:r>
             <a:endParaRPr lang="en-US" sz="2100" dirty="0"/>
           </a:p>
@@ -6140,7 +5818,7 @@
                 <a:ea typeface="Inter" pitchFamily="34" charset="-122"/>
                 <a:cs typeface="Inter" pitchFamily="34" charset="-120"/>
               </a:rPr>
-              <a:t>the upcoming writing benchmark/task and source or evidence;</a:t>
+              <a:t>the upcoming writing benchmark/task and annotated source or evidence;</a:t>
             </a:r>
             <a:endParaRPr lang="en-US" sz="2300" dirty="0"/>
           </a:p>
@@ -6164,7 +5842,7 @@
                 <a:ea typeface="Inter" pitchFamily="34" charset="-122"/>
                 <a:cs typeface="Inter" pitchFamily="34" charset="-120"/>
               </a:rPr>
-              <a:t>one priority criterion and an anticipated partial response;</a:t>
+              <a:t>one complete CER response that meets the bar and one anticipated partial response;</a:t>
             </a:r>
             <a:endParaRPr lang="en-US" sz="2300" dirty="0"/>
           </a:p>

</xml_diff>

<commit_message>
Revise Oct. 26–30 science literacy materials
Replace all four agendas and editable decks; add the Biology HS-LS2-1 benchmark resource. The sequence now moves from teacher-as-student benchmark analysis to lesson planning, CUBS/CER strategy instruction, completed student writing, written feedback, and a standard-mastery next step.
</commit_message>
<xml_diff>
--- a/assets/plc/2026-10-26_Lesson_Internalization_Analyze_Science_Articles_and_Responses_CUBS_CER.pptx
+++ b/assets/plc/2026-10-26_Lesson_Internalization_Analyze_Science_Articles_and_Responses_CUBS_CER.pptx
@@ -1397,7 +1397,7 @@
     <p:bg>
       <p:bgPr>
         <a:solidFill>
-          <a:srgbClr val="202124"/>
+          <a:srgbClr val="FFFFFF"/>
         </a:solidFill>
       </p:bgPr>
     </p:bg>
@@ -1424,7 +1424,27 @@
         <p:spPr>
           <a:xfrm>
             <a:off x="0" y="0"/>
-            <a:ext cx="355600" cy="9144000"/>
+            <a:ext cx="16256000" cy="1168400"/>
+          </a:xfrm>
+          <a:prstGeom prst="rect">
+            <a:avLst/>
+          </a:prstGeom>
+          <a:solidFill>
+            <a:srgbClr val="202124"/>
+          </a:solidFill>
+          <a:ln/>
+        </p:spPr>
+      </p:sp>
+      <p:sp>
+        <p:nvSpPr>
+          <p:cNvPr id="3" name="cover-shape-2"/>
+          <p:cNvSpPr/>
+          <p:nvPr/>
+        </p:nvSpPr>
+        <p:spPr>
+          <a:xfrm>
+            <a:off x="0" y="1168400"/>
+            <a:ext cx="16256000" cy="101600"/>
           </a:xfrm>
           <a:prstGeom prst="rect">
             <a:avLst/>
@@ -1437,34 +1457,14 @@
       </p:sp>
       <p:sp>
         <p:nvSpPr>
-          <p:cNvPr id="3" name="cover-shape-2"/>
-          <p:cNvSpPr/>
-          <p:nvPr/>
-        </p:nvSpPr>
-        <p:spPr>
-          <a:xfrm>
-            <a:off x="889000" y="1168400"/>
-            <a:ext cx="1905000" cy="101600"/>
-          </a:xfrm>
-          <a:prstGeom prst="rect">
-            <a:avLst/>
-          </a:prstGeom>
-          <a:solidFill>
-            <a:srgbClr val="C41220"/>
-          </a:solidFill>
-          <a:ln/>
-        </p:spPr>
-      </p:sp>
-      <p:sp>
-        <p:nvSpPr>
-          <p:cNvPr id="4" name="cover-kicker"/>
-          <p:cNvSpPr/>
-          <p:nvPr/>
-        </p:nvSpPr>
-        <p:spPr>
-          <a:xfrm>
-            <a:off x="889000" y="1600200"/>
-            <a:ext cx="12065000" cy="355600"/>
+          <p:cNvPr id="4" name="kicker"/>
+          <p:cNvSpPr/>
+          <p:nvPr/>
+        </p:nvSpPr>
+        <p:spPr>
+          <a:xfrm>
+            <a:off x="736600" y="381000"/>
+            <a:ext cx="11430000" cy="279400"/>
           </a:xfrm>
           <a:prstGeom prst="rect">
             <a:avLst/>
@@ -1480,9 +1480,9 @@
               <a:buNone/>
             </a:pPr>
             <a:r>
-              <a:rPr lang="en-US" altLang="en-US" sz="1700" dirty="0">
-                <a:solidFill>
-                  <a:srgbClr val="D1D5DB"/>
+              <a:rPr lang="en-US" altLang="en-US" sz="1600" dirty="0">
+                <a:solidFill>
+                  <a:srgbClr val="F1F3F4"/>
                 </a:solidFill>
                 <a:latin typeface="Inter" pitchFamily="34" charset="0"/>
                 <a:ea typeface="Inter" pitchFamily="34" charset="-122"/>
@@ -1490,20 +1490,20 @@
               </a:rPr>
               <a:t>SCIENCE DEPARTMENT PLC  •  MONDAY, OCTOBER 26, 2026  •  41 MINUTES</a:t>
             </a:r>
-            <a:endParaRPr lang="en-US" sz="1700" dirty="0"/>
-          </a:p>
-        </p:txBody>
-      </p:sp>
-      <p:sp>
-        <p:nvSpPr>
-          <p:cNvPr id="5" name="cover-title"/>
-          <p:cNvSpPr/>
-          <p:nvPr/>
-        </p:nvSpPr>
-        <p:spPr>
-          <a:xfrm>
-            <a:off x="889000" y="2387600"/>
-            <a:ext cx="13335000" cy="1625600"/>
+            <a:endParaRPr lang="en-US" sz="1600" dirty="0"/>
+          </a:p>
+        </p:txBody>
+      </p:sp>
+      <p:sp>
+        <p:nvSpPr>
+          <p:cNvPr id="5" name="title"/>
+          <p:cNvSpPr/>
+          <p:nvPr/>
+        </p:nvSpPr>
+        <p:spPr>
+          <a:xfrm>
+            <a:off x="736600" y="1917700"/>
+            <a:ext cx="12319000" cy="1473200"/>
           </a:xfrm>
           <a:prstGeom prst="rect">
             <a:avLst/>
@@ -1526,13 +1526,13 @@
             <a:r>
               <a:rPr lang="en-US" altLang="en-US" sz="4500" dirty="0">
                 <a:solidFill>
-                  <a:srgbClr val="FFFFFF"/>
-                </a:solidFill>
-                <a:latin typeface="Inter" pitchFamily="34" charset="0"/>
-                <a:ea typeface="Inter" pitchFamily="34" charset="-122"/>
-                <a:cs typeface="Inter" pitchFamily="34" charset="-120"/>
-              </a:rPr>
-              <a:t>Writing Benchmark → Anticipated Student Thinking</a:t>
+                  <a:srgbClr val="202124"/>
+                </a:solidFill>
+                <a:latin typeface="Inter" pitchFamily="34" charset="0"/>
+                <a:ea typeface="Inter" pitchFamily="34" charset="-122"/>
+                <a:cs typeface="Inter" pitchFamily="34" charset="-120"/>
+              </a:rPr>
+              <a:t>Experience the Writing Benchmark</a:t>
             </a:r>
             <a:endParaRPr lang="en-US" sz="4500" dirty="0"/>
           </a:p>
@@ -1546,13 +1546,13 @@
             <a:r>
               <a:rPr lang="en-US" altLang="en-US" sz="4500" dirty="0">
                 <a:solidFill>
-                  <a:srgbClr val="FFFFFF"/>
-                </a:solidFill>
-                <a:latin typeface="Inter" pitchFamily="34" charset="0"/>
-                <a:ea typeface="Inter" pitchFamily="34" charset="-122"/>
-                <a:cs typeface="Inter" pitchFamily="34" charset="-120"/>
-              </a:rPr>
-              <a:t>→ Feedback + Student Action</a:t>
+                  <a:srgbClr val="202124"/>
+                </a:solidFill>
+                <a:latin typeface="Inter" pitchFamily="34" charset="0"/>
+                <a:ea typeface="Inter" pitchFamily="34" charset="-122"/>
+                <a:cs typeface="Inter" pitchFamily="34" charset="-120"/>
+              </a:rPr>
+              <a:t>as a Student</a:t>
             </a:r>
             <a:endParaRPr lang="en-US" sz="4500" dirty="0"/>
           </a:p>
@@ -1560,21 +1560,66 @@
       </p:sp>
       <p:sp>
         <p:nvSpPr>
-          <p:cNvPr id="6" name="cover-shape-5"/>
-          <p:cNvSpPr/>
-          <p:nvPr/>
-        </p:nvSpPr>
-        <p:spPr>
-          <a:xfrm>
-            <a:off x="889000" y="4597400"/>
-            <a:ext cx="12954000" cy="9144"/>
-          </a:xfrm>
-          <a:prstGeom prst="line">
-            <a:avLst/>
-          </a:prstGeom>
-          <a:ln w="12700">
+          <p:cNvPr id="6" name="subtitle"/>
+          <p:cNvSpPr/>
+          <p:nvPr/>
+        </p:nvSpPr>
+        <p:spPr>
+          <a:xfrm>
+            <a:off x="736600" y="3797300"/>
+            <a:ext cx="10820400" cy="1092200"/>
+          </a:xfrm>
+          <a:prstGeom prst="rect">
+            <a:avLst/>
+          </a:prstGeom>
+          <a:noFill/>
+          <a:ln/>
+        </p:spPr>
+        <p:txBody>
+          <a:bodyPr wrap="square" lIns="0" tIns="0" rIns="0" bIns="0" rtlCol="0" anchor="t"/>
+          <a:lstStyle/>
+          <a:p>
+            <a:pPr algn="l" indent="0" marL="0">
+              <a:lnSpc>
+                <a:spcPts val="3050"/>
+              </a:lnSpc>
+              <a:buNone/>
+            </a:pPr>
+            <a:r>
+              <a:rPr lang="en-US" altLang="en-US" sz="2500" dirty="0">
+                <a:solidFill>
+                  <a:srgbClr val="3C4043"/>
+                </a:solidFill>
+                <a:latin typeface="Inter" pitchFamily="34" charset="0"/>
+                <a:ea typeface="Inter" pitchFamily="34" charset="-122"/>
+                <a:cs typeface="Inter" pitchFamily="34" charset="-120"/>
+              </a:rPr>
+              <a:t>Use the attached Biology HS-LS2-1 benchmark as a shared model: complete it, analyze the texts and visuals, color-code the CER, and anticipate how students may respond.</a:t>
+            </a:r>
+            <a:endParaRPr lang="en-US" sz="2500" dirty="0"/>
+          </a:p>
+        </p:txBody>
+      </p:sp>
+      <p:sp>
+        <p:nvSpPr>
+          <p:cNvPr id="7" name="cover-shape-6"/>
+          <p:cNvSpPr/>
+          <p:nvPr/>
+        </p:nvSpPr>
+        <p:spPr>
+          <a:xfrm>
+            <a:off x="12242800" y="2057400"/>
+            <a:ext cx="3200400" cy="2984500"/>
+          </a:xfrm>
+          <a:prstGeom prst="rect">
+            <a:avLst/>
+          </a:prstGeom>
+          <a:solidFill>
+            <a:srgbClr val="FCE8EA"/>
+          </a:solidFill>
+          <a:ln w="25400">
             <a:solidFill>
-              <a:srgbClr val="72777D"/>
+              <a:srgbClr val="C41220"/>
             </a:solidFill>
             <a:prstDash val="solid"/>
           </a:ln>
@@ -1582,14 +1627,120 @@
       </p:sp>
       <p:sp>
         <p:nvSpPr>
-          <p:cNvPr id="7" name="cover-subtitle"/>
-          <p:cNvSpPr/>
-          <p:nvPr/>
-        </p:nvSpPr>
-        <p:spPr>
-          <a:xfrm>
-            <a:off x="889000" y="5016500"/>
-            <a:ext cx="10668000" cy="939800"/>
+          <p:cNvPr id="8" name="outcome-label"/>
+          <p:cNvSpPr/>
+          <p:nvPr/>
+        </p:nvSpPr>
+        <p:spPr>
+          <a:xfrm>
+            <a:off x="12573000" y="2438400"/>
+            <a:ext cx="2540000" cy="254000"/>
+          </a:xfrm>
+          <a:prstGeom prst="rect">
+            <a:avLst/>
+          </a:prstGeom>
+          <a:noFill/>
+          <a:ln/>
+        </p:spPr>
+        <p:txBody>
+          <a:bodyPr wrap="square" lIns="0" tIns="0" rIns="0" bIns="0" rtlCol="0" anchor="t"/>
+          <a:lstStyle/>
+          <a:p>
+            <a:pPr algn="ctr" indent="0" marL="0">
+              <a:buNone/>
+            </a:pPr>
+            <a:r>
+              <a:rPr lang="en-US" altLang="en-US" sz="1400" dirty="0">
+                <a:solidFill>
+                  <a:srgbClr val="C41220"/>
+                </a:solidFill>
+                <a:latin typeface="Inter" pitchFamily="34" charset="0"/>
+                <a:ea typeface="Inter" pitchFamily="34" charset="-122"/>
+                <a:cs typeface="Inter" pitchFamily="34" charset="-120"/>
+              </a:rPr>
+              <a:t>TODAY’S OUTCOME</a:t>
+            </a:r>
+            <a:endParaRPr lang="en-US" sz="1400" dirty="0"/>
+          </a:p>
+        </p:txBody>
+      </p:sp>
+      <p:sp>
+        <p:nvSpPr>
+          <p:cNvPr id="9" name="outcome"/>
+          <p:cNvSpPr/>
+          <p:nvPr/>
+        </p:nvSpPr>
+        <p:spPr>
+          <a:xfrm>
+            <a:off x="12547600" y="3035300"/>
+            <a:ext cx="2590800" cy="1358900"/>
+          </a:xfrm>
+          <a:prstGeom prst="rect">
+            <a:avLst/>
+          </a:prstGeom>
+          <a:noFill/>
+          <a:ln/>
+        </p:spPr>
+        <p:txBody>
+          <a:bodyPr wrap="square" lIns="0" tIns="0" rIns="0" bIns="0" rtlCol="0" anchor="ctr"/>
+          <a:lstStyle/>
+          <a:p>
+            <a:pPr algn="ctr" indent="0" marL="0">
+              <a:lnSpc>
+                <a:spcPts val="2400"/>
+              </a:lnSpc>
+              <a:buNone/>
+            </a:pPr>
+            <a:r>
+              <a:rPr lang="en-US" altLang="en-US" sz="2000" dirty="0">
+                <a:solidFill>
+                  <a:srgbClr val="3C4043"/>
+                </a:solidFill>
+                <a:latin typeface="Inter" pitchFamily="34" charset="0"/>
+                <a:ea typeface="Inter" pitchFamily="34" charset="-122"/>
+                <a:cs typeface="Inter" pitchFamily="34" charset="-120"/>
+              </a:rPr>
+              <a:t>A completed benchmark, task analysis, color-coded CER, and anticipated student responses.</a:t>
+            </a:r>
+            <a:endParaRPr lang="en-US" sz="2000" dirty="0"/>
+          </a:p>
+        </p:txBody>
+      </p:sp>
+      <p:sp>
+        <p:nvSpPr>
+          <p:cNvPr id="10" name="cover-shape-9"/>
+          <p:cNvSpPr/>
+          <p:nvPr/>
+        </p:nvSpPr>
+        <p:spPr>
+          <a:xfrm>
+            <a:off x="736600" y="5842000"/>
+            <a:ext cx="14706600" cy="1422400"/>
+          </a:xfrm>
+          <a:prstGeom prst="rect">
+            <a:avLst/>
+          </a:prstGeom>
+          <a:solidFill>
+            <a:srgbClr val="F3F4F6"/>
+          </a:solidFill>
+          <a:ln w="12700">
+            <a:solidFill>
+              <a:srgbClr val="D1D5DB"/>
+            </a:solidFill>
+            <a:prstDash val="solid"/>
+          </a:ln>
+        </p:spPr>
+      </p:sp>
+      <p:sp>
+        <p:nvSpPr>
+          <p:cNvPr id="11" name="benchmark-anchor"/>
+          <p:cNvSpPr/>
+          <p:nvPr/>
+        </p:nvSpPr>
+        <p:spPr>
+          <a:xfrm>
+            <a:off x="1117600" y="6172200"/>
+            <a:ext cx="13919200" cy="787400"/>
           </a:xfrm>
           <a:prstGeom prst="rect">
             <a:avLst/>
@@ -1603,55 +1754,46 @@
           <a:p>
             <a:pPr algn="l" indent="0" marL="0">
               <a:lnSpc>
-                <a:spcPts val="2950"/>
+                <a:spcPts val="2684"/>
               </a:lnSpc>
               <a:buNone/>
             </a:pPr>
             <a:r>
-              <a:rPr lang="en-US" altLang="en-US" sz="2500" dirty="0">
-                <a:solidFill>
-                  <a:srgbClr val="F1F3F4"/>
-                </a:solidFill>
-                <a:latin typeface="Inter" pitchFamily="34" charset="0"/>
-                <a:ea typeface="Inter" pitchFamily="34" charset="-122"/>
-                <a:cs typeface="Inter" pitchFamily="34" charset="-120"/>
-              </a:rPr>
-              <a:t>Use one upcoming standards-aligned science writing task to anticipate responses and plan feedback that helps students revise or act.</a:t>
-            </a:r>
-            <a:endParaRPr lang="en-US" sz="2500" dirty="0"/>
-          </a:p>
-        </p:txBody>
-      </p:sp>
-      <p:sp>
-        <p:nvSpPr>
-          <p:cNvPr id="8" name="cover-shape-7"/>
-          <p:cNvSpPr/>
-          <p:nvPr/>
-        </p:nvSpPr>
-        <p:spPr>
-          <a:xfrm>
-            <a:off x="11912600" y="5308600"/>
-            <a:ext cx="3098800" cy="1727200"/>
-          </a:xfrm>
-          <a:prstGeom prst="rect">
-            <a:avLst/>
-          </a:prstGeom>
-          <a:solidFill>
-            <a:srgbClr val="C41220"/>
-          </a:solidFill>
-          <a:ln/>
-        </p:spPr>
-      </p:sp>
-      <p:sp>
-        <p:nvSpPr>
-          <p:cNvPr id="9" name="cover-outcome-label"/>
-          <p:cNvSpPr/>
-          <p:nvPr/>
-        </p:nvSpPr>
-        <p:spPr>
-          <a:xfrm>
-            <a:off x="12166600" y="5588000"/>
-            <a:ext cx="2590800" cy="228600"/>
+              <a:rPr lang="en-US" altLang="en-US" sz="2200" b="1" dirty="0">
+                <a:solidFill>
+                  <a:srgbClr val="C41220"/>
+                </a:solidFill>
+                <a:latin typeface="Inter" pitchFamily="34" charset="0"/>
+                <a:ea typeface="Inter" pitchFamily="34" charset="-122"/>
+                <a:cs typeface="Inter" pitchFamily="34" charset="-120"/>
+              </a:rPr>
+              <a:t>Shared model:</a:t>
+            </a:r>
+            <a:r>
+              <a:rPr lang="en-US" altLang="en-US" sz="2200" dirty="0">
+                <a:solidFill>
+                  <a:srgbClr val="3C4043"/>
+                </a:solidFill>
+                <a:latin typeface="Inter" pitchFamily="34" charset="0"/>
+                <a:ea typeface="Inter" pitchFamily="34" charset="-122"/>
+                <a:cs typeface="Inter" pitchFamily="34" charset="-120"/>
+              </a:rPr>
+              <a:t> Biology Benchmark #1 asks students to use a fruit-fly population graph and food web to explain carrying capacity and write a Claim–Evidence–Reasoning response.</a:t>
+            </a:r>
+            <a:endParaRPr lang="en-US" sz="2200" dirty="0"/>
+          </a:p>
+        </p:txBody>
+      </p:sp>
+      <p:sp>
+        <p:nvSpPr>
+          <p:cNvPr id="12" name="footer"/>
+          <p:cNvSpPr/>
+          <p:nvPr/>
+        </p:nvSpPr>
+        <p:spPr>
+          <a:xfrm>
+            <a:off x="736600" y="7975600"/>
+            <a:ext cx="12827000" cy="431800"/>
           </a:xfrm>
           <a:prstGeom prst="rect">
             <a:avLst/>
@@ -1660,22 +1802,72 @@
           <a:ln/>
         </p:spPr>
         <p:txBody>
-          <a:bodyPr wrap="none" lIns="0" tIns="0" rIns="0" bIns="0" rtlCol="0" anchor="t"/>
-          <a:lstStyle/>
-          <a:p>
-            <a:pPr algn="ctr" indent="0" marL="0">
+          <a:bodyPr wrap="square" lIns="0" tIns="0" rIns="0" bIns="0" rtlCol="0" anchor="t"/>
+          <a:lstStyle/>
+          <a:p>
+            <a:pPr algn="l" indent="0" marL="0">
+              <a:buNone/>
+            </a:pPr>
+            <a:r>
+              <a:rPr lang="en-US" altLang="en-US" sz="2100" b="1" dirty="0">
+                <a:solidFill>
+                  <a:srgbClr val="C41220"/>
+                </a:solidFill>
+                <a:latin typeface="Inter" pitchFamily="34" charset="0"/>
+                <a:ea typeface="Inter" pitchFamily="34" charset="-122"/>
+                <a:cs typeface="Inter" pitchFamily="34" charset="-120"/>
+              </a:rPr>
+              <a:t>Lesson Internalization Tool:</a:t>
+            </a:r>
+            <a:r>
+              <a:rPr lang="en-US" altLang="en-US" sz="2100" dirty="0">
+                <a:solidFill>
+                  <a:srgbClr val="3C4043"/>
+                </a:solidFill>
+                <a:latin typeface="Inter" pitchFamily="34" charset="0"/>
+                <a:ea typeface="Inter" pitchFamily="34" charset="-122"/>
+                <a:cs typeface="Inter" pitchFamily="34" charset="-120"/>
+              </a:rPr>
+              <a:t> Every Day Questions 1, 3, and 4; Team Deep Dive Steps 2–4.</a:t>
+            </a:r>
+            <a:endParaRPr lang="en-US" sz="2100" dirty="0"/>
+          </a:p>
+        </p:txBody>
+      </p:sp>
+      <p:sp>
+        <p:nvSpPr>
+          <p:cNvPr id="13" name="page"/>
+          <p:cNvSpPr/>
+          <p:nvPr/>
+        </p:nvSpPr>
+        <p:spPr>
+          <a:xfrm>
+            <a:off x="14732000" y="8432800"/>
+            <a:ext cx="736600" cy="228600"/>
+          </a:xfrm>
+          <a:prstGeom prst="rect">
+            <a:avLst/>
+          </a:prstGeom>
+          <a:noFill/>
+          <a:ln/>
+        </p:spPr>
+        <p:txBody>
+          <a:bodyPr wrap="square" lIns="0" tIns="0" rIns="0" bIns="0" rtlCol="0" anchor="t"/>
+          <a:lstStyle/>
+          <a:p>
+            <a:pPr algn="r" indent="0" marL="0">
               <a:buNone/>
             </a:pPr>
             <a:r>
               <a:rPr lang="en-US" altLang="en-US" sz="1300" dirty="0">
                 <a:solidFill>
-                  <a:srgbClr val="FDECEC"/>
-                </a:solidFill>
-                <a:latin typeface="Inter" pitchFamily="34" charset="0"/>
-                <a:ea typeface="Inter" pitchFamily="34" charset="-122"/>
-                <a:cs typeface="Inter" pitchFamily="34" charset="-120"/>
-              </a:rPr>
-              <a:t>TODAY’S OUTCOME</a:t>
+                  <a:srgbClr val="6B7280"/>
+                </a:solidFill>
+                <a:latin typeface="Inter" pitchFamily="34" charset="0"/>
+                <a:ea typeface="Inter" pitchFamily="34" charset="-122"/>
+                <a:cs typeface="Inter" pitchFamily="34" charset="-120"/>
+              </a:rPr>
+              <a:t>01</a:t>
             </a:r>
             <a:endParaRPr lang="en-US" sz="1300" dirty="0"/>
           </a:p>
@@ -1683,141 +1875,7 @@
       </p:sp>
       <p:sp>
         <p:nvSpPr>
-          <p:cNvPr id="10" name="cover-outcome"/>
-          <p:cNvSpPr/>
-          <p:nvPr/>
-        </p:nvSpPr>
-        <p:spPr>
-          <a:xfrm>
-            <a:off x="12141200" y="5969000"/>
-            <a:ext cx="2641600" cy="762000"/>
-          </a:xfrm>
-          <a:prstGeom prst="rect">
-            <a:avLst/>
-          </a:prstGeom>
-          <a:noFill/>
-          <a:ln/>
-        </p:spPr>
-        <p:txBody>
-          <a:bodyPr wrap="square" lIns="0" tIns="0" rIns="0" bIns="0" rtlCol="0" anchor="t"/>
-          <a:lstStyle/>
-          <a:p>
-            <a:pPr algn="ctr" indent="0" marL="0">
-              <a:lnSpc>
-                <a:spcPts val="1972"/>
-              </a:lnSpc>
-              <a:buNone/>
-            </a:pPr>
-            <a:r>
-              <a:rPr lang="en-US" altLang="en-US" sz="1700" dirty="0">
-                <a:solidFill>
-                  <a:srgbClr val="FFFFFF"/>
-                </a:solidFill>
-                <a:latin typeface="Inter" pitchFamily="34" charset="0"/>
-                <a:ea typeface="Inter" pitchFamily="34" charset="-122"/>
-                <a:cs typeface="Inter" pitchFamily="34" charset="-120"/>
-              </a:rPr>
-              <a:t>One task, one anticipated need, one feedback prompt, and one student action.</a:t>
-            </a:r>
-            <a:endParaRPr lang="en-US" sz="1700" dirty="0"/>
-          </a:p>
-        </p:txBody>
-      </p:sp>
-      <p:sp>
-        <p:nvSpPr>
-          <p:cNvPr id="11" name="cover-footer"/>
-          <p:cNvSpPr/>
-          <p:nvPr/>
-        </p:nvSpPr>
-        <p:spPr>
-          <a:xfrm>
-            <a:off x="889000" y="7493000"/>
-            <a:ext cx="11684000" cy="533400"/>
-          </a:xfrm>
-          <a:prstGeom prst="rect">
-            <a:avLst/>
-          </a:prstGeom>
-          <a:noFill/>
-          <a:ln/>
-        </p:spPr>
-        <p:txBody>
-          <a:bodyPr wrap="square" lIns="0" tIns="0" rIns="0" bIns="0" rtlCol="0" anchor="t"/>
-          <a:lstStyle/>
-          <a:p>
-            <a:pPr algn="l" indent="0" marL="0">
-              <a:lnSpc>
-                <a:spcPts val="2596"/>
-              </a:lnSpc>
-              <a:buNone/>
-            </a:pPr>
-            <a:r>
-              <a:rPr lang="en-US" altLang="en-US" sz="2200" b="1" dirty="0">
-                <a:solidFill>
-                  <a:srgbClr val="F6B4BA"/>
-                </a:solidFill>
-                <a:latin typeface="Inter" pitchFamily="34" charset="0"/>
-                <a:ea typeface="Inter" pitchFamily="34" charset="-122"/>
-                <a:cs typeface="Inter" pitchFamily="34" charset="-120"/>
-              </a:rPr>
-              <a:t>Lesson Internalization Tool:</a:t>
-            </a:r>
-            <a:r>
-              <a:rPr lang="en-US" altLang="en-US" sz="2200" dirty="0">
-                <a:solidFill>
-                  <a:srgbClr val="D1D5DB"/>
-                </a:solidFill>
-                <a:latin typeface="Inter" pitchFamily="34" charset="0"/>
-                <a:ea typeface="Inter" pitchFamily="34" charset="-122"/>
-                <a:cs typeface="Inter" pitchFamily="34" charset="-120"/>
-              </a:rPr>
-              <a:t> Every Day Questions 1, 3, and 4; Team Deep Dive Steps 2–4.</a:t>
-            </a:r>
-            <a:endParaRPr lang="en-US" sz="2200" dirty="0"/>
-          </a:p>
-        </p:txBody>
-      </p:sp>
-      <p:sp>
-        <p:nvSpPr>
-          <p:cNvPr id="12" name="page"/>
-          <p:cNvSpPr/>
-          <p:nvPr/>
-        </p:nvSpPr>
-        <p:spPr>
-          <a:xfrm>
-            <a:off x="14478000" y="8407400"/>
-            <a:ext cx="762000" cy="228600"/>
-          </a:xfrm>
-          <a:prstGeom prst="rect">
-            <a:avLst/>
-          </a:prstGeom>
-          <a:noFill/>
-          <a:ln/>
-        </p:spPr>
-        <p:txBody>
-          <a:bodyPr wrap="square" lIns="0" tIns="0" rIns="0" bIns="0" rtlCol="0" anchor="t"/>
-          <a:lstStyle/>
-          <a:p>
-            <a:pPr algn="r" indent="0" marL="0">
-              <a:buNone/>
-            </a:pPr>
-            <a:r>
-              <a:rPr lang="en-US" altLang="en-US" sz="1300" dirty="0">
-                <a:solidFill>
-                  <a:srgbClr val="D1D5DB"/>
-                </a:solidFill>
-                <a:latin typeface="Inter" pitchFamily="34" charset="0"/>
-                <a:ea typeface="Inter" pitchFamily="34" charset="-122"/>
-                <a:cs typeface="Inter" pitchFamily="34" charset="-120"/>
-              </a:rPr>
-              <a:t>01</a:t>
-            </a:r>
-            <a:endParaRPr lang="en-US" sz="1300" dirty="0"/>
-          </a:p>
-        </p:txBody>
-      </p:sp>
-      <p:sp>
-        <p:nvSpPr>
-          <p:cNvPr id="13" name="cover-shape-12"/>
+          <p:cNvPr id="14" name="cover-shape-13"/>
           <p:cNvSpPr/>
           <p:nvPr/>
         </p:nvSpPr>
@@ -1920,7 +1978,7 @@
                 <a:ea typeface="Inter" pitchFamily="34" charset="-122"/>
                 <a:cs typeface="Inter" pitchFamily="34" charset="-120"/>
               </a:rPr>
-              <a:t>One Coherent Science Literacy Evidence Cycle</a:t>
+              <a:t>One Benchmark, One Coherent Learning Cycle</a:t>
             </a:r>
             <a:endParaRPr lang="en-US" sz="3000" dirty="0"/>
           </a:p>
@@ -1959,7 +2017,7 @@
                 <a:ea typeface="Inter" pitchFamily="34" charset="-122"/>
                 <a:cs typeface="Inter" pitchFamily="34" charset="-120"/>
               </a:rPr>
-              <a:t>0:00–4:00  •  4 MIN</a:t>
+              <a:t>0:00–3:00  •  3 MIN</a:t>
             </a:r>
             <a:endParaRPr lang="en-US" sz="1600" dirty="0"/>
           </a:p>
@@ -1974,7 +2032,7 @@
         <p:spPr>
           <a:xfrm>
             <a:off x="508000" y="1371600"/>
-            <a:ext cx="14859000" cy="711200"/>
+            <a:ext cx="14859000" cy="685800"/>
           </a:xfrm>
           <a:prstGeom prst="rect">
             <a:avLst/>
@@ -2001,7 +2059,7 @@
                 <a:ea typeface="Inter" pitchFamily="34" charset="-122"/>
                 <a:cs typeface="Inter" pitchFamily="34" charset="-120"/>
               </a:rPr>
-              <a:t>This week stays with the same standards-aligned writing task from planning through evidence review. CUBS and CER make student thinking visible; they do not become a separate initiative.</a:t>
+              <a:t>The Biology benchmark is a shared model. Every course team applies the same instructional moves to an appropriate standard, article, data display, investigation, or constructed-response task.</a:t>
             </a:r>
             <a:endParaRPr lang="en-US" sz="2300" dirty="0"/>
           </a:p>
@@ -2015,8 +2073,8 @@
         </p:nvSpPr>
         <p:spPr>
           <a:xfrm>
-            <a:off x="508000" y="2768600"/>
-            <a:ext cx="2286000" cy="3111500"/>
+            <a:off x="508000" y="2717800"/>
+            <a:ext cx="2667000" cy="3238500"/>
           </a:xfrm>
           <a:prstGeom prst="rect">
             <a:avLst/>
@@ -2040,8 +2098,8 @@
         </p:nvSpPr>
         <p:spPr>
           <a:xfrm>
-            <a:off x="736600" y="3098800"/>
-            <a:ext cx="1828800" cy="2133600"/>
+            <a:off x="762000" y="3048000"/>
+            <a:ext cx="2159000" cy="2374900"/>
           </a:xfrm>
           <a:prstGeom prst="rect">
             <a:avLst/>
@@ -2070,35 +2128,12 @@
               </a:rPr>
               <a:t>MONDAY</a:t>
             </a:r>
-            <a:endParaRPr lang="en-US" sz="1800" dirty="0"/>
+            <a:endParaRPr lang="en-US" sz="1900" dirty="0"/>
           </a:p>
           <a:p>
             <a:pPr algn="l" indent="0" marL="0">
               <a:lnSpc>
-                <a:spcPts val="2596"/>
-              </a:lnSpc>
-              <a:spcBef>
-                <a:spcPts val="1200"/>
-              </a:spcBef>
-              <a:buNone/>
-            </a:pPr>
-            <a:r>
-              <a:rPr lang="en-US" altLang="en-US" sz="2200" b="1" dirty="0">
-                <a:solidFill>
-                  <a:srgbClr val="3C4043"/>
-                </a:solidFill>
-                <a:latin typeface="Inter" pitchFamily="34" charset="0"/>
-                <a:ea typeface="Inter" pitchFamily="34" charset="-122"/>
-                <a:cs typeface="Inter" pitchFamily="34" charset="-120"/>
-              </a:rPr>
-              <a:t>Writing benchmark</a:t>
-            </a:r>
-            <a:endParaRPr lang="en-US" sz="1800" dirty="0"/>
-          </a:p>
-          <a:p>
-            <a:pPr algn="l" indent="0" marL="0">
-              <a:lnSpc>
-                <a:spcPts val="2124"/>
+                <a:spcPts val="2714"/>
               </a:lnSpc>
               <a:spcBef>
                 <a:spcPts val="1000"/>
@@ -2106,7 +2141,7 @@
               <a:buNone/>
             </a:pPr>
             <a:r>
-              <a:rPr lang="en-US" altLang="en-US" sz="1800" dirty="0">
+              <a:rPr lang="en-US" altLang="en-US" sz="2300" b="1" dirty="0">
                 <a:solidFill>
                   <a:srgbClr val="3C4043"/>
                 </a:solidFill>
@@ -2114,9 +2149,32 @@
                 <a:ea typeface="Inter" pitchFamily="34" charset="-122"/>
                 <a:cs typeface="Inter" pitchFamily="34" charset="-120"/>
               </a:rPr>
-              <a:t>Task, source, criteria, and anticipated responses.</a:t>
-            </a:r>
-            <a:endParaRPr lang="en-US" sz="1800" dirty="0"/>
+              <a:t>Experience + analyze</a:t>
+            </a:r>
+            <a:endParaRPr lang="en-US" sz="1900" dirty="0"/>
+          </a:p>
+          <a:p>
+            <a:pPr algn="l" indent="0" marL="0">
+              <a:lnSpc>
+                <a:spcPts val="2242"/>
+              </a:lnSpc>
+              <a:spcBef>
+                <a:spcPts val="1000"/>
+              </a:spcBef>
+              <a:buNone/>
+            </a:pPr>
+            <a:r>
+              <a:rPr lang="en-US" altLang="en-US" sz="1900" dirty="0">
+                <a:solidFill>
+                  <a:srgbClr val="3C4043"/>
+                </a:solidFill>
+                <a:latin typeface="Inter" pitchFamily="34" charset="0"/>
+                <a:ea typeface="Inter" pitchFamily="34" charset="-122"/>
+                <a:cs typeface="Inter" pitchFamily="34" charset="-120"/>
+              </a:rPr>
+              <a:t>Complete the benchmark, annotate sources, color-code CER, and anticipate responses.</a:t>
+            </a:r>
+            <a:endParaRPr lang="en-US" sz="1900" dirty="0"/>
           </a:p>
         </p:txBody>
       </p:sp>
@@ -2128,8 +2186,8 @@
         </p:nvSpPr>
         <p:spPr>
           <a:xfrm>
-            <a:off x="2870200" y="4038600"/>
-            <a:ext cx="457200" cy="533400"/>
+            <a:off x="3225800" y="4127500"/>
+            <a:ext cx="431800" cy="533400"/>
           </a:xfrm>
           <a:prstGeom prst="rect">
             <a:avLst/>
@@ -2145,7 +2203,7 @@
               <a:buNone/>
             </a:pPr>
             <a:r>
-              <a:rPr lang="en-US" altLang="en-US" sz="3200" dirty="0">
+              <a:rPr lang="en-US" altLang="en-US" sz="3100" dirty="0">
                 <a:solidFill>
                   <a:srgbClr val="C41220"/>
                 </a:solidFill>
@@ -2155,7 +2213,7 @@
               </a:rPr>
               <a:t>→</a:t>
             </a:r>
-            <a:endParaRPr lang="en-US" sz="3200" dirty="0"/>
+            <a:endParaRPr lang="en-US" sz="3100" dirty="0"/>
           </a:p>
         </p:txBody>
       </p:sp>
@@ -2167,8 +2225,8 @@
         </p:nvSpPr>
         <p:spPr>
           <a:xfrm>
-            <a:off x="3403600" y="2768600"/>
-            <a:ext cx="2286000" cy="3111500"/>
+            <a:off x="3708400" y="2717800"/>
+            <a:ext cx="2667000" cy="3238500"/>
           </a:xfrm>
           <a:prstGeom prst="rect">
             <a:avLst/>
@@ -2192,8 +2250,8 @@
         </p:nvSpPr>
         <p:spPr>
           <a:xfrm>
-            <a:off x="3632200" y="3098800"/>
-            <a:ext cx="1828800" cy="2133600"/>
+            <a:off x="3962400" y="3048000"/>
+            <a:ext cx="2159000" cy="2374900"/>
           </a:xfrm>
           <a:prstGeom prst="rect">
             <a:avLst/>
@@ -2222,35 +2280,12 @@
               </a:rPr>
               <a:t>TUESDAY</a:t>
             </a:r>
-            <a:endParaRPr lang="en-US" sz="1800" dirty="0"/>
+            <a:endParaRPr lang="en-US" sz="1900" dirty="0"/>
           </a:p>
           <a:p>
             <a:pPr algn="l" indent="0" marL="0">
               <a:lnSpc>
-                <a:spcPts val="2596"/>
-              </a:lnSpc>
-              <a:spcBef>
-                <a:spcPts val="1200"/>
-              </a:spcBef>
-              <a:buNone/>
-            </a:pPr>
-            <a:r>
-              <a:rPr lang="en-US" altLang="en-US" sz="2200" b="1" dirty="0">
-                <a:solidFill>
-                  <a:srgbClr val="3C4043"/>
-                </a:solidFill>
-                <a:latin typeface="Inter" pitchFamily="34" charset="0"/>
-                <a:ea typeface="Inter" pitchFamily="34" charset="-122"/>
-                <a:cs typeface="Inter" pitchFamily="34" charset="-120"/>
-              </a:rPr>
-              <a:t>Feedback + action</a:t>
-            </a:r>
-            <a:endParaRPr lang="en-US" sz="1800" dirty="0"/>
-          </a:p>
-          <a:p>
-            <a:pPr algn="l" indent="0" marL="0">
-              <a:lnSpc>
-                <a:spcPts val="2124"/>
+                <a:spcPts val="2714"/>
               </a:lnSpc>
               <a:spcBef>
                 <a:spcPts val="1000"/>
@@ -2258,7 +2293,7 @@
               <a:buNone/>
             </a:pPr>
             <a:r>
-              <a:rPr lang="en-US" altLang="en-US" sz="1800" dirty="0">
+              <a:rPr lang="en-US" altLang="en-US" sz="2300" b="1" dirty="0">
                 <a:solidFill>
                   <a:srgbClr val="3C4043"/>
                 </a:solidFill>
@@ -2266,9 +2301,32 @@
                 <a:ea typeface="Inter" pitchFamily="34" charset="-122"/>
                 <a:cs typeface="Inter" pitchFamily="34" charset="-120"/>
               </a:rPr>
-              <a:t>One criterion, prompt, student move, and evidence look-for.</a:t>
-            </a:r>
-            <a:endParaRPr lang="en-US" sz="1800" dirty="0"/>
+              <a:t>Plan for learning</a:t>
+            </a:r>
+            <a:endParaRPr lang="en-US" sz="1900" dirty="0"/>
+          </a:p>
+          <a:p>
+            <a:pPr algn="l" indent="0" marL="0">
+              <a:lnSpc>
+                <a:spcPts val="2242"/>
+              </a:lnSpc>
+              <a:spcBef>
+                <a:spcPts val="1000"/>
+              </a:spcBef>
+              <a:buNone/>
+            </a:pPr>
+            <a:r>
+              <a:rPr lang="en-US" altLang="en-US" sz="1900" dirty="0">
+                <a:solidFill>
+                  <a:srgbClr val="3C4043"/>
+                </a:solidFill>
+                <a:latin typeface="Inter" pitchFamily="34" charset="0"/>
+                <a:ea typeface="Inter" pitchFamily="34" charset="-122"/>
+                <a:cs typeface="Inter" pitchFamily="34" charset="-120"/>
+              </a:rPr>
+              <a:t>Build the lesson arc, access, facilitation, and feedback from Monday’s evidence.</a:t>
+            </a:r>
+            <a:endParaRPr lang="en-US" sz="1900" dirty="0"/>
           </a:p>
         </p:txBody>
       </p:sp>
@@ -2280,8 +2338,8 @@
         </p:nvSpPr>
         <p:spPr>
           <a:xfrm>
-            <a:off x="5765800" y="4038600"/>
-            <a:ext cx="457200" cy="533400"/>
+            <a:off x="6426200" y="4127500"/>
+            <a:ext cx="431800" cy="533400"/>
           </a:xfrm>
           <a:prstGeom prst="rect">
             <a:avLst/>
@@ -2297,7 +2355,7 @@
               <a:buNone/>
             </a:pPr>
             <a:r>
-              <a:rPr lang="en-US" altLang="en-US" sz="3200" dirty="0">
+              <a:rPr lang="en-US" altLang="en-US" sz="3100" dirty="0">
                 <a:solidFill>
                   <a:srgbClr val="C41220"/>
                 </a:solidFill>
@@ -2307,7 +2365,7 @@
               </a:rPr>
               <a:t>→</a:t>
             </a:r>
-            <a:endParaRPr lang="en-US" sz="3200" dirty="0"/>
+            <a:endParaRPr lang="en-US" sz="3100" dirty="0"/>
           </a:p>
         </p:txBody>
       </p:sp>
@@ -2319,8 +2377,8 @@
         </p:nvSpPr>
         <p:spPr>
           <a:xfrm>
-            <a:off x="6299200" y="2768600"/>
-            <a:ext cx="2286000" cy="3111500"/>
+            <a:off x="6908800" y="2717800"/>
+            <a:ext cx="2667000" cy="3238500"/>
           </a:xfrm>
           <a:prstGeom prst="rect">
             <a:avLst/>
@@ -2344,8 +2402,8 @@
         </p:nvSpPr>
         <p:spPr>
           <a:xfrm>
-            <a:off x="6527800" y="3098800"/>
-            <a:ext cx="1828800" cy="2133600"/>
+            <a:off x="7162800" y="3048000"/>
+            <a:ext cx="2159000" cy="2374900"/>
           </a:xfrm>
           <a:prstGeom prst="rect">
             <a:avLst/>
@@ -2374,35 +2432,12 @@
               </a:rPr>
               <a:t>WED. PD</a:t>
             </a:r>
-            <a:endParaRPr lang="en-US" sz="1800" dirty="0"/>
+            <a:endParaRPr lang="en-US" sz="1900" dirty="0"/>
           </a:p>
           <a:p>
             <a:pPr algn="l" indent="0" marL="0">
               <a:lnSpc>
-                <a:spcPts val="2596"/>
-              </a:lnSpc>
-              <a:spcBef>
-                <a:spcPts val="1200"/>
-              </a:spcBef>
-              <a:buNone/>
-            </a:pPr>
-            <a:r>
-              <a:rPr lang="en-US" altLang="en-US" sz="2200" b="1" dirty="0">
-                <a:solidFill>
-                  <a:srgbClr val="3C4043"/>
-                </a:solidFill>
-                <a:latin typeface="Inter" pitchFamily="34" charset="0"/>
-                <a:ea typeface="Inter" pitchFamily="34" charset="-122"/>
-                <a:cs typeface="Inter" pitchFamily="34" charset="-120"/>
-              </a:rPr>
-              <a:t>Calibrate the bar</a:t>
-            </a:r>
-            <a:endParaRPr lang="en-US" sz="1800" dirty="0"/>
-          </a:p>
-          <a:p>
-            <a:pPr algn="l" indent="0" marL="0">
-              <a:lnSpc>
-                <a:spcPts val="2124"/>
+                <a:spcPts val="2714"/>
               </a:lnSpc>
               <a:spcBef>
                 <a:spcPts val="1000"/>
@@ -2410,7 +2445,7 @@
               <a:buNone/>
             </a:pPr>
             <a:r>
-              <a:rPr lang="en-US" altLang="en-US" sz="1800" dirty="0">
+              <a:rPr lang="en-US" altLang="en-US" sz="2300" b="1" dirty="0">
                 <a:solidFill>
                   <a:srgbClr val="3C4043"/>
                 </a:solidFill>
@@ -2418,9 +2453,32 @@
                 <a:ea typeface="Inter" pitchFamily="34" charset="-122"/>
                 <a:cs typeface="Inter" pitchFamily="34" charset="-120"/>
               </a:rPr>
-              <a:t>Compare task, criteria, samples, feedback, and revision.</a:t>
-            </a:r>
-            <a:endParaRPr lang="en-US" sz="1800" dirty="0"/>
+              <a:t>Teach the routine</a:t>
+            </a:r>
+            <a:endParaRPr lang="en-US" sz="1900" dirty="0"/>
+          </a:p>
+          <a:p>
+            <a:pPr algn="l" indent="0" marL="0">
+              <a:lnSpc>
+                <a:spcPts val="2242"/>
+              </a:lnSpc>
+              <a:spcBef>
+                <a:spcPts val="1000"/>
+              </a:spcBef>
+              <a:buNone/>
+            </a:pPr>
+            <a:r>
+              <a:rPr lang="en-US" altLang="en-US" sz="1900" dirty="0">
+                <a:solidFill>
+                  <a:srgbClr val="3C4043"/>
+                </a:solidFill>
+                <a:latin typeface="Inter" pitchFamily="34" charset="0"/>
+                <a:ea typeface="Inter" pitchFamily="34" charset="-122"/>
+                <a:cs typeface="Inter" pitchFamily="34" charset="-120"/>
+              </a:rPr>
+              <a:t>Model CUBS and color-coded CER as student-facing science literacy supports.</a:t>
+            </a:r>
+            <a:endParaRPr lang="en-US" sz="1900" dirty="0"/>
           </a:p>
         </p:txBody>
       </p:sp>
@@ -2432,8 +2490,8 @@
         </p:nvSpPr>
         <p:spPr>
           <a:xfrm>
-            <a:off x="8661400" y="4038600"/>
-            <a:ext cx="457200" cy="533400"/>
+            <a:off x="9626600" y="4127500"/>
+            <a:ext cx="431800" cy="533400"/>
           </a:xfrm>
           <a:prstGeom prst="rect">
             <a:avLst/>
@@ -2449,7 +2507,7 @@
               <a:buNone/>
             </a:pPr>
             <a:r>
-              <a:rPr lang="en-US" altLang="en-US" sz="3200" dirty="0">
+              <a:rPr lang="en-US" altLang="en-US" sz="3100" dirty="0">
                 <a:solidFill>
                   <a:srgbClr val="C41220"/>
                 </a:solidFill>
@@ -2459,7 +2517,7 @@
               </a:rPr>
               <a:t>→</a:t>
             </a:r>
-            <a:endParaRPr lang="en-US" sz="3200" dirty="0"/>
+            <a:endParaRPr lang="en-US" sz="3100" dirty="0"/>
           </a:p>
         </p:txBody>
       </p:sp>
@@ -2471,8 +2529,8 @@
         </p:nvSpPr>
         <p:spPr>
           <a:xfrm>
-            <a:off x="9194800" y="2768600"/>
-            <a:ext cx="2286000" cy="3111500"/>
+            <a:off x="10109200" y="2717800"/>
+            <a:ext cx="2667000" cy="3238500"/>
           </a:xfrm>
           <a:prstGeom prst="rect">
             <a:avLst/>
@@ -2496,8 +2554,8 @@
         </p:nvSpPr>
         <p:spPr>
           <a:xfrm>
-            <a:off x="9423400" y="3098800"/>
-            <a:ext cx="1828800" cy="2133600"/>
+            <a:off x="10363200" y="3048000"/>
+            <a:ext cx="2159000" cy="2374900"/>
           </a:xfrm>
           <a:prstGeom prst="rect">
             <a:avLst/>
@@ -2526,35 +2584,12 @@
               </a:rPr>
               <a:t>FRIDAY</a:t>
             </a:r>
-            <a:endParaRPr lang="en-US" sz="1800" dirty="0"/>
+            <a:endParaRPr lang="en-US" sz="1900" dirty="0"/>
           </a:p>
           <a:p>
             <a:pPr algn="l" indent="0" marL="0">
               <a:lnSpc>
-                <a:spcPts val="2596"/>
-              </a:lnSpc>
-              <a:spcBef>
-                <a:spcPts val="1200"/>
-              </a:spcBef>
-              <a:buNone/>
-            </a:pPr>
-            <a:r>
-              <a:rPr lang="en-US" altLang="en-US" sz="2200" b="1" dirty="0">
-                <a:solidFill>
-                  <a:srgbClr val="3C4043"/>
-                </a:solidFill>
-                <a:latin typeface="Inter" pitchFamily="34" charset="0"/>
-                <a:ea typeface="Inter" pitchFamily="34" charset="-122"/>
-                <a:cs typeface="Inter" pitchFamily="34" charset="-120"/>
-              </a:rPr>
-              <a:t>Evidence review</a:t>
-            </a:r>
-            <a:endParaRPr lang="en-US" sz="1800" dirty="0"/>
-          </a:p>
-          <a:p>
-            <a:pPr algn="l" indent="0" marL="0">
-              <a:lnSpc>
-                <a:spcPts val="2124"/>
+                <a:spcPts val="2714"/>
               </a:lnSpc>
               <a:spcBef>
                 <a:spcPts val="1000"/>
@@ -2562,7 +2597,7 @@
               <a:buNone/>
             </a:pPr>
             <a:r>
-              <a:rPr lang="en-US" altLang="en-US" sz="1800" dirty="0">
+              <a:rPr lang="en-US" altLang="en-US" sz="2300" b="1" dirty="0">
                 <a:solidFill>
                   <a:srgbClr val="3C4043"/>
                 </a:solidFill>
@@ -2570,9 +2605,32 @@
                 <a:ea typeface="Inter" pitchFamily="34" charset="-122"/>
                 <a:cs typeface="Inter" pitchFamily="34" charset="-120"/>
               </a:rPr>
-              <a:t>Writing samples + unit-test evidence where available.</a:t>
-            </a:r>
-            <a:endParaRPr lang="en-US" sz="1800" dirty="0"/>
+              <a:t>Read student work</a:t>
+            </a:r>
+            <a:endParaRPr lang="en-US" sz="1900" dirty="0"/>
+          </a:p>
+          <a:p>
+            <a:pPr algn="l" indent="0" marL="0">
+              <a:lnSpc>
+                <a:spcPts val="2242"/>
+              </a:lnSpc>
+              <a:spcBef>
+                <a:spcPts val="1000"/>
+              </a:spcBef>
+              <a:buNone/>
+            </a:pPr>
+            <a:r>
+              <a:rPr lang="en-US" altLang="en-US" sz="1900" dirty="0">
+                <a:solidFill>
+                  <a:srgbClr val="3C4043"/>
+                </a:solidFill>
+                <a:latin typeface="Inter" pitchFamily="34" charset="0"/>
+                <a:ea typeface="Inter" pitchFamily="34" charset="-122"/>
+                <a:cs typeface="Inter" pitchFamily="34" charset="-120"/>
+              </a:rPr>
+              <a:t>Analyze completed writing, give written feedback, and identify the next step.</a:t>
+            </a:r>
+            <a:endParaRPr lang="en-US" sz="1900" dirty="0"/>
           </a:p>
         </p:txBody>
       </p:sp>
@@ -2584,8 +2642,8 @@
         </p:nvSpPr>
         <p:spPr>
           <a:xfrm>
-            <a:off x="11557000" y="4038600"/>
-            <a:ext cx="457200" cy="533400"/>
+            <a:off x="12827000" y="4127500"/>
+            <a:ext cx="431800" cy="533400"/>
           </a:xfrm>
           <a:prstGeom prst="rect">
             <a:avLst/>
@@ -2601,7 +2659,7 @@
               <a:buNone/>
             </a:pPr>
             <a:r>
-              <a:rPr lang="en-US" altLang="en-US" sz="3200" dirty="0">
+              <a:rPr lang="en-US" altLang="en-US" sz="3100" dirty="0">
                 <a:solidFill>
                   <a:srgbClr val="C41220"/>
                 </a:solidFill>
@@ -2611,7 +2669,7 @@
               </a:rPr>
               <a:t>→</a:t>
             </a:r>
-            <a:endParaRPr lang="en-US" sz="3200" dirty="0"/>
+            <a:endParaRPr lang="en-US" sz="3100" dirty="0"/>
           </a:p>
         </p:txBody>
       </p:sp>
@@ -2623,8 +2681,8 @@
         </p:nvSpPr>
         <p:spPr>
           <a:xfrm>
-            <a:off x="12090400" y="2768600"/>
-            <a:ext cx="3657600" cy="3111500"/>
+            <a:off x="13309600" y="2717800"/>
+            <a:ext cx="2438400" cy="3238500"/>
           </a:xfrm>
           <a:prstGeom prst="rect">
             <a:avLst/>
@@ -2643,8 +2701,8 @@
         </p:nvSpPr>
         <p:spPr>
           <a:xfrm>
-            <a:off x="12420600" y="3098800"/>
-            <a:ext cx="2997200" cy="2133600"/>
+            <a:off x="13538200" y="3048000"/>
+            <a:ext cx="1981200" cy="2374900"/>
           </a:xfrm>
           <a:prstGeom prst="rect">
             <a:avLst/>
@@ -2671,37 +2729,14 @@
                 <a:ea typeface="Inter" pitchFamily="34" charset="-122"/>
                 <a:cs typeface="Inter" pitchFamily="34" charset="-120"/>
               </a:rPr>
-              <a:t>NEXT LEARNING EXPERIENCE</a:t>
-            </a:r>
-            <a:endParaRPr lang="en-US" sz="1800" dirty="0"/>
+              <a:t>MASTERY</a:t>
+            </a:r>
+            <a:endParaRPr lang="en-US" sz="1900" dirty="0"/>
           </a:p>
           <a:p>
             <a:pPr algn="l" indent="0" marL="0">
               <a:lnSpc>
-                <a:spcPts val="2596"/>
-              </a:lnSpc>
-              <a:spcBef>
-                <a:spcPts val="1200"/>
-              </a:spcBef>
-              <a:buNone/>
-            </a:pPr>
-            <a:r>
-              <a:rPr lang="en-US" altLang="en-US" sz="2200" b="1" dirty="0">
-                <a:solidFill>
-                  <a:srgbClr val="FFFFFF"/>
-                </a:solidFill>
-                <a:latin typeface="Inter" pitchFamily="34" charset="0"/>
-                <a:ea typeface="Inter" pitchFamily="34" charset="-122"/>
-                <a:cs typeface="Inter" pitchFamily="34" charset="-120"/>
-              </a:rPr>
-              <a:t>Respond to a supported learning pattern</a:t>
-            </a:r>
-            <a:endParaRPr lang="en-US" sz="1800" dirty="0"/>
-          </a:p>
-          <a:p>
-            <a:pPr algn="l" indent="0" marL="0">
-              <a:lnSpc>
-                <a:spcPts val="2124"/>
+                <a:spcPts val="2714"/>
               </a:lnSpc>
               <a:spcBef>
                 <a:spcPts val="1000"/>
@@ -2709,7 +2744,7 @@
               <a:buNone/>
             </a:pPr>
             <a:r>
-              <a:rPr lang="en-US" altLang="en-US" sz="1800" dirty="0">
+              <a:rPr lang="en-US" altLang="en-US" sz="2300" b="1" dirty="0">
                 <a:solidFill>
                   <a:srgbClr val="FFFFFF"/>
                 </a:solidFill>
@@ -2717,9 +2752,32 @@
                 <a:ea typeface="Inter" pitchFamily="34" charset="-122"/>
                 <a:cs typeface="Inter" pitchFamily="34" charset="-120"/>
               </a:rPr>
-              <a:t>Name the next student action and a brief evidence check.</a:t>
-            </a:r>
-            <a:endParaRPr lang="en-US" sz="1800" dirty="0"/>
+              <a:t>Respond precisely</a:t>
+            </a:r>
+            <a:endParaRPr lang="en-US" sz="1900" dirty="0"/>
+          </a:p>
+          <a:p>
+            <a:pPr algn="l" indent="0" marL="0">
+              <a:lnSpc>
+                <a:spcPts val="2242"/>
+              </a:lnSpc>
+              <a:spcBef>
+                <a:spcPts val="1000"/>
+              </a:spcBef>
+              <a:buNone/>
+            </a:pPr>
+            <a:r>
+              <a:rPr lang="en-US" altLang="en-US" sz="1900" dirty="0">
+                <a:solidFill>
+                  <a:srgbClr val="FFFFFF"/>
+                </a:solidFill>
+                <a:latin typeface="Inter" pitchFamily="34" charset="0"/>
+                <a:ea typeface="Inter" pitchFamily="34" charset="-122"/>
+                <a:cs typeface="Inter" pitchFamily="34" charset="-120"/>
+              </a:rPr>
+              <a:t>Choose a targeted next learning experience and evidence check.</a:t>
+            </a:r>
+            <a:endParaRPr lang="en-US" sz="1900" dirty="0"/>
           </a:p>
         </p:txBody>
       </p:sp>
@@ -2781,7 +2839,7 @@
         <p:spPr>
           <a:xfrm>
             <a:off x="1574800" y="6959600"/>
-            <a:ext cx="13398500" cy="698500"/>
+            <a:ext cx="13462000" cy="698500"/>
           </a:xfrm>
           <a:prstGeom prst="rect">
             <a:avLst/>
@@ -2808,7 +2866,7 @@
                 <a:ea typeface="Inter" pitchFamily="34" charset="-122"/>
                 <a:cs typeface="Inter" pitchFamily="34" charset="-120"/>
               </a:rPr>
-              <a:t>Non-evaluative evidence story:</a:t>
+              <a:t>Instructional focus:</a:t>
             </a:r>
             <a:r>
               <a:rPr lang="en-US" altLang="en-US" sz="2200" dirty="0">
@@ -2819,7 +2877,7 @@
                 <a:ea typeface="Inter" pitchFamily="34" charset="-122"/>
                 <a:cs typeface="Inter" pitchFamily="34" charset="-120"/>
               </a:rPr>
-              <a:t> work from the task and evidence, not from teacher, student, or course comparisons. Avoid broad reteach plans.</a:t>
+              <a:t> the task and evidence guide the conversation. Do not rank students, teachers, courses, or sections; avoid broad reteach plans.</a:t>
             </a:r>
             <a:endParaRPr lang="en-US" sz="2200" dirty="0"/>
           </a:p>
@@ -2969,7 +3027,7 @@
                 <a:ea typeface="Inter" pitchFamily="34" charset="-122"/>
                 <a:cs typeface="Inter" pitchFamily="34" charset="-120"/>
               </a:rPr>
-              <a:t>Student-Facing CUBS: Read and Annotate Before CER</a:t>
+              <a:t>Complete the Benchmark as a Student</a:t>
             </a:r>
             <a:endParaRPr lang="en-US" sz="3000" dirty="0"/>
           </a:p>
@@ -3008,7 +3066,7 @@
                 <a:ea typeface="Inter" pitchFamily="34" charset="-122"/>
                 <a:cs typeface="Inter" pitchFamily="34" charset="-120"/>
               </a:rPr>
-              <a:t>4:00–10:00  •  6 MIN</a:t>
+              <a:t>3:00–17:00  •  14 MIN</a:t>
             </a:r>
             <a:endParaRPr lang="en-US" sz="1600" dirty="0"/>
           </a:p>
@@ -3022,8 +3080,8 @@
         </p:nvSpPr>
         <p:spPr>
           <a:xfrm>
-            <a:off x="508000" y="1397000"/>
-            <a:ext cx="14732000" cy="635000"/>
+            <a:off x="508000" y="1371600"/>
+            <a:ext cx="14859000" cy="685800"/>
           </a:xfrm>
           <a:prstGeom prst="rect">
             <a:avLst/>
@@ -3036,6 +3094,9 @@
           <a:lstStyle/>
           <a:p>
             <a:pPr algn="l" indent="0" marL="0">
+              <a:lnSpc>
+                <a:spcPts val="2760"/>
+              </a:lnSpc>
               <a:buNone/>
             </a:pPr>
             <a:r>
@@ -3047,7 +3108,7 @@
                 <a:ea typeface="Inter" pitchFamily="34" charset="-122"/>
                 <a:cs typeface="Inter" pitchFamily="34" charset="-120"/>
               </a:rPr>
-              <a:t>Use this student-facing example with the actual article, data display, model, investigation result, or prompt that supplies evidence for the writing benchmark.</a:t>
+              <a:t>Work silently and independently first. Respond to the attached Biology Benchmark #1 exactly as a student would; other course teams notice the transferable task demands they will apply to their own task.</a:t>
             </a:r>
             <a:endParaRPr lang="en-US" sz="2300" dirty="0"/>
           </a:p>
@@ -3061,8 +3122,8 @@
         </p:nvSpPr>
         <p:spPr>
           <a:xfrm>
-            <a:off x="508000" y="2387600"/>
-            <a:ext cx="7112000" cy="4279900"/>
+            <a:off x="508000" y="2476500"/>
+            <a:ext cx="6350000" cy="4876800"/>
           </a:xfrm>
           <a:prstGeom prst="rect">
             <a:avLst/>
@@ -3080,7 +3141,7 @@
       </p:sp>
       <p:pic>
         <p:nvPicPr>
-          <p:cNvPr id="7" name="cubs-example" descr="preencoded.png">    </p:cNvPr>
+          <p:cNvPr id="7" name="benchmark-page-1" descr="preencoded.png">    </p:cNvPr>
           <p:cNvPicPr>
             <a:picLocks noChangeAspect="1"/>
           </p:cNvPicPr>
@@ -3088,13 +3149,13 @@
         </p:nvPicPr>
         <p:blipFill>
           <a:blip r:embed="rId1"/>
-          <a:srcRect l="0" r="0" t="-409" b="-409"/>
+          <a:srcRect l="-35909" r="-35909" t="0" b="0"/>
           <a:stretch/>
         </p:blipFill>
         <p:spPr>
           <a:xfrm>
-            <a:off x="685800" y="2565400"/>
-            <a:ext cx="6756400" cy="3924300"/>
+            <a:off x="698500" y="2667000"/>
+            <a:ext cx="5969000" cy="4495800"/>
           </a:xfrm>
           <a:prstGeom prst="rect">
             <a:avLst/>
@@ -3109,14 +3170,14 @@
         </p:nvSpPr>
         <p:spPr>
           <a:xfrm>
-            <a:off x="8001000" y="2387600"/>
-            <a:ext cx="7747000" cy="4279900"/>
-          </a:xfrm>
-          <a:prstGeom prst="rect">
-            <a:avLst/>
-          </a:prstGeom>
-          <a:solidFill>
-            <a:srgbClr val="F3F4F6"/>
+            <a:off x="7239000" y="2476500"/>
+            <a:ext cx="6350000" cy="4876800"/>
+          </a:xfrm>
+          <a:prstGeom prst="rect">
+            <a:avLst/>
+          </a:prstGeom>
+          <a:solidFill>
+            <a:srgbClr val="F8F9FA"/>
           </a:solidFill>
           <a:ln w="12700">
             <a:solidFill>
@@ -3126,221 +3187,64 @@
           </a:ln>
         </p:spPr>
       </p:sp>
-      <p:sp>
-        <p:nvSpPr>
-          <p:cNvPr id="9" name="cubs-title"/>
-          <p:cNvSpPr/>
-          <p:nvPr/>
-        </p:nvSpPr>
-        <p:spPr>
-          <a:xfrm>
-            <a:off x="8382000" y="2730500"/>
-            <a:ext cx="6731000" cy="381000"/>
-          </a:xfrm>
-          <a:prstGeom prst="rect">
-            <a:avLst/>
-          </a:prstGeom>
-          <a:noFill/>
-          <a:ln/>
-        </p:spPr>
-        <p:txBody>
-          <a:bodyPr wrap="square" lIns="0" tIns="0" rIns="0" bIns="0" rtlCol="0" anchor="t"/>
-          <a:lstStyle/>
-          <a:p>
-            <a:pPr algn="l" indent="0" marL="0">
-              <a:buNone/>
-            </a:pPr>
-            <a:r>
-              <a:rPr lang="en-US" altLang="en-US" sz="2400" dirty="0">
-                <a:solidFill>
-                  <a:srgbClr val="3C4043"/>
-                </a:solidFill>
-                <a:latin typeface="Inter" pitchFamily="34" charset="0"/>
-                <a:ea typeface="Inter" pitchFamily="34" charset="-122"/>
-                <a:cs typeface="Inter" pitchFamily="34" charset="-120"/>
-              </a:rPr>
-              <a:t>STUDENT ROUTINE: USE THE SOURCE TO BUILD A RESPONSE</a:t>
-            </a:r>
-            <a:endParaRPr lang="en-US" sz="2400" dirty="0"/>
-          </a:p>
-        </p:txBody>
-      </p:sp>
-      <p:sp>
-        <p:nvSpPr>
-          <p:cNvPr id="10" name="cubs-steps"/>
-          <p:cNvSpPr/>
-          <p:nvPr/>
-        </p:nvSpPr>
-        <p:spPr>
-          <a:xfrm>
-            <a:off x="8382000" y="3390900"/>
-            <a:ext cx="6731000" cy="2641600"/>
-          </a:xfrm>
-          <a:prstGeom prst="rect">
-            <a:avLst/>
-          </a:prstGeom>
-          <a:noFill/>
-          <a:ln/>
-        </p:spPr>
-        <p:txBody>
-          <a:bodyPr wrap="square" lIns="0" tIns="0" rIns="0" bIns="0" rtlCol="0" anchor="t"/>
-          <a:lstStyle/>
-          <a:p>
-            <a:pPr algn="l" indent="0" marL="0">
-              <a:lnSpc>
-                <a:spcPts val="2583"/>
-              </a:lnSpc>
-              <a:buNone/>
-            </a:pPr>
-            <a:r>
-              <a:rPr lang="en-US" altLang="en-US" sz="2100" b="1" dirty="0">
-                <a:solidFill>
-                  <a:srgbClr val="C41220"/>
-                </a:solidFill>
-                <a:latin typeface="Inter" pitchFamily="34" charset="0"/>
-                <a:ea typeface="Inter" pitchFamily="34" charset="-122"/>
-                <a:cs typeface="Inter" pitchFamily="34" charset="-120"/>
-              </a:rPr>
-              <a:t>C — Circle</a:t>
-            </a:r>
-            <a:r>
-              <a:rPr lang="en-US" altLang="en-US" sz="2100" dirty="0">
-                <a:solidFill>
-                  <a:srgbClr val="3C4043"/>
-                </a:solidFill>
-                <a:latin typeface="Inter" pitchFamily="34" charset="0"/>
-                <a:ea typeface="Inter" pitchFamily="34" charset="-122"/>
-                <a:cs typeface="Inter" pitchFamily="34" charset="-120"/>
-              </a:rPr>
-              <a:t> the main idea or scientific claim.</a:t>
-            </a:r>
-            <a:endParaRPr lang="en-US" sz="2100" dirty="0"/>
-          </a:p>
-          <a:p>
-            <a:pPr algn="l" indent="0" marL="0">
-              <a:lnSpc>
-                <a:spcPts val="2583"/>
-              </a:lnSpc>
-              <a:buNone/>
-            </a:pPr>
-            <a:r>
-              <a:rPr lang="en-US" altLang="en-US" sz="2100" b="1" dirty="0">
-                <a:solidFill>
-                  <a:srgbClr val="C41220"/>
-                </a:solidFill>
-                <a:latin typeface="Inter" pitchFamily="34" charset="0"/>
-                <a:ea typeface="Inter" pitchFamily="34" charset="-122"/>
-                <a:cs typeface="Inter" pitchFamily="34" charset="-120"/>
-              </a:rPr>
-              <a:t>U — Underline</a:t>
-            </a:r>
-            <a:r>
-              <a:rPr lang="en-US" altLang="en-US" sz="2100" dirty="0">
-                <a:solidFill>
-                  <a:srgbClr val="3C4043"/>
-                </a:solidFill>
-                <a:latin typeface="Inter" pitchFamily="34" charset="0"/>
-                <a:ea typeface="Inter" pitchFamily="34" charset="-122"/>
-                <a:cs typeface="Inter" pitchFamily="34" charset="-120"/>
-              </a:rPr>
-              <a:t> supporting data, observations, or details.</a:t>
-            </a:r>
-            <a:endParaRPr lang="en-US" sz="2100" dirty="0"/>
-          </a:p>
-          <a:p>
-            <a:pPr algn="l" indent="0" marL="0">
-              <a:lnSpc>
-                <a:spcPts val="2583"/>
-              </a:lnSpc>
-              <a:buNone/>
-            </a:pPr>
-            <a:r>
-              <a:rPr lang="en-US" altLang="en-US" sz="2100" b="1" dirty="0">
-                <a:solidFill>
-                  <a:srgbClr val="C41220"/>
-                </a:solidFill>
-                <a:latin typeface="Inter" pitchFamily="34" charset="0"/>
-                <a:ea typeface="Inter" pitchFamily="34" charset="-122"/>
-                <a:cs typeface="Inter" pitchFamily="34" charset="-120"/>
-              </a:rPr>
-              <a:t>B — Box</a:t>
-            </a:r>
-            <a:r>
-              <a:rPr lang="en-US" altLang="en-US" sz="2100" dirty="0">
-                <a:solidFill>
-                  <a:srgbClr val="3C4043"/>
-                </a:solidFill>
-                <a:latin typeface="Inter" pitchFamily="34" charset="0"/>
-                <a:ea typeface="Inter" pitchFamily="34" charset="-122"/>
-                <a:cs typeface="Inter" pitchFamily="34" charset="-120"/>
-              </a:rPr>
-              <a:t> unfamiliar or important vocabulary.</a:t>
-            </a:r>
-            <a:endParaRPr lang="en-US" sz="2100" dirty="0"/>
-          </a:p>
-          <a:p>
-            <a:pPr algn="l" indent="0" marL="0">
-              <a:lnSpc>
-                <a:spcPts val="2583"/>
-              </a:lnSpc>
-              <a:buNone/>
-            </a:pPr>
-            <a:r>
-              <a:rPr lang="en-US" altLang="en-US" sz="2100" b="1" dirty="0">
-                <a:solidFill>
-                  <a:srgbClr val="C41220"/>
-                </a:solidFill>
-                <a:latin typeface="Inter" pitchFamily="34" charset="0"/>
-                <a:ea typeface="Inter" pitchFamily="34" charset="-122"/>
-                <a:cs typeface="Inter" pitchFamily="34" charset="-120"/>
-              </a:rPr>
-              <a:t>S — Summarize</a:t>
-            </a:r>
-            <a:r>
-              <a:rPr lang="en-US" altLang="en-US" sz="2100" dirty="0">
-                <a:solidFill>
-                  <a:srgbClr val="3C4043"/>
-                </a:solidFill>
-                <a:latin typeface="Inter" pitchFamily="34" charset="0"/>
-                <a:ea typeface="Inter" pitchFamily="34" charset="-122"/>
-                <a:cs typeface="Inter" pitchFamily="34" charset="-120"/>
-              </a:rPr>
-              <a:t> the science idea or question the source helps answer.</a:t>
-            </a:r>
-            <a:endParaRPr lang="en-US" sz="2100" dirty="0"/>
-          </a:p>
-        </p:txBody>
-      </p:sp>
-      <p:sp>
-        <p:nvSpPr>
-          <p:cNvPr id="11" name="cubs-shape-10"/>
-          <p:cNvSpPr/>
-          <p:nvPr/>
-        </p:nvSpPr>
-        <p:spPr>
-          <a:xfrm>
-            <a:off x="508000" y="7035800"/>
-            <a:ext cx="15240000" cy="889000"/>
-          </a:xfrm>
-          <a:prstGeom prst="rect">
-            <a:avLst/>
-          </a:prstGeom>
-          <a:solidFill>
-            <a:srgbClr val="202124"/>
-          </a:solidFill>
-          <a:ln/>
-        </p:spPr>
-      </p:sp>
-      <p:sp>
-        <p:nvSpPr>
-          <p:cNvPr id="12" name="cubs-bottom"/>
-          <p:cNvSpPr/>
-          <p:nvPr/>
-        </p:nvSpPr>
-        <p:spPr>
-          <a:xfrm>
-            <a:off x="838200" y="7239000"/>
-            <a:ext cx="14528800" cy="508000"/>
+      <p:pic>
+        <p:nvPicPr>
+          <p:cNvPr id="9" name="benchmark-page-2" descr="preencoded.png">    </p:cNvPr>
+          <p:cNvPicPr>
+            <a:picLocks noChangeAspect="1"/>
+          </p:cNvPicPr>
+          <p:nvPr/>
+        </p:nvPicPr>
+        <p:blipFill>
+          <a:blip r:embed="rId2"/>
+          <a:srcRect l="-35909" r="-35909" t="0" b="0"/>
+          <a:stretch/>
+        </p:blipFill>
+        <p:spPr>
+          <a:xfrm>
+            <a:off x="7429500" y="2667000"/>
+            <a:ext cx="5969000" cy="4495800"/>
+          </a:xfrm>
+          <a:prstGeom prst="rect">
+            <a:avLst/>
+          </a:prstGeom>
+        </p:spPr>
+      </p:pic>
+      <p:sp>
+        <p:nvSpPr>
+          <p:cNvPr id="10" name="cubs-shape-9"/>
+          <p:cNvSpPr/>
+          <p:nvPr/>
+        </p:nvSpPr>
+        <p:spPr>
+          <a:xfrm>
+            <a:off x="13970000" y="2476500"/>
+            <a:ext cx="1778000" cy="4876800"/>
+          </a:xfrm>
+          <a:prstGeom prst="rect">
+            <a:avLst/>
+          </a:prstGeom>
+          <a:solidFill>
+            <a:srgbClr val="FCE8EA"/>
+          </a:solidFill>
+          <a:ln w="25400">
+            <a:solidFill>
+              <a:srgbClr val="C41220"/>
+            </a:solidFill>
+            <a:prstDash val="solid"/>
+          </a:ln>
+        </p:spPr>
+      </p:sp>
+      <p:sp>
+        <p:nvSpPr>
+          <p:cNvPr id="11" name="student-task"/>
+          <p:cNvSpPr/>
+          <p:nvPr/>
+        </p:nvSpPr>
+        <p:spPr>
+          <a:xfrm>
+            <a:off x="14160500" y="2819400"/>
+            <a:ext cx="1397000" cy="4064000"/>
           </a:xfrm>
           <a:prstGeom prst="rect">
             <a:avLst/>
@@ -3354,12 +3258,140 @@
           <a:p>
             <a:pPr algn="ctr" indent="0" marL="0">
               <a:lnSpc>
-                <a:spcPts val="2436"/>
+                <a:spcPts val="1652"/>
               </a:lnSpc>
               <a:buNone/>
             </a:pPr>
             <a:r>
-              <a:rPr lang="en-US" altLang="en-US" sz="2100" b="1" dirty="0">
+              <a:rPr lang="en-US" altLang="en-US" sz="1400" b="1" dirty="0">
+                <a:solidFill>
+                  <a:srgbClr val="C41220"/>
+                </a:solidFill>
+                <a:latin typeface="Inter" pitchFamily="34" charset="0"/>
+                <a:ea typeface="Inter" pitchFamily="34" charset="-122"/>
+                <a:cs typeface="Inter" pitchFamily="34" charset="-120"/>
+              </a:rPr>
+              <a:t>WORK AS A STUDENT</a:t>
+            </a:r>
+            <a:endParaRPr lang="en-US" sz="1800" dirty="0"/>
+          </a:p>
+          <a:p>
+            <a:pPr algn="ctr" indent="0" marL="0">
+              <a:lnSpc>
+                <a:spcPts val="2124"/>
+              </a:lnSpc>
+              <a:spcBef>
+                <a:spcPts val="1400"/>
+              </a:spcBef>
+              <a:buNone/>
+            </a:pPr>
+            <a:r>
+              <a:rPr lang="en-US" altLang="en-US" sz="1800" dirty="0">
+                <a:solidFill>
+                  <a:srgbClr val="3C4043"/>
+                </a:solidFill>
+                <a:latin typeface="Inter" pitchFamily="34" charset="0"/>
+                <a:ea typeface="Inter" pitchFamily="34" charset="-122"/>
+                <a:cs typeface="Inter" pitchFamily="34" charset="-120"/>
+              </a:rPr>
+              <a:t>Read the graph and food web.</a:t>
+            </a:r>
+            <a:endParaRPr lang="en-US" sz="1800" dirty="0"/>
+          </a:p>
+          <a:p>
+            <a:pPr algn="ctr" indent="0" marL="0">
+              <a:lnSpc>
+                <a:spcPts val="2124"/>
+              </a:lnSpc>
+              <a:spcBef>
+                <a:spcPts val="1200"/>
+              </a:spcBef>
+              <a:buNone/>
+            </a:pPr>
+            <a:r>
+              <a:rPr lang="en-US" altLang="en-US" sz="1800" dirty="0">
+                <a:solidFill>
+                  <a:srgbClr val="3C4043"/>
+                </a:solidFill>
+                <a:latin typeface="Inter" pitchFamily="34" charset="0"/>
+                <a:ea typeface="Inter" pitchFamily="34" charset="-122"/>
+                <a:cs typeface="Inter" pitchFamily="34" charset="-120"/>
+              </a:rPr>
+              <a:t>Answer all five questions.</a:t>
+            </a:r>
+            <a:endParaRPr lang="en-US" sz="1800" dirty="0"/>
+          </a:p>
+          <a:p>
+            <a:pPr algn="ctr" indent="0" marL="0">
+              <a:lnSpc>
+                <a:spcPts val="2124"/>
+              </a:lnSpc>
+              <a:spcBef>
+                <a:spcPts val="1200"/>
+              </a:spcBef>
+              <a:buNone/>
+            </a:pPr>
+            <a:r>
+              <a:rPr lang="en-US" altLang="en-US" sz="1800" dirty="0">
+                <a:solidFill>
+                  <a:srgbClr val="3C4043"/>
+                </a:solidFill>
+                <a:latin typeface="Inter" pitchFamily="34" charset="0"/>
+                <a:ea typeface="Inter" pitchFamily="34" charset="-122"/>
+                <a:cs typeface="Inter" pitchFamily="34" charset="-120"/>
+              </a:rPr>
+              <a:t>Write the CER for Question 5.</a:t>
+            </a:r>
+            <a:endParaRPr lang="en-US" sz="1800" dirty="0"/>
+          </a:p>
+        </p:txBody>
+      </p:sp>
+      <p:sp>
+        <p:nvSpPr>
+          <p:cNvPr id="12" name="cubs-shape-11"/>
+          <p:cNvSpPr/>
+          <p:nvPr/>
+        </p:nvSpPr>
+        <p:spPr>
+          <a:xfrm>
+            <a:off x="508000" y="7747000"/>
+            <a:ext cx="15240000" cy="546100"/>
+          </a:xfrm>
+          <a:prstGeom prst="rect">
+            <a:avLst/>
+          </a:prstGeom>
+          <a:solidFill>
+            <a:srgbClr val="202124"/>
+          </a:solidFill>
+          <a:ln/>
+        </p:spPr>
+      </p:sp>
+      <p:sp>
+        <p:nvSpPr>
+          <p:cNvPr id="13" name="transfer"/>
+          <p:cNvSpPr/>
+          <p:nvPr/>
+        </p:nvSpPr>
+        <p:spPr>
+          <a:xfrm>
+            <a:off x="825500" y="7874000"/>
+            <a:ext cx="14351000" cy="279400"/>
+          </a:xfrm>
+          <a:prstGeom prst="rect">
+            <a:avLst/>
+          </a:prstGeom>
+          <a:noFill/>
+          <a:ln/>
+        </p:spPr>
+        <p:txBody>
+          <a:bodyPr wrap="square" lIns="0" tIns="0" rIns="0" bIns="0" rtlCol="0" anchor="t"/>
+          <a:lstStyle/>
+          <a:p>
+            <a:pPr algn="ctr" indent="0" marL="0">
+              <a:buNone/>
+            </a:pPr>
+            <a:r>
+              <a:rPr lang="en-US" altLang="en-US" sz="1800" b="1" dirty="0">
                 <a:solidFill>
                   <a:srgbClr val="F6B4BA"/>
                 </a:solidFill>
@@ -3367,10 +3399,10 @@
                 <a:ea typeface="Inter" pitchFamily="34" charset="-122"/>
                 <a:cs typeface="Inter" pitchFamily="34" charset="-120"/>
               </a:rPr>
-              <a:t>Expected student product:</a:t>
-            </a:r>
-            <a:r>
-              <a:rPr lang="en-US" altLang="en-US" sz="2100" dirty="0">
+              <a:t>Transfer:</a:t>
+            </a:r>
+            <a:r>
+              <a:rPr lang="en-US" altLang="en-US" sz="1800" dirty="0">
                 <a:solidFill>
                   <a:srgbClr val="FFFFFF"/>
                 </a:solidFill>
@@ -3378,15 +3410,15 @@
                 <a:ea typeface="Inter" pitchFamily="34" charset="-122"/>
                 <a:cs typeface="Inter" pitchFamily="34" charset="-120"/>
               </a:rPr>
-              <a:t> an annotated source that helps students identify and complete a claim, evidence, and reasoning response—not a separate activity or grading category.</a:t>
-            </a:r>
-            <a:endParaRPr lang="en-US" sz="2100" dirty="0"/>
-          </a:p>
-        </p:txBody>
-      </p:sp>
-      <p:sp>
-        <p:nvSpPr>
-          <p:cNvPr id="13" name="page"/>
+              <a:t> the shared model is Biology; each science team will apply this same experience-and-analyze move to its own standards-aligned task.</a:t>
+            </a:r>
+            <a:endParaRPr lang="en-US" sz="1800" dirty="0"/>
+          </a:p>
+        </p:txBody>
+      </p:sp>
+      <p:sp>
+        <p:nvSpPr>
+          <p:cNvPr id="14" name="page"/>
           <p:cNvSpPr/>
           <p:nvPr/>
         </p:nvSpPr>
@@ -3425,7 +3457,7 @@
       </p:sp>
       <p:sp>
         <p:nvSpPr>
-          <p:cNvPr id="14" name="cubs-shape-13"/>
+          <p:cNvPr id="15" name="cubs-shape-14"/>
           <p:cNvSpPr/>
           <p:nvPr/>
         </p:nvSpPr>
@@ -3504,7 +3536,7 @@
         <p:spPr>
           <a:xfrm>
             <a:off x="508000" y="292100"/>
-            <a:ext cx="11430000" cy="482600"/>
+            <a:ext cx="11684000" cy="482600"/>
           </a:xfrm>
           <a:prstGeom prst="rect">
             <a:avLst/>
@@ -3528,7 +3560,7 @@
                 <a:ea typeface="Inter" pitchFamily="34" charset="-122"/>
                 <a:cs typeface="Inter" pitchFamily="34" charset="-120"/>
               </a:rPr>
-              <a:t>Anticipate and Judge the Student CER Response</a:t>
+              <a:t>Analyze the Task, Texts, and Visuals With CUBS</a:t>
             </a:r>
             <a:endParaRPr lang="en-US" sz="3000" dirty="0"/>
           </a:p>
@@ -3542,8 +3574,8 @@
         </p:nvSpPr>
         <p:spPr>
           <a:xfrm>
-            <a:off x="13208000" y="355600"/>
-            <a:ext cx="2540000" cy="304800"/>
+            <a:off x="13081000" y="355600"/>
+            <a:ext cx="2667000" cy="304800"/>
           </a:xfrm>
           <a:prstGeom prst="rect">
             <a:avLst/>
@@ -3567,7 +3599,7 @@
                 <a:ea typeface="Inter" pitchFamily="34" charset="-122"/>
                 <a:cs typeface="Inter" pitchFamily="34" charset="-120"/>
               </a:rPr>
-              <a:t>10:00–17:00  •  7 MIN</a:t>
+              <a:t>17:00–24:00  •  7 MIN</a:t>
             </a:r>
             <a:endParaRPr lang="en-US" sz="1600" dirty="0"/>
           </a:p>
@@ -3581,8 +3613,8 @@
         </p:nvSpPr>
         <p:spPr>
           <a:xfrm>
-            <a:off x="508000" y="1397000"/>
-            <a:ext cx="14478000" cy="660400"/>
+            <a:off x="508000" y="1371600"/>
+            <a:ext cx="14605000" cy="660400"/>
           </a:xfrm>
           <a:prstGeom prst="rect">
             <a:avLst/>
@@ -3595,6 +3627,9 @@
           <a:lstStyle/>
           <a:p>
             <a:pPr algn="l" indent="0" marL="0">
+              <a:lnSpc>
+                <a:spcPts val="2760"/>
+              </a:lnSpc>
               <a:buNone/>
             </a:pPr>
             <a:r>
@@ -3606,7 +3641,7 @@
                 <a:ea typeface="Inter" pitchFamily="34" charset="-122"/>
                 <a:cs typeface="Inter" pitchFamily="34" charset="-120"/>
               </a:rPr>
-              <a:t>Use an exemplar or anticipated response to define what meeting the standard looks like, what a partial CER shows, and where students need a prompt—not an answer.</a:t>
+              <a:t>CUBS is a brief student-facing way to slow down the source analysis before writing. Use the graph, food web, and Question 5 prompt to notice what the response must draw on.</a:t>
             </a:r>
             <a:endParaRPr lang="en-US" sz="2300" dirty="0"/>
           </a:p>
@@ -3620,8 +3655,8 @@
         </p:nvSpPr>
         <p:spPr>
           <a:xfrm>
-            <a:off x="508000" y="2463800"/>
-            <a:ext cx="3530600" cy="3429000"/>
+            <a:off x="508000" y="2565400"/>
+            <a:ext cx="3492500" cy="3708400"/>
           </a:xfrm>
           <a:prstGeom prst="rect">
             <a:avLst/>
@@ -3639,14 +3674,14 @@
       </p:sp>
       <p:sp>
         <p:nvSpPr>
-          <p:cNvPr id="7" name="claim-label"/>
-          <p:cNvSpPr/>
-          <p:nvPr/>
-        </p:nvSpPr>
-        <p:spPr>
-          <a:xfrm>
-            <a:off x="812800" y="2819400"/>
-            <a:ext cx="2921000" cy="381000"/>
+          <p:cNvPr id="7" name="c-card"/>
+          <p:cNvSpPr/>
+          <p:nvPr/>
+        </p:nvSpPr>
+        <p:spPr>
+          <a:xfrm>
+            <a:off x="812800" y="2921000"/>
+            <a:ext cx="2882900" cy="2730500"/>
           </a:xfrm>
           <a:prstGeom prst="rect">
             <a:avLst/>
@@ -3659,10 +3694,13 @@
           <a:lstStyle/>
           <a:p>
             <a:pPr algn="l" indent="0" marL="0">
-              <a:buNone/>
-            </a:pPr>
-            <a:r>
-              <a:rPr lang="en-US" altLang="en-US" sz="2400" dirty="0">
+              <a:lnSpc>
+                <a:spcPts val="2928"/>
+              </a:lnSpc>
+              <a:buNone/>
+            </a:pPr>
+            <a:r>
+              <a:rPr lang="en-US" altLang="en-US" sz="2400" b="1" dirty="0">
                 <a:solidFill>
                   <a:srgbClr val="238636"/>
                 </a:solidFill>
@@ -3670,37 +3708,18 @@
                 <a:ea typeface="Inter" pitchFamily="34" charset="-122"/>
                 <a:cs typeface="Inter" pitchFamily="34" charset="-120"/>
               </a:rPr>
-              <a:t>CLAIM</a:t>
-            </a:r>
-            <a:endParaRPr lang="en-US" sz="2400" dirty="0"/>
-          </a:p>
-        </p:txBody>
-      </p:sp>
-      <p:sp>
-        <p:nvSpPr>
-          <p:cNvPr id="8" name="claim-body"/>
-          <p:cNvSpPr/>
-          <p:nvPr/>
-        </p:nvSpPr>
-        <p:spPr>
-          <a:xfrm>
-            <a:off x="812800" y="3556000"/>
-            <a:ext cx="2921000" cy="1397000"/>
-          </a:xfrm>
-          <a:prstGeom prst="rect">
-            <a:avLst/>
-          </a:prstGeom>
-          <a:noFill/>
-          <a:ln/>
-        </p:spPr>
-        <p:txBody>
-          <a:bodyPr wrap="square" lIns="0" tIns="0" rIns="0" bIns="0" rtlCol="0" anchor="t"/>
-          <a:lstStyle/>
+              <a:t>C — CIRCLE</a:t>
+            </a:r>
+            <a:endParaRPr lang="en-US" sz="2000" dirty="0"/>
+          </a:p>
           <a:p>
             <a:pPr algn="l" indent="0" marL="0">
               <a:lnSpc>
                 <a:spcPts val="2440"/>
               </a:lnSpc>
+              <a:spcBef>
+                <a:spcPts val="1200"/>
+              </a:spcBef>
               <a:buNone/>
             </a:pPr>
             <a:r>
@@ -3712,22 +3731,45 @@
                 <a:ea typeface="Inter" pitchFamily="34" charset="-122"/>
                 <a:cs typeface="Inter" pitchFamily="34" charset="-120"/>
               </a:rPr>
-              <a:t>Can the student identify and clearly state a conclusion, explanation, or position?</a:t>
+              <a:t>Circle the main question or central science idea.</a:t>
             </a:r>
             <a:endParaRPr lang="en-US" sz="2000" dirty="0"/>
           </a:p>
-        </p:txBody>
-      </p:sp>
-      <p:sp>
-        <p:nvSpPr>
-          <p:cNvPr id="9" name="cer-shape-8"/>
-          <p:cNvSpPr/>
-          <p:nvPr/>
-        </p:nvSpPr>
-        <p:spPr>
-          <a:xfrm>
-            <a:off x="4292600" y="2463800"/>
-            <a:ext cx="3530600" cy="3429000"/>
+          <a:p>
+            <a:pPr algn="l" indent="0" marL="0">
+              <a:lnSpc>
+                <a:spcPts val="2440"/>
+              </a:lnSpc>
+              <a:spcBef>
+                <a:spcPts val="1000"/>
+              </a:spcBef>
+              <a:buNone/>
+            </a:pPr>
+            <a:r>
+              <a:rPr lang="en-US" altLang="en-US" sz="2000" dirty="0">
+                <a:solidFill>
+                  <a:srgbClr val="3C4043"/>
+                </a:solidFill>
+                <a:latin typeface="Inter" pitchFamily="34" charset="0"/>
+                <a:ea typeface="Inter" pitchFamily="34" charset="-122"/>
+                <a:cs typeface="Inter" pitchFamily="34" charset="-120"/>
+              </a:rPr>
+              <a:t>What is the task asking students to predict or explain?</a:t>
+            </a:r>
+            <a:endParaRPr lang="en-US" sz="2000" dirty="0"/>
+          </a:p>
+        </p:txBody>
+      </p:sp>
+      <p:sp>
+        <p:nvSpPr>
+          <p:cNvPr id="8" name="cer-shape-7"/>
+          <p:cNvSpPr/>
+          <p:nvPr/>
+        </p:nvSpPr>
+        <p:spPr>
+          <a:xfrm>
+            <a:off x="4292600" y="2565400"/>
+            <a:ext cx="3492500" cy="3708400"/>
           </a:xfrm>
           <a:prstGeom prst="rect">
             <a:avLst/>
@@ -3745,14 +3787,14 @@
       </p:sp>
       <p:sp>
         <p:nvSpPr>
-          <p:cNvPr id="10" name="evidence-label"/>
-          <p:cNvSpPr/>
-          <p:nvPr/>
-        </p:nvSpPr>
-        <p:spPr>
-          <a:xfrm>
-            <a:off x="4597400" y="2819400"/>
-            <a:ext cx="2921000" cy="381000"/>
+          <p:cNvPr id="9" name="u-card"/>
+          <p:cNvSpPr/>
+          <p:nvPr/>
+        </p:nvSpPr>
+        <p:spPr>
+          <a:xfrm>
+            <a:off x="4597400" y="2921000"/>
+            <a:ext cx="2882900" cy="2730500"/>
           </a:xfrm>
           <a:prstGeom prst="rect">
             <a:avLst/>
@@ -3765,10 +3807,13 @@
           <a:lstStyle/>
           <a:p>
             <a:pPr algn="l" indent="0" marL="0">
-              <a:buNone/>
-            </a:pPr>
-            <a:r>
-              <a:rPr lang="en-US" altLang="en-US" sz="2400" dirty="0">
+              <a:lnSpc>
+                <a:spcPts val="2928"/>
+              </a:lnSpc>
+              <a:buNone/>
+            </a:pPr>
+            <a:r>
+              <a:rPr lang="en-US" altLang="en-US" sz="2400" b="1" dirty="0">
                 <a:solidFill>
                   <a:srgbClr val="1D4ED8"/>
                 </a:solidFill>
@@ -3776,37 +3821,18 @@
                 <a:ea typeface="Inter" pitchFamily="34" charset="-122"/>
                 <a:cs typeface="Inter" pitchFamily="34" charset="-120"/>
               </a:rPr>
-              <a:t>EVIDENCE</a:t>
-            </a:r>
-            <a:endParaRPr lang="en-US" sz="2400" dirty="0"/>
-          </a:p>
-        </p:txBody>
-      </p:sp>
-      <p:sp>
-        <p:nvSpPr>
-          <p:cNvPr id="11" name="evidence-body"/>
-          <p:cNvSpPr/>
-          <p:nvPr/>
-        </p:nvSpPr>
-        <p:spPr>
-          <a:xfrm>
-            <a:off x="4597400" y="3556000"/>
-            <a:ext cx="2921000" cy="1397000"/>
-          </a:xfrm>
-          <a:prstGeom prst="rect">
-            <a:avLst/>
-          </a:prstGeom>
-          <a:noFill/>
-          <a:ln/>
-        </p:spPr>
-        <p:txBody>
-          <a:bodyPr wrap="square" lIns="0" tIns="0" rIns="0" bIns="0" rtlCol="0" anchor="t"/>
-          <a:lstStyle/>
+              <a:t>U — UNDERLINE</a:t>
+            </a:r>
+            <a:endParaRPr lang="en-US" sz="2000" dirty="0"/>
+          </a:p>
           <a:p>
             <a:pPr algn="l" indent="0" marL="0">
               <a:lnSpc>
                 <a:spcPts val="2440"/>
               </a:lnSpc>
+              <a:spcBef>
+                <a:spcPts val="1200"/>
+              </a:spcBef>
               <a:buNone/>
             </a:pPr>
             <a:r>
@@ -3818,22 +3844,45 @@
                 <a:ea typeface="Inter" pitchFamily="34" charset="-122"/>
                 <a:cs typeface="Inter" pitchFamily="34" charset="-120"/>
               </a:rPr>
-              <a:t>Can the student select and use accurate, relevant data, observations, or source details?</a:t>
+              <a:t>Underline supporting data and relationships.</a:t>
             </a:r>
             <a:endParaRPr lang="en-US" sz="2000" dirty="0"/>
           </a:p>
-        </p:txBody>
-      </p:sp>
-      <p:sp>
-        <p:nvSpPr>
-          <p:cNvPr id="12" name="cer-shape-11"/>
-          <p:cNvSpPr/>
-          <p:nvPr/>
-        </p:nvSpPr>
-        <p:spPr>
-          <a:xfrm>
-            <a:off x="8077200" y="2463800"/>
-            <a:ext cx="3530600" cy="3429000"/>
+          <a:p>
+            <a:pPr algn="l" indent="0" marL="0">
+              <a:lnSpc>
+                <a:spcPts val="2440"/>
+              </a:lnSpc>
+              <a:spcBef>
+                <a:spcPts val="1000"/>
+              </a:spcBef>
+              <a:buNone/>
+            </a:pPr>
+            <a:r>
+              <a:rPr lang="en-US" altLang="en-US" sz="2000" dirty="0">
+                <a:solidFill>
+                  <a:srgbClr val="3C4043"/>
+                </a:solidFill>
+                <a:latin typeface="Inter" pitchFamily="34" charset="0"/>
+                <a:ea typeface="Inter" pitchFamily="34" charset="-122"/>
+                <a:cs typeface="Inter" pitchFamily="34" charset="-120"/>
+              </a:rPr>
+              <a:t>Which graph trend and food-web evidence could a student use?</a:t>
+            </a:r>
+            <a:endParaRPr lang="en-US" sz="2000" dirty="0"/>
+          </a:p>
+        </p:txBody>
+      </p:sp>
+      <p:sp>
+        <p:nvSpPr>
+          <p:cNvPr id="10" name="cer-shape-9"/>
+          <p:cNvSpPr/>
+          <p:nvPr/>
+        </p:nvSpPr>
+        <p:spPr>
+          <a:xfrm>
+            <a:off x="8077200" y="2565400"/>
+            <a:ext cx="3492500" cy="3708400"/>
           </a:xfrm>
           <a:prstGeom prst="rect">
             <a:avLst/>
@@ -3851,14 +3900,14 @@
       </p:sp>
       <p:sp>
         <p:nvSpPr>
-          <p:cNvPr id="13" name="reasoning-label"/>
-          <p:cNvSpPr/>
-          <p:nvPr/>
-        </p:nvSpPr>
-        <p:spPr>
-          <a:xfrm>
-            <a:off x="8382000" y="2819400"/>
-            <a:ext cx="2921000" cy="381000"/>
+          <p:cNvPr id="11" name="b-card"/>
+          <p:cNvSpPr/>
+          <p:nvPr/>
+        </p:nvSpPr>
+        <p:spPr>
+          <a:xfrm>
+            <a:off x="8382000" y="2921000"/>
+            <a:ext cx="2882900" cy="2730500"/>
           </a:xfrm>
           <a:prstGeom prst="rect">
             <a:avLst/>
@@ -3871,10 +3920,13 @@
           <a:lstStyle/>
           <a:p>
             <a:pPr algn="l" indent="0" marL="0">
-              <a:buNone/>
-            </a:pPr>
-            <a:r>
-              <a:rPr lang="en-US" altLang="en-US" sz="2400" dirty="0">
+              <a:lnSpc>
+                <a:spcPts val="2928"/>
+              </a:lnSpc>
+              <a:buNone/>
+            </a:pPr>
+            <a:r>
+              <a:rPr lang="en-US" altLang="en-US" sz="2400" b="1" dirty="0">
                 <a:solidFill>
                   <a:srgbClr val="C56B00"/>
                 </a:solidFill>
@@ -3882,37 +3934,18 @@
                 <a:ea typeface="Inter" pitchFamily="34" charset="-122"/>
                 <a:cs typeface="Inter" pitchFamily="34" charset="-120"/>
               </a:rPr>
-              <a:t>REASONING</a:t>
-            </a:r>
-            <a:endParaRPr lang="en-US" sz="2400" dirty="0"/>
-          </a:p>
-        </p:txBody>
-      </p:sp>
-      <p:sp>
-        <p:nvSpPr>
-          <p:cNvPr id="14" name="reasoning-body"/>
-          <p:cNvSpPr/>
-          <p:nvPr/>
-        </p:nvSpPr>
-        <p:spPr>
-          <a:xfrm>
-            <a:off x="8382000" y="3556000"/>
-            <a:ext cx="2921000" cy="1397000"/>
-          </a:xfrm>
-          <a:prstGeom prst="rect">
-            <a:avLst/>
-          </a:prstGeom>
-          <a:noFill/>
-          <a:ln/>
-        </p:spPr>
-        <p:txBody>
-          <a:bodyPr wrap="square" lIns="0" tIns="0" rIns="0" bIns="0" rtlCol="0" anchor="t"/>
-          <a:lstStyle/>
+              <a:t>B — BOX</a:t>
+            </a:r>
+            <a:endParaRPr lang="en-US" sz="2000" dirty="0"/>
+          </a:p>
           <a:p>
             <a:pPr algn="l" indent="0" marL="0">
               <a:lnSpc>
                 <a:spcPts val="2440"/>
               </a:lnSpc>
+              <a:spcBef>
+                <a:spcPts val="1200"/>
+              </a:spcBef>
               <a:buNone/>
             </a:pPr>
             <a:r>
@@ -3924,22 +3957,45 @@
                 <a:ea typeface="Inter" pitchFamily="34" charset="-122"/>
                 <a:cs typeface="Inter" pitchFamily="34" charset="-120"/>
               </a:rPr>
-              <a:t>Can the student explain why the evidence supports the claim using the science idea?</a:t>
+              <a:t>Box unfamiliar or high-leverage vocabulary.</a:t>
             </a:r>
             <a:endParaRPr lang="en-US" sz="2000" dirty="0"/>
           </a:p>
-        </p:txBody>
-      </p:sp>
-      <p:sp>
-        <p:nvSpPr>
-          <p:cNvPr id="15" name="cer-shape-14"/>
-          <p:cNvSpPr/>
-          <p:nvPr/>
-        </p:nvSpPr>
-        <p:spPr>
-          <a:xfrm>
-            <a:off x="11861800" y="2463800"/>
-            <a:ext cx="3886200" cy="3429000"/>
+          <a:p>
+            <a:pPr algn="l" indent="0" marL="0">
+              <a:lnSpc>
+                <a:spcPts val="2440"/>
+              </a:lnSpc>
+              <a:spcBef>
+                <a:spcPts val="1000"/>
+              </a:spcBef>
+              <a:buNone/>
+            </a:pPr>
+            <a:r>
+              <a:rPr lang="en-US" altLang="en-US" sz="2000" dirty="0">
+                <a:solidFill>
+                  <a:srgbClr val="3C4043"/>
+                </a:solidFill>
+                <a:latin typeface="Inter" pitchFamily="34" charset="0"/>
+                <a:ea typeface="Inter" pitchFamily="34" charset="-122"/>
+                <a:cs typeface="Inter" pitchFamily="34" charset="-120"/>
+              </a:rPr>
+              <a:t>For example: carrying capacity, predator, consumer, population.</a:t>
+            </a:r>
+            <a:endParaRPr lang="en-US" sz="2000" dirty="0"/>
+          </a:p>
+        </p:txBody>
+      </p:sp>
+      <p:sp>
+        <p:nvSpPr>
+          <p:cNvPr id="12" name="cer-shape-11"/>
+          <p:cNvSpPr/>
+          <p:nvPr/>
+        </p:nvSpPr>
+        <p:spPr>
+          <a:xfrm>
+            <a:off x="11861800" y="2565400"/>
+            <a:ext cx="3886200" cy="3708400"/>
           </a:xfrm>
           <a:prstGeom prst="rect">
             <a:avLst/>
@@ -3957,14 +4013,14 @@
       </p:sp>
       <p:sp>
         <p:nvSpPr>
-          <p:cNvPr id="16" name="language-label"/>
-          <p:cNvSpPr/>
-          <p:nvPr/>
-        </p:nvSpPr>
-        <p:spPr>
-          <a:xfrm>
-            <a:off x="12166600" y="2819400"/>
-            <a:ext cx="3276600" cy="381000"/>
+          <p:cNvPr id="13" name="s-card"/>
+          <p:cNvSpPr/>
+          <p:nvPr/>
+        </p:nvSpPr>
+        <p:spPr>
+          <a:xfrm>
+            <a:off x="12166600" y="2921000"/>
+            <a:ext cx="3276600" cy="2730500"/>
           </a:xfrm>
           <a:prstGeom prst="rect">
             <a:avLst/>
@@ -3977,10 +4033,13 @@
           <a:lstStyle/>
           <a:p>
             <a:pPr algn="l" indent="0" marL="0">
-              <a:buNone/>
-            </a:pPr>
-            <a:r>
-              <a:rPr lang="en-US" altLang="en-US" sz="2400" dirty="0">
+              <a:lnSpc>
+                <a:spcPts val="2928"/>
+              </a:lnSpc>
+              <a:buNone/>
+            </a:pPr>
+            <a:r>
+              <a:rPr lang="en-US" altLang="en-US" sz="2400" b="1" dirty="0">
                 <a:solidFill>
                   <a:srgbClr val="7C3AED"/>
                 </a:solidFill>
@@ -3988,37 +4047,18 @@
                 <a:ea typeface="Inter" pitchFamily="34" charset="-122"/>
                 <a:cs typeface="Inter" pitchFamily="34" charset="-120"/>
               </a:rPr>
-              <a:t>LANGUAGE + LINKS</a:t>
-            </a:r>
-            <a:endParaRPr lang="en-US" sz="2400" dirty="0"/>
-          </a:p>
-        </p:txBody>
-      </p:sp>
-      <p:sp>
-        <p:nvSpPr>
-          <p:cNvPr id="17" name="language-body"/>
-          <p:cNvSpPr/>
-          <p:nvPr/>
-        </p:nvSpPr>
-        <p:spPr>
-          <a:xfrm>
-            <a:off x="12166600" y="3556000"/>
-            <a:ext cx="3276600" cy="1397000"/>
-          </a:xfrm>
-          <a:prstGeom prst="rect">
-            <a:avLst/>
-          </a:prstGeom>
-          <a:noFill/>
-          <a:ln/>
-        </p:spPr>
-        <p:txBody>
-          <a:bodyPr wrap="square" lIns="0" tIns="0" rIns="0" bIns="0" rtlCol="0" anchor="t"/>
-          <a:lstStyle/>
+              <a:t>S — SUMMARIZE</a:t>
+            </a:r>
+            <a:endParaRPr lang="en-US" sz="2000" dirty="0"/>
+          </a:p>
           <a:p>
             <a:pPr algn="l" indent="0" marL="0">
               <a:lnSpc>
                 <a:spcPts val="2440"/>
               </a:lnSpc>
+              <a:spcBef>
+                <a:spcPts val="1200"/>
+              </a:spcBef>
               <a:buNone/>
             </a:pPr>
             <a:r>
@@ -4030,90 +4070,22 @@
                 <a:ea typeface="Inter" pitchFamily="34" charset="-122"/>
                 <a:cs typeface="Inter" pitchFamily="34" charset="-120"/>
               </a:rPr>
-              <a:t>Which language or representation makes the student’s completed thinking clear to a reader?</a:t>
+              <a:t>State the science idea the visuals help answer.</a:t>
             </a:r>
             <a:endParaRPr lang="en-US" sz="2000" dirty="0"/>
           </a:p>
-        </p:txBody>
-      </p:sp>
-      <p:sp>
-        <p:nvSpPr>
-          <p:cNvPr id="18" name="cer-shape-17"/>
-          <p:cNvSpPr/>
-          <p:nvPr/>
-        </p:nvSpPr>
-        <p:spPr>
-          <a:xfrm>
-            <a:off x="508000" y="6477000"/>
-            <a:ext cx="15240000" cy="1371600"/>
-          </a:xfrm>
-          <a:prstGeom prst="rect">
-            <a:avLst/>
-          </a:prstGeom>
-          <a:solidFill>
-            <a:srgbClr val="F3F4F6"/>
-          </a:solidFill>
-          <a:ln w="12700">
-            <a:solidFill>
-              <a:srgbClr val="D1D5DB"/>
-            </a:solidFill>
-            <a:prstDash val="solid"/>
-          </a:ln>
-        </p:spPr>
-      </p:sp>
-      <p:pic>
-        <p:nvPicPr>
-          <p:cNvPr id="19" name="cer-icon-18" descr="preencoded.png">    </p:cNvPr>
-          <p:cNvPicPr>
-            <a:picLocks noChangeAspect="1"/>
-          </p:cNvPicPr>
-          <p:nvPr/>
-        </p:nvPicPr>
-        <p:blipFill>
-          <a:blip r:embed="rId1"/>
-          <a:stretch>
-            <a:fillRect/>
-          </a:stretch>
-        </p:blipFill>
-        <p:spPr>
-          <a:xfrm>
-            <a:off x="825500" y="6870700"/>
-            <a:ext cx="482600" cy="482600"/>
-          </a:xfrm>
-          <a:prstGeom prst="rect">
-            <a:avLst/>
-          </a:prstGeom>
-        </p:spPr>
-      </p:pic>
-      <p:sp>
-        <p:nvSpPr>
-          <p:cNvPr id="20" name="talk-move"/>
-          <p:cNvSpPr/>
-          <p:nvPr/>
-        </p:nvSpPr>
-        <p:spPr>
-          <a:xfrm>
-            <a:off x="1600200" y="6680200"/>
-            <a:ext cx="13335000" cy="787400"/>
-          </a:xfrm>
-          <a:prstGeom prst="rect">
-            <a:avLst/>
-          </a:prstGeom>
-          <a:noFill/>
-          <a:ln/>
-        </p:spPr>
-        <p:txBody>
-          <a:bodyPr wrap="square" lIns="0" tIns="0" rIns="0" bIns="0" rtlCol="0" anchor="t"/>
-          <a:lstStyle/>
           <a:p>
             <a:pPr algn="l" indent="0" marL="0">
               <a:lnSpc>
-                <a:spcPts val="2640"/>
+                <a:spcPts val="2440"/>
               </a:lnSpc>
-              <a:buNone/>
-            </a:pPr>
-            <a:r>
-              <a:rPr lang="en-US" altLang="en-US" sz="2200" b="1" dirty="0">
+              <a:spcBef>
+                <a:spcPts val="1000"/>
+              </a:spcBef>
+              <a:buNone/>
+            </a:pPr>
+            <a:r>
+              <a:rPr lang="en-US" altLang="en-US" sz="2000" dirty="0">
                 <a:solidFill>
                   <a:srgbClr val="3C4043"/>
                 </a:solidFill>
@@ -4121,26 +4093,88 @@
                 <a:ea typeface="Inter" pitchFamily="34" charset="-122"/>
                 <a:cs typeface="Inter" pitchFamily="34" charset="-120"/>
               </a:rPr>
-              <a:t>Judge the bar:</a:t>
-            </a:r>
-            <a:r>
-              <a:rPr lang="en-US" altLang="en-US" sz="2200" dirty="0">
-                <a:solidFill>
-                  <a:srgbClr val="3C4043"/>
-                </a:solidFill>
-                <a:latin typeface="Inter" pitchFamily="34" charset="0"/>
-                <a:ea typeface="Inter" pitchFamily="34" charset="-122"/>
-                <a:cs typeface="Inter" pitchFamily="34" charset="-120"/>
-              </a:rPr>
-              <a:t> “What would a complete CER show? What would a partial response show? Which criterion would move students forward most?”</a:t>
-            </a:r>
-            <a:endParaRPr lang="en-US" sz="2200" dirty="0"/>
-          </a:p>
-        </p:txBody>
-      </p:sp>
-      <p:sp>
-        <p:nvSpPr>
-          <p:cNvPr id="21" name="page"/>
+              <a:t>Record a question students may still need to resolve.</a:t>
+            </a:r>
+            <a:endParaRPr lang="en-US" sz="2000" dirty="0"/>
+          </a:p>
+        </p:txBody>
+      </p:sp>
+      <p:sp>
+        <p:nvSpPr>
+          <p:cNvPr id="14" name="cer-shape-13"/>
+          <p:cNvSpPr/>
+          <p:nvPr/>
+        </p:nvSpPr>
+        <p:spPr>
+          <a:xfrm>
+            <a:off x="508000" y="6908800"/>
+            <a:ext cx="15240000" cy="990600"/>
+          </a:xfrm>
+          <a:prstGeom prst="rect">
+            <a:avLst/>
+          </a:prstGeom>
+          <a:solidFill>
+            <a:srgbClr val="202124"/>
+          </a:solidFill>
+          <a:ln/>
+        </p:spPr>
+      </p:sp>
+      <p:sp>
+        <p:nvSpPr>
+          <p:cNvPr id="15" name="talk-move"/>
+          <p:cNvSpPr/>
+          <p:nvPr/>
+        </p:nvSpPr>
+        <p:spPr>
+          <a:xfrm>
+            <a:off x="838200" y="7124700"/>
+            <a:ext cx="14478000" cy="546100"/>
+          </a:xfrm>
+          <a:prstGeom prst="rect">
+            <a:avLst/>
+          </a:prstGeom>
+          <a:noFill/>
+          <a:ln/>
+        </p:spPr>
+        <p:txBody>
+          <a:bodyPr wrap="square" lIns="0" tIns="0" rIns="0" bIns="0" rtlCol="0" anchor="t"/>
+          <a:lstStyle/>
+          <a:p>
+            <a:pPr algn="ctr" indent="0" marL="0">
+              <a:lnSpc>
+                <a:spcPts val="2478"/>
+              </a:lnSpc>
+              <a:buNone/>
+            </a:pPr>
+            <a:r>
+              <a:rPr lang="en-US" altLang="en-US" sz="2100" b="1" dirty="0">
+                <a:solidFill>
+                  <a:srgbClr val="F6B4BA"/>
+                </a:solidFill>
+                <a:latin typeface="Inter" pitchFamily="34" charset="0"/>
+                <a:ea typeface="Inter" pitchFamily="34" charset="-122"/>
+                <a:cs typeface="Inter" pitchFamily="34" charset="-120"/>
+              </a:rPr>
+              <a:t>Reflection prompt:</a:t>
+            </a:r>
+            <a:r>
+              <a:rPr lang="en-US" altLang="en-US" sz="2100" dirty="0">
+                <a:solidFill>
+                  <a:srgbClr val="FFFFFF"/>
+                </a:solidFill>
+                <a:latin typeface="Inter" pitchFamily="34" charset="0"/>
+                <a:ea typeface="Inter" pitchFamily="34" charset="-122"/>
+                <a:cs typeface="Inter" pitchFamily="34" charset="-120"/>
+              </a:rPr>
+              <a:t> What does this strategy reveal about the reading, visual-analysis, vocabulary, and evidence-selection work students must do before they can write?</a:t>
+            </a:r>
+            <a:endParaRPr lang="en-US" sz="2100" dirty="0"/>
+          </a:p>
+        </p:txBody>
+      </p:sp>
+      <p:sp>
+        <p:nvSpPr>
+          <p:cNvPr id="16" name="page"/>
           <p:cNvSpPr/>
           <p:nvPr/>
         </p:nvSpPr>
@@ -4179,7 +4213,7 @@
       </p:sp>
       <p:sp>
         <p:nvSpPr>
-          <p:cNvPr id="22" name="cer-shape-21"/>
+          <p:cNvPr id="17" name="cer-shape-16"/>
           <p:cNvSpPr/>
           <p:nvPr/>
         </p:nvSpPr>
@@ -4258,7 +4292,7 @@
         <p:spPr>
           <a:xfrm>
             <a:off x="508000" y="292100"/>
-            <a:ext cx="11684000" cy="482600"/>
+            <a:ext cx="12192000" cy="482600"/>
           </a:xfrm>
           <a:prstGeom prst="rect">
             <a:avLst/>
@@ -4282,7 +4316,7 @@
                 <a:ea typeface="Inter" pitchFamily="34" charset="-122"/>
                 <a:cs typeface="Inter" pitchFamily="34" charset="-120"/>
               </a:rPr>
-              <a:t>Anticipate the Response + Judge the Bar for Mastery</a:t>
+              <a:t>Color-Code the CER and Anticipate Student Responses</a:t>
             </a:r>
             <a:endParaRPr lang="en-US" sz="3000" dirty="0"/>
           </a:p>
@@ -4296,8 +4330,8 @@
         </p:nvSpPr>
         <p:spPr>
           <a:xfrm>
-            <a:off x="13081000" y="355600"/>
-            <a:ext cx="2667000" cy="304800"/>
+            <a:off x="12954000" y="355600"/>
+            <a:ext cx="2794000" cy="304800"/>
           </a:xfrm>
           <a:prstGeom prst="rect">
             <a:avLst/>
@@ -4321,7 +4355,7 @@
                 <a:ea typeface="Inter" pitchFamily="34" charset="-122"/>
                 <a:cs typeface="Inter" pitchFamily="34" charset="-120"/>
               </a:rPr>
-              <a:t>17:00–25:00  •  8 MIN</a:t>
+              <a:t>24:00–31:00  •  7 MIN</a:t>
             </a:r>
             <a:endParaRPr lang="en-US" sz="1600" dirty="0"/>
           </a:p>
@@ -4329,112 +4363,14 @@
       </p:sp>
       <p:sp>
         <p:nvSpPr>
-          <p:cNvPr id="5" name="analysis-shape-4"/>
-          <p:cNvSpPr/>
-          <p:nvPr/>
-        </p:nvSpPr>
-        <p:spPr>
-          <a:xfrm>
-            <a:off x="508000" y="1422400"/>
-            <a:ext cx="2692400" cy="1143000"/>
-          </a:xfrm>
-          <a:prstGeom prst="rect">
-            <a:avLst/>
-          </a:prstGeom>
-          <a:solidFill>
-            <a:srgbClr val="C41220"/>
-          </a:solidFill>
-          <a:ln/>
-        </p:spPr>
-      </p:sp>
-      <p:sp>
-        <p:nvSpPr>
-          <p:cNvPr id="6" name="timer-label"/>
-          <p:cNvSpPr/>
-          <p:nvPr/>
-        </p:nvSpPr>
-        <p:spPr>
-          <a:xfrm>
-            <a:off x="698500" y="1651000"/>
-            <a:ext cx="2311400" cy="228600"/>
-          </a:xfrm>
-          <a:prstGeom prst="rect">
-            <a:avLst/>
-          </a:prstGeom>
-          <a:noFill/>
-          <a:ln/>
-        </p:spPr>
-        <p:txBody>
-          <a:bodyPr wrap="square" lIns="0" tIns="0" rIns="0" bIns="0" rtlCol="0" anchor="t"/>
-          <a:lstStyle/>
-          <a:p>
-            <a:pPr algn="ctr" indent="0" marL="0">
-              <a:buNone/>
-            </a:pPr>
-            <a:r>
-              <a:rPr lang="en-US" altLang="en-US" sz="1400" dirty="0">
-                <a:solidFill>
-                  <a:srgbClr val="FDECEC"/>
-                </a:solidFill>
-                <a:latin typeface="Inter" pitchFamily="34" charset="0"/>
-                <a:ea typeface="Inter" pitchFamily="34" charset="-122"/>
-                <a:cs typeface="Inter" pitchFamily="34" charset="-120"/>
-              </a:rPr>
-              <a:t>COURSE-ALIKE WORK</a:t>
-            </a:r>
-            <a:endParaRPr lang="en-US" sz="1400" dirty="0"/>
-          </a:p>
-        </p:txBody>
-      </p:sp>
-      <p:sp>
-        <p:nvSpPr>
-          <p:cNvPr id="7" name="timer"/>
-          <p:cNvSpPr/>
-          <p:nvPr/>
-        </p:nvSpPr>
-        <p:spPr>
-          <a:xfrm>
-            <a:off x="698500" y="1930400"/>
-            <a:ext cx="2311400" cy="444500"/>
-          </a:xfrm>
-          <a:prstGeom prst="rect">
-            <a:avLst/>
-          </a:prstGeom>
-          <a:noFill/>
-          <a:ln/>
-        </p:spPr>
-        <p:txBody>
-          <a:bodyPr wrap="square" lIns="0" tIns="0" rIns="0" bIns="0" rtlCol="0" anchor="t"/>
-          <a:lstStyle/>
-          <a:p>
-            <a:pPr algn="ctr" indent="0" marL="0">
-              <a:buNone/>
-            </a:pPr>
-            <a:r>
-              <a:rPr lang="en-US" altLang="en-US" sz="3400" dirty="0">
-                <a:solidFill>
-                  <a:srgbClr val="FFFFFF"/>
-                </a:solidFill>
-                <a:latin typeface="Inter" pitchFamily="34" charset="0"/>
-                <a:ea typeface="Inter" pitchFamily="34" charset="-122"/>
-                <a:cs typeface="Inter" pitchFamily="34" charset="-120"/>
-              </a:rPr>
-              <a:t>8 min</a:t>
-            </a:r>
-            <a:endParaRPr lang="en-US" sz="3400" dirty="0"/>
-          </a:p>
-        </p:txBody>
-      </p:sp>
-      <p:sp>
-        <p:nvSpPr>
-          <p:cNvPr id="8" name="instruction"/>
-          <p:cNvSpPr/>
-          <p:nvPr/>
-        </p:nvSpPr>
-        <p:spPr>
-          <a:xfrm>
-            <a:off x="3594100" y="1625600"/>
-            <a:ext cx="11176000" cy="698500"/>
+          <p:cNvPr id="5" name="intro"/>
+          <p:cNvSpPr/>
+          <p:nvPr/>
+        </p:nvSpPr>
+        <p:spPr>
+          <a:xfrm>
+            <a:off x="508000" y="1371600"/>
+            <a:ext cx="14732000" cy="673100"/>
           </a:xfrm>
           <a:prstGeom prst="rect">
             <a:avLst/>
@@ -4461,7 +4397,7 @@
                 <a:ea typeface="Inter" pitchFamily="34" charset="-122"/>
                 <a:cs typeface="Inter" pitchFamily="34" charset="-120"/>
               </a:rPr>
-              <a:t>Use the actual task rather than a generic example. Start alone, then compare a few high-leverage decisions with course-alike colleagues.</a:t>
+              <a:t>Use your own Question 5 response or an anticipated response. Color-code the thinking to see what meeting the standard requires and what may be missing or confused for students.</a:t>
             </a:r>
             <a:endParaRPr lang="en-US" sz="2300" dirty="0"/>
           </a:p>
@@ -4469,24 +4405,24 @@
       </p:sp>
       <p:sp>
         <p:nvSpPr>
-          <p:cNvPr id="9" name="analysis-shape-8"/>
-          <p:cNvSpPr/>
-          <p:nvPr/>
-        </p:nvSpPr>
-        <p:spPr>
-          <a:xfrm>
-            <a:off x="508000" y="3098800"/>
-            <a:ext cx="7023100" cy="4445000"/>
-          </a:xfrm>
-          <a:prstGeom prst="rect">
-            <a:avLst/>
-          </a:prstGeom>
-          <a:solidFill>
-            <a:srgbClr val="F3F4F6"/>
-          </a:solidFill>
-          <a:ln w="12700">
+          <p:cNvPr id="6" name="analysis-shape-5"/>
+          <p:cNvSpPr/>
+          <p:nvPr/>
+        </p:nvSpPr>
+        <p:spPr>
+          <a:xfrm>
+            <a:off x="508000" y="2616200"/>
+            <a:ext cx="4508500" cy="3632200"/>
+          </a:xfrm>
+          <a:prstGeom prst="rect">
+            <a:avLst/>
+          </a:prstGeom>
+          <a:solidFill>
+            <a:srgbClr val="EAF5EC"/>
+          </a:solidFill>
+          <a:ln w="25400">
             <a:solidFill>
-              <a:srgbClr val="D1D5DB"/>
+              <a:srgbClr val="238636"/>
             </a:solidFill>
             <a:prstDash val="solid"/>
           </a:ln>
@@ -4494,14 +4430,14 @@
       </p:sp>
       <p:sp>
         <p:nvSpPr>
-          <p:cNvPr id="10" name="left-title"/>
-          <p:cNvSpPr/>
-          <p:nvPr/>
-        </p:nvSpPr>
-        <p:spPr>
-          <a:xfrm>
-            <a:off x="838200" y="3454400"/>
-            <a:ext cx="5969000" cy="406400"/>
+          <p:cNvPr id="7" name="claim-title"/>
+          <p:cNvSpPr/>
+          <p:nvPr/>
+        </p:nvSpPr>
+        <p:spPr>
+          <a:xfrm>
+            <a:off x="838200" y="2959100"/>
+            <a:ext cx="3810000" cy="381000"/>
           </a:xfrm>
           <a:prstGeom prst="rect">
             <a:avLst/>
@@ -4517,7 +4453,49 @@
               <a:buNone/>
             </a:pPr>
             <a:r>
-              <a:rPr lang="en-US" altLang="en-US" sz="2600" dirty="0">
+              <a:rPr lang="en-US" altLang="en-US" sz="2500" dirty="0">
+                <a:solidFill>
+                  <a:srgbClr val="238636"/>
+                </a:solidFill>
+                <a:latin typeface="Inter" pitchFamily="34" charset="0"/>
+                <a:ea typeface="Inter" pitchFamily="34" charset="-122"/>
+                <a:cs typeface="Inter" pitchFamily="34" charset="-120"/>
+              </a:rPr>
+              <a:t>CLAIM</a:t>
+            </a:r>
+            <a:endParaRPr lang="en-US" sz="2500" dirty="0"/>
+          </a:p>
+        </p:txBody>
+      </p:sp>
+      <p:sp>
+        <p:nvSpPr>
+          <p:cNvPr id="8" name="claim-copy"/>
+          <p:cNvSpPr/>
+          <p:nvPr/>
+        </p:nvSpPr>
+        <p:spPr>
+          <a:xfrm>
+            <a:off x="838200" y="3695700"/>
+            <a:ext cx="3810000" cy="1841500"/>
+          </a:xfrm>
+          <a:prstGeom prst="rect">
+            <a:avLst/>
+          </a:prstGeom>
+          <a:noFill/>
+          <a:ln/>
+        </p:spPr>
+        <p:txBody>
+          <a:bodyPr wrap="square" lIns="0" tIns="0" rIns="0" bIns="0" rtlCol="0" anchor="t"/>
+          <a:lstStyle/>
+          <a:p>
+            <a:pPr algn="l" indent="0" marL="0">
+              <a:lnSpc>
+                <a:spcPts val="2480"/>
+              </a:lnSpc>
+              <a:buNone/>
+            </a:pPr>
+            <a:r>
+              <a:rPr lang="en-US" altLang="en-US" sz="2000" b="1" dirty="0">
                 <a:solidFill>
                   <a:srgbClr val="3C4043"/>
                 </a:solidFill>
@@ -4525,45 +4503,33 @@
                 <a:ea typeface="Inter" pitchFamily="34" charset="-122"/>
                 <a:cs typeface="Inter" pitchFamily="34" charset="-120"/>
               </a:rPr>
-              <a:t>1. Place the task on the learning arc</a:t>
-            </a:r>
-            <a:endParaRPr lang="en-US" sz="2600" dirty="0"/>
-          </a:p>
-        </p:txBody>
-      </p:sp>
-      <p:sp>
-        <p:nvSpPr>
-          <p:cNvPr id="11" name="left-body"/>
-          <p:cNvSpPr/>
-          <p:nvPr/>
-        </p:nvSpPr>
-        <p:spPr>
-          <a:xfrm>
-            <a:off x="838200" y="4191000"/>
-            <a:ext cx="6096000" cy="2565400"/>
-          </a:xfrm>
-          <a:prstGeom prst="rect">
-            <a:avLst/>
-          </a:prstGeom>
-          <a:noFill/>
-          <a:ln/>
-        </p:spPr>
-        <p:txBody>
-          <a:bodyPr wrap="square" lIns="0" tIns="0" rIns="0" bIns="0" rtlCol="0" anchor="t"/>
-          <a:lstStyle/>
-          <a:p>
-            <a:pPr algn="l" marL="333375" indent="-333375">
+              <a:t>Complete:</a:t>
+            </a:r>
+            <a:r>
+              <a:rPr lang="en-US" altLang="en-US" sz="2000" dirty="0">
+                <a:solidFill>
+                  <a:srgbClr val="3C4043"/>
+                </a:solidFill>
+                <a:latin typeface="Inter" pitchFamily="34" charset="0"/>
+                <a:ea typeface="Inter" pitchFamily="34" charset="-122"/>
+                <a:cs typeface="Inter" pitchFamily="34" charset="-120"/>
+              </a:rPr>
+              <a:t> answers the prediction with an accurate conclusion.</a:t>
+            </a:r>
+            <a:endParaRPr lang="en-US" sz="2000" dirty="0"/>
+          </a:p>
+          <a:p>
+            <a:pPr algn="l" indent="0" marL="0">
               <a:lnSpc>
-                <a:spcPts val="2688"/>
+                <a:spcPts val="2480"/>
               </a:lnSpc>
               <a:spcBef>
-                <a:spcPts val="10"/>
+                <a:spcPts val="1000"/>
               </a:spcBef>
-              <a:buSzPct val="100000"/>
-              <a:buChar char="•"/>
-            </a:pPr>
-            <a:r>
-              <a:rPr lang="en-US" altLang="en-US" sz="2100" dirty="0">
+              <a:buNone/>
+            </a:pPr>
+            <a:r>
+              <a:rPr lang="en-US" altLang="en-US" sz="2000" b="1" dirty="0">
                 <a:solidFill>
                   <a:srgbClr val="3C4043"/>
                 </a:solidFill>
@@ -4571,23 +4537,150 @@
                 <a:ea typeface="Inter" pitchFamily="34" charset="-122"/>
                 <a:cs typeface="Inter" pitchFamily="34" charset="-120"/>
               </a:rPr>
-              <a:t>Priority standard and science skill</a:t>
-            </a:r>
-            <a:endParaRPr lang="en-US" sz="2100" dirty="0"/>
-          </a:p>
-          <a:p>
-            <a:pPr algn="l" marL="333375" indent="-333375">
+              <a:t>Anticipate:</a:t>
+            </a:r>
+            <a:r>
+              <a:rPr lang="en-US" altLang="en-US" sz="2000" dirty="0">
+                <a:solidFill>
+                  <a:srgbClr val="3C4043"/>
+                </a:solidFill>
+                <a:latin typeface="Inter" pitchFamily="34" charset="0"/>
+                <a:ea typeface="Inter" pitchFamily="34" charset="-122"/>
+                <a:cs typeface="Inter" pitchFamily="34" charset="-120"/>
+              </a:rPr>
+              <a:t> a vague prediction, an unsupported answer, or a claim that ignores the food-web relationship.</a:t>
+            </a:r>
+            <a:endParaRPr lang="en-US" sz="2000" dirty="0"/>
+          </a:p>
+        </p:txBody>
+      </p:sp>
+      <p:sp>
+        <p:nvSpPr>
+          <p:cNvPr id="9" name="analysis-shape-8"/>
+          <p:cNvSpPr/>
+          <p:nvPr/>
+        </p:nvSpPr>
+        <p:spPr>
+          <a:xfrm>
+            <a:off x="5880100" y="2616200"/>
+            <a:ext cx="4508500" cy="3632200"/>
+          </a:xfrm>
+          <a:prstGeom prst="rect">
+            <a:avLst/>
+          </a:prstGeom>
+          <a:solidFill>
+            <a:srgbClr val="EAF2FC"/>
+          </a:solidFill>
+          <a:ln w="25400">
+            <a:solidFill>
+              <a:srgbClr val="1D4ED8"/>
+            </a:solidFill>
+            <a:prstDash val="solid"/>
+          </a:ln>
+        </p:spPr>
+      </p:sp>
+      <p:sp>
+        <p:nvSpPr>
+          <p:cNvPr id="10" name="evidence-title"/>
+          <p:cNvSpPr/>
+          <p:nvPr/>
+        </p:nvSpPr>
+        <p:spPr>
+          <a:xfrm>
+            <a:off x="6210300" y="2959100"/>
+            <a:ext cx="3810000" cy="381000"/>
+          </a:xfrm>
+          <a:prstGeom prst="rect">
+            <a:avLst/>
+          </a:prstGeom>
+          <a:noFill/>
+          <a:ln/>
+        </p:spPr>
+        <p:txBody>
+          <a:bodyPr wrap="square" lIns="0" tIns="0" rIns="0" bIns="0" rtlCol="0" anchor="t"/>
+          <a:lstStyle/>
+          <a:p>
+            <a:pPr algn="l" indent="0" marL="0">
+              <a:buNone/>
+            </a:pPr>
+            <a:r>
+              <a:rPr lang="en-US" altLang="en-US" sz="2500" dirty="0">
+                <a:solidFill>
+                  <a:srgbClr val="1D4ED8"/>
+                </a:solidFill>
+                <a:latin typeface="Inter" pitchFamily="34" charset="0"/>
+                <a:ea typeface="Inter" pitchFamily="34" charset="-122"/>
+                <a:cs typeface="Inter" pitchFamily="34" charset="-120"/>
+              </a:rPr>
+              <a:t>EVIDENCE</a:t>
+            </a:r>
+            <a:endParaRPr lang="en-US" sz="2500" dirty="0"/>
+          </a:p>
+        </p:txBody>
+      </p:sp>
+      <p:sp>
+        <p:nvSpPr>
+          <p:cNvPr id="11" name="evidence-copy"/>
+          <p:cNvSpPr/>
+          <p:nvPr/>
+        </p:nvSpPr>
+        <p:spPr>
+          <a:xfrm>
+            <a:off x="6210300" y="3695700"/>
+            <a:ext cx="3810000" cy="1841500"/>
+          </a:xfrm>
+          <a:prstGeom prst="rect">
+            <a:avLst/>
+          </a:prstGeom>
+          <a:noFill/>
+          <a:ln/>
+        </p:spPr>
+        <p:txBody>
+          <a:bodyPr wrap="square" lIns="0" tIns="0" rIns="0" bIns="0" rtlCol="0" anchor="t"/>
+          <a:lstStyle/>
+          <a:p>
+            <a:pPr algn="l" indent="0" marL="0">
               <a:lnSpc>
-                <a:spcPts val="2688"/>
+                <a:spcPts val="2480"/>
+              </a:lnSpc>
+              <a:buNone/>
+            </a:pPr>
+            <a:r>
+              <a:rPr lang="en-US" altLang="en-US" sz="2000" b="1" dirty="0">
+                <a:solidFill>
+                  <a:srgbClr val="3C4043"/>
+                </a:solidFill>
+                <a:latin typeface="Inter" pitchFamily="34" charset="0"/>
+                <a:ea typeface="Inter" pitchFamily="34" charset="-122"/>
+                <a:cs typeface="Inter" pitchFamily="34" charset="-120"/>
+              </a:rPr>
+              <a:t>Complete:</a:t>
+            </a:r>
+            <a:r>
+              <a:rPr lang="en-US" altLang="en-US" sz="2000" dirty="0">
+                <a:solidFill>
+                  <a:srgbClr val="3C4043"/>
+                </a:solidFill>
+                <a:latin typeface="Inter" pitchFamily="34" charset="0"/>
+                <a:ea typeface="Inter" pitchFamily="34" charset="-122"/>
+                <a:cs typeface="Inter" pitchFamily="34" charset="-120"/>
+              </a:rPr>
+              <a:t> selects accurate details from the graph and food web.</a:t>
+            </a:r>
+            <a:endParaRPr lang="en-US" sz="2000" dirty="0"/>
+          </a:p>
+          <a:p>
+            <a:pPr algn="l" indent="0" marL="0">
+              <a:lnSpc>
+                <a:spcPts val="2480"/>
               </a:lnSpc>
               <a:spcBef>
-                <a:spcPts val="10"/>
+                <a:spcPts val="1000"/>
               </a:spcBef>
-              <a:buSzPct val="100000"/>
-              <a:buChar char="•"/>
-            </a:pPr>
-            <a:r>
-              <a:rPr lang="en-US" altLang="en-US" sz="2100" dirty="0">
+              <a:buNone/>
+            </a:pPr>
+            <a:r>
+              <a:rPr lang="en-US" altLang="en-US" sz="2000" b="1" dirty="0">
                 <a:solidFill>
                   <a:srgbClr val="3C4043"/>
                 </a:solidFill>
@@ -4595,23 +4688,150 @@
                 <a:ea typeface="Inter" pitchFamily="34" charset="-122"/>
                 <a:cs typeface="Inter" pitchFamily="34" charset="-120"/>
               </a:rPr>
-              <a:t>Writing prompt and student product</a:t>
-            </a:r>
-            <a:endParaRPr lang="en-US" sz="2100" dirty="0"/>
-          </a:p>
-          <a:p>
-            <a:pPr algn="l" marL="333375" indent="-333375">
+              <a:t>Anticipate:</a:t>
+            </a:r>
+            <a:r>
+              <a:rPr lang="en-US" altLang="en-US" sz="2000" dirty="0">
+                <a:solidFill>
+                  <a:srgbClr val="3C4043"/>
+                </a:solidFill>
+                <a:latin typeface="Inter" pitchFamily="34" charset="0"/>
+                <a:ea typeface="Inter" pitchFamily="34" charset="-122"/>
+                <a:cs typeface="Inter" pitchFamily="34" charset="-120"/>
+              </a:rPr>
+              <a:t> a detail is copied without relevance, inaccurate, or drawn from only one visual.</a:t>
+            </a:r>
+            <a:endParaRPr lang="en-US" sz="2000" dirty="0"/>
+          </a:p>
+        </p:txBody>
+      </p:sp>
+      <p:sp>
+        <p:nvSpPr>
+          <p:cNvPr id="12" name="analysis-shape-11"/>
+          <p:cNvSpPr/>
+          <p:nvPr/>
+        </p:nvSpPr>
+        <p:spPr>
+          <a:xfrm>
+            <a:off x="11252200" y="2616200"/>
+            <a:ext cx="4495800" cy="3632200"/>
+          </a:xfrm>
+          <a:prstGeom prst="rect">
+            <a:avLst/>
+          </a:prstGeom>
+          <a:solidFill>
+            <a:srgbClr val="FFF1E7"/>
+          </a:solidFill>
+          <a:ln w="25400">
+            <a:solidFill>
+              <a:srgbClr val="C56B00"/>
+            </a:solidFill>
+            <a:prstDash val="solid"/>
+          </a:ln>
+        </p:spPr>
+      </p:sp>
+      <p:sp>
+        <p:nvSpPr>
+          <p:cNvPr id="13" name="reasoning-title"/>
+          <p:cNvSpPr/>
+          <p:nvPr/>
+        </p:nvSpPr>
+        <p:spPr>
+          <a:xfrm>
+            <a:off x="11582400" y="2959100"/>
+            <a:ext cx="3810000" cy="381000"/>
+          </a:xfrm>
+          <a:prstGeom prst="rect">
+            <a:avLst/>
+          </a:prstGeom>
+          <a:noFill/>
+          <a:ln/>
+        </p:spPr>
+        <p:txBody>
+          <a:bodyPr wrap="square" lIns="0" tIns="0" rIns="0" bIns="0" rtlCol="0" anchor="t"/>
+          <a:lstStyle/>
+          <a:p>
+            <a:pPr algn="l" indent="0" marL="0">
+              <a:buNone/>
+            </a:pPr>
+            <a:r>
+              <a:rPr lang="en-US" altLang="en-US" sz="2500" dirty="0">
+                <a:solidFill>
+                  <a:srgbClr val="C56B00"/>
+                </a:solidFill>
+                <a:latin typeface="Inter" pitchFamily="34" charset="0"/>
+                <a:ea typeface="Inter" pitchFamily="34" charset="-122"/>
+                <a:cs typeface="Inter" pitchFamily="34" charset="-120"/>
+              </a:rPr>
+              <a:t>REASONING</a:t>
+            </a:r>
+            <a:endParaRPr lang="en-US" sz="2500" dirty="0"/>
+          </a:p>
+        </p:txBody>
+      </p:sp>
+      <p:sp>
+        <p:nvSpPr>
+          <p:cNvPr id="14" name="reasoning-copy"/>
+          <p:cNvSpPr/>
+          <p:nvPr/>
+        </p:nvSpPr>
+        <p:spPr>
+          <a:xfrm>
+            <a:off x="11582400" y="3695700"/>
+            <a:ext cx="3810000" cy="1841500"/>
+          </a:xfrm>
+          <a:prstGeom prst="rect">
+            <a:avLst/>
+          </a:prstGeom>
+          <a:noFill/>
+          <a:ln/>
+        </p:spPr>
+        <p:txBody>
+          <a:bodyPr wrap="square" lIns="0" tIns="0" rIns="0" bIns="0" rtlCol="0" anchor="t"/>
+          <a:lstStyle/>
+          <a:p>
+            <a:pPr algn="l" indent="0" marL="0">
               <a:lnSpc>
-                <a:spcPts val="2688"/>
+                <a:spcPts val="2480"/>
+              </a:lnSpc>
+              <a:buNone/>
+            </a:pPr>
+            <a:r>
+              <a:rPr lang="en-US" altLang="en-US" sz="2000" b="1" dirty="0">
+                <a:solidFill>
+                  <a:srgbClr val="3C4043"/>
+                </a:solidFill>
+                <a:latin typeface="Inter" pitchFamily="34" charset="0"/>
+                <a:ea typeface="Inter" pitchFamily="34" charset="-122"/>
+                <a:cs typeface="Inter" pitchFamily="34" charset="-120"/>
+              </a:rPr>
+              <a:t>Complete:</a:t>
+            </a:r>
+            <a:r>
+              <a:rPr lang="en-US" altLang="en-US" sz="2000" dirty="0">
+                <a:solidFill>
+                  <a:srgbClr val="3C4043"/>
+                </a:solidFill>
+                <a:latin typeface="Inter" pitchFamily="34" charset="0"/>
+                <a:ea typeface="Inter" pitchFamily="34" charset="-122"/>
+                <a:cs typeface="Inter" pitchFamily="34" charset="-120"/>
+              </a:rPr>
+              <a:t> explains why the selected evidence supports the scientific prediction.</a:t>
+            </a:r>
+            <a:endParaRPr lang="en-US" sz="2000" dirty="0"/>
+          </a:p>
+          <a:p>
+            <a:pPr algn="l" indent="0" marL="0">
+              <a:lnSpc>
+                <a:spcPts val="2480"/>
               </a:lnSpc>
               <a:spcBef>
-                <a:spcPts val="10"/>
+                <a:spcPts val="1000"/>
               </a:spcBef>
-              <a:buSzPct val="100000"/>
-              <a:buChar char="•"/>
-            </a:pPr>
-            <a:r>
-              <a:rPr lang="en-US" altLang="en-US" sz="2100" dirty="0">
+              <a:buNone/>
+            </a:pPr>
+            <a:r>
+              <a:rPr lang="en-US" altLang="en-US" sz="2000" b="1" dirty="0">
                 <a:solidFill>
                   <a:srgbClr val="3C4043"/>
                 </a:solidFill>
@@ -4619,23 +4839,10 @@
                 <a:ea typeface="Inter" pitchFamily="34" charset="-122"/>
                 <a:cs typeface="Inter" pitchFamily="34" charset="-120"/>
               </a:rPr>
-              <a:t>Source, data, model, or investigation evidence</a:t>
-            </a:r>
-            <a:endParaRPr lang="en-US" sz="2100" dirty="0"/>
-          </a:p>
-          <a:p>
-            <a:pPr algn="l" marL="333375" indent="-333375">
-              <a:lnSpc>
-                <a:spcPts val="2688"/>
-              </a:lnSpc>
-              <a:spcBef>
-                <a:spcPts val="10"/>
-              </a:spcBef>
-              <a:buSzPct val="100000"/>
-              <a:buChar char="•"/>
-            </a:pPr>
-            <a:r>
-              <a:rPr lang="en-US" altLang="en-US" sz="2100" dirty="0">
+              <a:t>Anticipate:</a:t>
+            </a:r>
+            <a:r>
+              <a:rPr lang="en-US" altLang="en-US" sz="2000" dirty="0">
                 <a:solidFill>
                   <a:srgbClr val="3C4043"/>
                 </a:solidFill>
@@ -4643,22 +4850,22 @@
                 <a:ea typeface="Inter" pitchFamily="34" charset="-122"/>
                 <a:cs typeface="Inter" pitchFamily="34" charset="-120"/>
               </a:rPr>
-              <a:t>Success criteria: what must be visible?</a:t>
-            </a:r>
-            <a:endParaRPr lang="en-US" sz="2100" dirty="0"/>
-          </a:p>
-        </p:txBody>
-      </p:sp>
-      <p:sp>
-        <p:nvSpPr>
-          <p:cNvPr id="12" name="analysis-shape-11"/>
-          <p:cNvSpPr/>
-          <p:nvPr/>
-        </p:nvSpPr>
-        <p:spPr>
-          <a:xfrm>
-            <a:off x="8039100" y="3098800"/>
-            <a:ext cx="7708900" cy="4445000"/>
+              <a:t> evidence is listed but not connected to population relationships or carrying capacity.</a:t>
+            </a:r>
+            <a:endParaRPr lang="en-US" sz="2000" dirty="0"/>
+          </a:p>
+        </p:txBody>
+      </p:sp>
+      <p:sp>
+        <p:nvSpPr>
+          <p:cNvPr id="15" name="analysis-shape-14"/>
+          <p:cNvSpPr/>
+          <p:nvPr/>
+        </p:nvSpPr>
+        <p:spPr>
+          <a:xfrm>
+            <a:off x="508000" y="6908800"/>
+            <a:ext cx="15240000" cy="990600"/>
           </a:xfrm>
           <a:prstGeom prst="rect">
             <a:avLst/>
@@ -4666,7 +4873,7 @@
           <a:solidFill>
             <a:srgbClr val="FCE8EA"/>
           </a:solidFill>
-          <a:ln w="25400">
+          <a:ln w="12700">
             <a:solidFill>
               <a:srgbClr val="C41220"/>
             </a:solidFill>
@@ -4676,14 +4883,14 @@
       </p:sp>
       <p:sp>
         <p:nvSpPr>
-          <p:cNvPr id="13" name="right-title"/>
-          <p:cNvSpPr/>
-          <p:nvPr/>
-        </p:nvSpPr>
-        <p:spPr>
-          <a:xfrm>
-            <a:off x="8369300" y="3454400"/>
-            <a:ext cx="6604000" cy="406400"/>
+          <p:cNvPr id="16" name="reflection"/>
+          <p:cNvSpPr/>
+          <p:nvPr/>
+        </p:nvSpPr>
+        <p:spPr>
+          <a:xfrm>
+            <a:off x="838200" y="7124700"/>
+            <a:ext cx="14478000" cy="546100"/>
           </a:xfrm>
           <a:prstGeom prst="rect">
             <a:avLst/>
@@ -4695,11 +4902,25 @@
           <a:bodyPr wrap="square" lIns="0" tIns="0" rIns="0" bIns="0" rtlCol="0" anchor="t"/>
           <a:lstStyle/>
           <a:p>
-            <a:pPr algn="l" indent="0" marL="0">
-              <a:buNone/>
-            </a:pPr>
-            <a:r>
-              <a:rPr lang="en-US" altLang="en-US" sz="2600" dirty="0">
+            <a:pPr algn="ctr" indent="0" marL="0">
+              <a:lnSpc>
+                <a:spcPts val="2478"/>
+              </a:lnSpc>
+              <a:buNone/>
+            </a:pPr>
+            <a:r>
+              <a:rPr lang="en-US" altLang="en-US" sz="2100" b="1" dirty="0">
+                <a:solidFill>
+                  <a:srgbClr val="C41220"/>
+                </a:solidFill>
+                <a:latin typeface="Inter" pitchFamily="34" charset="0"/>
+                <a:ea typeface="Inter" pitchFamily="34" charset="-122"/>
+                <a:cs typeface="Inter" pitchFamily="34" charset="-120"/>
+              </a:rPr>
+              <a:t>Share the reflection:</a:t>
+            </a:r>
+            <a:r>
+              <a:rPr lang="en-US" altLang="en-US" sz="2100" dirty="0">
                 <a:solidFill>
                   <a:srgbClr val="3C4043"/>
                 </a:solidFill>
@@ -4707,183 +4928,15 @@
                 <a:ea typeface="Inter" pitchFamily="34" charset="-122"/>
                 <a:cs typeface="Inter" pitchFamily="34" charset="-120"/>
               </a:rPr>
-              <a:t>2. Anticipate + judge the CER response</a:t>
-            </a:r>
-            <a:endParaRPr lang="en-US" sz="2600" dirty="0"/>
-          </a:p>
-        </p:txBody>
-      </p:sp>
-      <p:sp>
-        <p:nvSpPr>
-          <p:cNvPr id="14" name="right-body"/>
-          <p:cNvSpPr/>
-          <p:nvPr/>
-        </p:nvSpPr>
-        <p:spPr>
-          <a:xfrm>
-            <a:off x="8369300" y="4191000"/>
-            <a:ext cx="6731000" cy="2565400"/>
-          </a:xfrm>
-          <a:prstGeom prst="rect">
-            <a:avLst/>
-          </a:prstGeom>
-          <a:noFill/>
-          <a:ln/>
-        </p:spPr>
-        <p:txBody>
-          <a:bodyPr wrap="square" lIns="0" tIns="0" rIns="0" bIns="0" rtlCol="0" anchor="t"/>
-          <a:lstStyle/>
-          <a:p>
-            <a:pPr algn="l" marL="333375" indent="-333375">
-              <a:lnSpc>
-                <a:spcPts val="2688"/>
-              </a:lnSpc>
-              <a:spcBef>
-                <a:spcPts val="10"/>
-              </a:spcBef>
-              <a:buSzPct val="100000"/>
-              <a:buChar char="•"/>
-            </a:pPr>
-            <a:r>
-              <a:rPr lang="en-US" altLang="en-US" sz="2100" dirty="0">
-                <a:solidFill>
-                  <a:srgbClr val="3C4043"/>
-                </a:solidFill>
-                <a:latin typeface="Inter" pitchFamily="34" charset="0"/>
-                <a:ea typeface="Inter" pitchFamily="34" charset="-122"/>
-                <a:cs typeface="Inter" pitchFamily="34" charset="-120"/>
-              </a:rPr>
-              <a:t>What claim, evidence, and reasoning would meet the standard?</a:t>
+              <a:t> Which mistake reflects a science misconception, a source-analysis need, or a writing/reasoning barrier? What would students need to do next?</a:t>
             </a:r>
             <a:endParaRPr lang="en-US" sz="2100" dirty="0"/>
           </a:p>
-          <a:p>
-            <a:pPr algn="l" marL="333375" indent="-333375">
-              <a:lnSpc>
-                <a:spcPts val="2688"/>
-              </a:lnSpc>
-              <a:spcBef>
-                <a:spcPts val="10"/>
-              </a:spcBef>
-              <a:buSzPct val="100000"/>
-              <a:buChar char="•"/>
-            </a:pPr>
-            <a:r>
-              <a:rPr lang="en-US" altLang="en-US" sz="2100" dirty="0">
-                <a:solidFill>
-                  <a:srgbClr val="3C4043"/>
-                </a:solidFill>
-                <a:latin typeface="Inter" pitchFamily="34" charset="0"/>
-                <a:ea typeface="Inter" pitchFamily="34" charset="-122"/>
-                <a:cs typeface="Inter" pitchFamily="34" charset="-120"/>
-              </a:rPr>
-              <a:t>What partial response is likely?</a:t>
-            </a:r>
-            <a:endParaRPr lang="en-US" sz="2100" dirty="0"/>
-          </a:p>
-          <a:p>
-            <a:pPr algn="l" marL="333375" indent="-333375">
-              <a:lnSpc>
-                <a:spcPts val="2688"/>
-              </a:lnSpc>
-              <a:spcBef>
-                <a:spcPts val="10"/>
-              </a:spcBef>
-              <a:buSzPct val="100000"/>
-              <a:buChar char="•"/>
-            </a:pPr>
-            <a:r>
-              <a:rPr lang="en-US" altLang="en-US" sz="2100" dirty="0">
-                <a:solidFill>
-                  <a:srgbClr val="3C4043"/>
-                </a:solidFill>
-                <a:latin typeface="Inter" pitchFamily="34" charset="0"/>
-                <a:ea typeface="Inter" pitchFamily="34" charset="-122"/>
-                <a:cs typeface="Inter" pitchFamily="34" charset="-120"/>
-              </a:rPr>
-              <a:t>Where may students confuse evidence and reasoning?</a:t>
-            </a:r>
-            <a:endParaRPr lang="en-US" sz="2100" dirty="0"/>
-          </a:p>
-          <a:p>
-            <a:pPr algn="l" marL="333375" indent="-333375">
-              <a:lnSpc>
-                <a:spcPts val="2688"/>
-              </a:lnSpc>
-              <a:spcBef>
-                <a:spcPts val="10"/>
-              </a:spcBef>
-              <a:buSzPct val="100000"/>
-              <a:buChar char="•"/>
-            </a:pPr>
-            <a:r>
-              <a:rPr lang="en-US" altLang="en-US" sz="2100" dirty="0">
-                <a:solidFill>
-                  <a:srgbClr val="3C4043"/>
-                </a:solidFill>
-                <a:latin typeface="Inter" pitchFamily="34" charset="0"/>
-                <a:ea typeface="Inter" pitchFamily="34" charset="-122"/>
-                <a:cs typeface="Inter" pitchFamily="34" charset="-120"/>
-              </a:rPr>
-              <a:t>What feedback prompt could lead students to complete or revise CER?</a:t>
-            </a:r>
-            <a:endParaRPr lang="en-US" sz="2100" dirty="0"/>
-          </a:p>
-        </p:txBody>
-      </p:sp>
-      <p:sp>
-        <p:nvSpPr>
-          <p:cNvPr id="15" name="bottom"/>
-          <p:cNvSpPr/>
-          <p:nvPr/>
-        </p:nvSpPr>
-        <p:spPr>
-          <a:xfrm>
-            <a:off x="508000" y="8001000"/>
-            <a:ext cx="13843000" cy="330200"/>
-          </a:xfrm>
-          <a:prstGeom prst="rect">
-            <a:avLst/>
-          </a:prstGeom>
-          <a:noFill/>
-          <a:ln/>
-        </p:spPr>
-        <p:txBody>
-          <a:bodyPr wrap="square" lIns="0" tIns="0" rIns="0" bIns="0" rtlCol="0" anchor="t"/>
-          <a:lstStyle/>
-          <a:p>
-            <a:pPr algn="l" indent="0" marL="0">
-              <a:buNone/>
-            </a:pPr>
-            <a:r>
-              <a:rPr lang="en-US" altLang="en-US" sz="1900" b="1" dirty="0">
-                <a:solidFill>
-                  <a:srgbClr val="C41220"/>
-                </a:solidFill>
-                <a:latin typeface="Inter" pitchFamily="34" charset="0"/>
-                <a:ea typeface="Inter" pitchFamily="34" charset="-122"/>
-                <a:cs typeface="Inter" pitchFamily="34" charset="-120"/>
-              </a:rPr>
-              <a:t>LIT connection:</a:t>
-            </a:r>
-            <a:r>
-              <a:rPr lang="en-US" altLang="en-US" sz="1900" dirty="0">
-                <a:solidFill>
-                  <a:srgbClr val="3C4043"/>
-                </a:solidFill>
-                <a:latin typeface="Inter" pitchFamily="34" charset="0"/>
-                <a:ea typeface="Inter" pitchFamily="34" charset="-122"/>
-                <a:cs typeface="Inter" pitchFamily="34" charset="-120"/>
-              </a:rPr>
-              <a:t> Every Day Questions 1, 3, and 4; Team Deep Dive Steps 2–4. Keep the same task at the center.</a:t>
-            </a:r>
-            <a:endParaRPr lang="en-US" sz="1900" dirty="0"/>
-          </a:p>
-        </p:txBody>
-      </p:sp>
-      <p:sp>
-        <p:nvSpPr>
-          <p:cNvPr id="16" name="page"/>
+        </p:txBody>
+      </p:sp>
+      <p:sp>
+        <p:nvSpPr>
+          <p:cNvPr id="17" name="page"/>
           <p:cNvSpPr/>
           <p:nvPr/>
         </p:nvSpPr>
@@ -4922,7 +4975,7 @@
       </p:sp>
       <p:sp>
         <p:nvSpPr>
-          <p:cNvPr id="17" name="analysis-shape-16"/>
+          <p:cNvPr id="18" name="analysis-shape-17"/>
           <p:cNvSpPr/>
           <p:nvPr/>
         </p:nvSpPr>
@@ -5025,7 +5078,7 @@
                 <a:ea typeface="Inter" pitchFamily="34" charset="-122"/>
                 <a:cs typeface="Inter" pitchFamily="34" charset="-120"/>
               </a:rPr>
-              <a:t>Protected Course-Alike Planning Time</a:t>
+              <a:t>Reflect With the Lesson Internalization Tool</a:t>
             </a:r>
             <a:endParaRPr lang="en-US" sz="3000" dirty="0"/>
           </a:p>
@@ -5064,7 +5117,7 @@
                 <a:ea typeface="Inter" pitchFamily="34" charset="-122"/>
                 <a:cs typeface="Inter" pitchFamily="34" charset="-120"/>
               </a:rPr>
-              <a:t>25:00–36:00  •  11 MIN</a:t>
+              <a:t>31:00–39:00  •  8 MIN</a:t>
             </a:r>
             <a:endParaRPr lang="en-US" sz="1600" dirty="0"/>
           </a:p>
@@ -5098,8 +5151,8 @@
         </p:nvSpPr>
         <p:spPr>
           <a:xfrm>
-            <a:off x="863600" y="2247900"/>
-            <a:ext cx="3098800" cy="355600"/>
+            <a:off x="863600" y="2197100"/>
+            <a:ext cx="3098800" cy="330200"/>
           </a:xfrm>
           <a:prstGeom prst="rect">
             <a:avLst/>
@@ -5123,7 +5176,7 @@
                 <a:ea typeface="Inter" pitchFamily="34" charset="-122"/>
                 <a:cs typeface="Inter" pitchFamily="34" charset="-120"/>
               </a:rPr>
-              <a:t>PROTECTED INDIVIDUAL-FIRST WORK</a:t>
+              <a:t>INDIVIDUAL-FIRST REFLECTION</a:t>
             </a:r>
             <a:endParaRPr lang="en-US" sz="1800" dirty="0"/>
           </a:p>
@@ -5162,7 +5215,7 @@
                 <a:ea typeface="Inter" pitchFamily="34" charset="-122"/>
                 <a:cs typeface="Inter" pitchFamily="34" charset="-120"/>
               </a:rPr>
-              <a:t>11 min</a:t>
+              <a:t>8 min</a:t>
             </a:r>
             <a:endParaRPr lang="en-US" sz="7400" dirty="0"/>
           </a:p>
@@ -5198,7 +5251,7 @@
         </p:nvSpPr>
         <p:spPr>
           <a:xfrm>
-            <a:off x="901700" y="5384800"/>
+            <a:off x="901700" y="5372100"/>
             <a:ext cx="3022600" cy="1117600"/>
           </a:xfrm>
           <a:prstGeom prst="rect">
@@ -5226,7 +5279,7 @@
                 <a:ea typeface="Inter" pitchFamily="34" charset="-122"/>
                 <a:cs typeface="Inter" pitchFamily="34" charset="-120"/>
               </a:rPr>
-              <a:t>Draft independently first. Then use your course-alike to sharpen one decision about student thinking.</a:t>
+              <a:t>Record your own analysis first. Then share one high-leverage implication with colleagues.</a:t>
             </a:r>
             <a:endParaRPr lang="en-US" sz="2000" dirty="0"/>
           </a:p>
@@ -5259,14 +5312,14 @@
       </p:sp>
       <p:sp>
         <p:nvSpPr>
-          <p:cNvPr id="11" name="one-title"/>
+          <p:cNvPr id="11" name="one"/>
           <p:cNvSpPr/>
           <p:nvPr/>
         </p:nvSpPr>
         <p:spPr>
           <a:xfrm>
             <a:off x="5181600" y="1854200"/>
-            <a:ext cx="4953000" cy="342900"/>
+            <a:ext cx="9842500" cy="838200"/>
           </a:xfrm>
           <a:prstGeom prst="rect">
             <a:avLst/>
@@ -5279,10 +5332,24 @@
           <a:lstStyle/>
           <a:p>
             <a:pPr algn="l" indent="0" marL="0">
-              <a:buNone/>
-            </a:pPr>
-            <a:r>
-              <a:rPr lang="en-US" altLang="en-US" sz="2400" dirty="0">
+              <a:lnSpc>
+                <a:spcPts val="2400"/>
+              </a:lnSpc>
+              <a:buNone/>
+            </a:pPr>
+            <a:r>
+              <a:rPr lang="en-US" altLang="en-US" sz="2000" b="1" dirty="0">
+                <a:solidFill>
+                  <a:srgbClr val="C41220"/>
+                </a:solidFill>
+                <a:latin typeface="Inter" pitchFamily="34" charset="0"/>
+                <a:ea typeface="Inter" pitchFamily="34" charset="-122"/>
+                <a:cs typeface="Inter" pitchFamily="34" charset="-120"/>
+              </a:rPr>
+              <a:t>1. Every Day Question 1 — What are students learning and how will they show it?</a:t>
+            </a:r>
+            <a:r>
+              <a:rPr lang="en-US" altLang="en-US" sz="2000" dirty="0">
                 <a:solidFill>
                   <a:srgbClr val="3C4043"/>
                 </a:solidFill>
@@ -5290,54 +5357,15 @@
                 <a:ea typeface="Inter" pitchFamily="34" charset="-122"/>
                 <a:cs typeface="Inter" pitchFamily="34" charset="-120"/>
               </a:rPr>
-              <a:t>1. NAME THE TASK + BAR FOR MASTERY</a:t>
-            </a:r>
-            <a:endParaRPr lang="en-US" sz="2400" dirty="0"/>
-          </a:p>
-        </p:txBody>
-      </p:sp>
-      <p:sp>
-        <p:nvSpPr>
-          <p:cNvPr id="12" name="one-body"/>
-          <p:cNvSpPr/>
-          <p:nvPr/>
-        </p:nvSpPr>
-        <p:spPr>
-          <a:xfrm>
-            <a:off x="5181600" y="2336800"/>
-            <a:ext cx="9842500" cy="469900"/>
-          </a:xfrm>
-          <a:prstGeom prst="rect">
-            <a:avLst/>
-          </a:prstGeom>
-          <a:noFill/>
-          <a:ln/>
-        </p:spPr>
-        <p:txBody>
-          <a:bodyPr wrap="square" lIns="0" tIns="0" rIns="0" bIns="0" rtlCol="0" anchor="t"/>
-          <a:lstStyle/>
-          <a:p>
-            <a:pPr algn="l" indent="0" marL="0">
-              <a:buNone/>
-            </a:pPr>
-            <a:r>
-              <a:rPr lang="en-US" altLang="en-US" sz="2100" dirty="0">
-                <a:solidFill>
-                  <a:srgbClr val="3C4043"/>
-                </a:solidFill>
-                <a:latin typeface="Inter" pitchFamily="34" charset="0"/>
-                <a:ea typeface="Inter" pitchFamily="34" charset="-122"/>
-                <a:cs typeface="Inter" pitchFamily="34" charset="-120"/>
-              </a:rPr>
-              <a:t>Record the writing task, source/evidence, priority criterion, and what a successful response must make visible.</a:t>
-            </a:r>
-            <a:endParaRPr lang="en-US" sz="2100" dirty="0"/>
-          </a:p>
-        </p:txBody>
-      </p:sp>
-      <p:sp>
-        <p:nvSpPr>
-          <p:cNvPr id="13" name="worktime-shape-12"/>
+              <a:t> Name the standard, prompt, texts/visuals, student product, and clear bar for mastery.</a:t>
+            </a:r>
+            <a:endParaRPr lang="en-US" sz="2000" dirty="0"/>
+          </a:p>
+        </p:txBody>
+      </p:sp>
+      <p:sp>
+        <p:nvSpPr>
+          <p:cNvPr id="12" name="worktime-shape-11"/>
           <p:cNvSpPr/>
           <p:nvPr/>
         </p:nvSpPr>
@@ -5362,14 +5390,14 @@
       </p:sp>
       <p:sp>
         <p:nvSpPr>
-          <p:cNvPr id="14" name="two-title"/>
+          <p:cNvPr id="13" name="two"/>
           <p:cNvSpPr/>
           <p:nvPr/>
         </p:nvSpPr>
         <p:spPr>
           <a:xfrm>
             <a:off x="5181600" y="3683000"/>
-            <a:ext cx="8001000" cy="342900"/>
+            <a:ext cx="9842500" cy="838200"/>
           </a:xfrm>
           <a:prstGeom prst="rect">
             <a:avLst/>
@@ -5382,10 +5410,24 @@
           <a:lstStyle/>
           <a:p>
             <a:pPr algn="l" indent="0" marL="0">
-              <a:buNone/>
-            </a:pPr>
-            <a:r>
-              <a:rPr lang="en-US" altLang="en-US" sz="2400" dirty="0">
+              <a:lnSpc>
+                <a:spcPts val="2400"/>
+              </a:lnSpc>
+              <a:buNone/>
+            </a:pPr>
+            <a:r>
+              <a:rPr lang="en-US" altLang="en-US" sz="2000" b="1" dirty="0">
+                <a:solidFill>
+                  <a:srgbClr val="C41220"/>
+                </a:solidFill>
+                <a:latin typeface="Inter" pitchFamily="34" charset="0"/>
+                <a:ea typeface="Inter" pitchFamily="34" charset="-122"/>
+                <a:cs typeface="Inter" pitchFamily="34" charset="-120"/>
+              </a:rPr>
+              <a:t>2. Every Day Question 3 / Deep Dive Steps 2–4 — What might students do?</a:t>
+            </a:r>
+            <a:r>
+              <a:rPr lang="en-US" altLang="en-US" sz="2000" dirty="0">
                 <a:solidFill>
                   <a:srgbClr val="3C4043"/>
                 </a:solidFill>
@@ -5393,54 +5435,15 @@
                 <a:ea typeface="Inter" pitchFamily="34" charset="-122"/>
                 <a:cs typeface="Inter" pitchFamily="34" charset="-120"/>
               </a:rPr>
-              <a:t>2. ANTICIPATE + JUDGE A CER RESPONSE</a:t>
-            </a:r>
-            <a:endParaRPr lang="en-US" sz="2400" dirty="0"/>
-          </a:p>
-        </p:txBody>
-      </p:sp>
-      <p:sp>
-        <p:nvSpPr>
-          <p:cNvPr id="15" name="two-body"/>
-          <p:cNvSpPr/>
-          <p:nvPr/>
-        </p:nvSpPr>
-        <p:spPr>
-          <a:xfrm>
-            <a:off x="5181600" y="4165600"/>
-            <a:ext cx="9842500" cy="469900"/>
-          </a:xfrm>
-          <a:prstGeom prst="rect">
-            <a:avLst/>
-          </a:prstGeom>
-          <a:noFill/>
-          <a:ln/>
-        </p:spPr>
-        <p:txBody>
-          <a:bodyPr wrap="square" lIns="0" tIns="0" rIns="0" bIns="0" rtlCol="0" anchor="t"/>
-          <a:lstStyle/>
-          <a:p>
-            <a:pPr algn="l" indent="0" marL="0">
-              <a:buNone/>
-            </a:pPr>
-            <a:r>
-              <a:rPr lang="en-US" altLang="en-US" sz="2100" dirty="0">
-                <a:solidFill>
-                  <a:srgbClr val="3C4043"/>
-                </a:solidFill>
-                <a:latin typeface="Inter" pitchFamily="34" charset="0"/>
-                <a:ea typeface="Inter" pitchFamily="34" charset="-122"/>
-                <a:cs typeface="Inter" pitchFamily="34" charset="-120"/>
-              </a:rPr>
-              <a:t>Name what a complete response meeting the standard shows and what may be partial, missing, or confused.</a:t>
-            </a:r>
-            <a:endParaRPr lang="en-US" sz="2100" dirty="0"/>
-          </a:p>
-        </p:txBody>
-      </p:sp>
-      <p:sp>
-        <p:nvSpPr>
-          <p:cNvPr id="16" name="worktime-shape-15"/>
+              <a:t> Record one likely complete response, partial response, question, or mistake and why it may occur.</a:t>
+            </a:r>
+            <a:endParaRPr lang="en-US" sz="2000" dirty="0"/>
+          </a:p>
+        </p:txBody>
+      </p:sp>
+      <p:sp>
+        <p:nvSpPr>
+          <p:cNvPr id="14" name="worktime-shape-13"/>
           <p:cNvSpPr/>
           <p:nvPr/>
         </p:nvSpPr>
@@ -5465,53 +5468,14 @@
       </p:sp>
       <p:sp>
         <p:nvSpPr>
-          <p:cNvPr id="17" name="three-title"/>
-          <p:cNvSpPr/>
-          <p:nvPr/>
-        </p:nvSpPr>
-        <p:spPr>
-          <a:xfrm>
-            <a:off x="5181600" y="5524500"/>
-            <a:ext cx="7874000" cy="342900"/>
-          </a:xfrm>
-          <a:prstGeom prst="rect">
-            <a:avLst/>
-          </a:prstGeom>
-          <a:noFill/>
-          <a:ln/>
-        </p:spPr>
-        <p:txBody>
-          <a:bodyPr wrap="square" lIns="0" tIns="0" rIns="0" bIns="0" rtlCol="0" anchor="t"/>
-          <a:lstStyle/>
-          <a:p>
-            <a:pPr algn="l" indent="0" marL="0">
-              <a:buNone/>
-            </a:pPr>
-            <a:r>
-              <a:rPr lang="en-US" altLang="en-US" sz="2400" dirty="0">
-                <a:solidFill>
-                  <a:srgbClr val="3C4043"/>
-                </a:solidFill>
-                <a:latin typeface="Inter" pitchFamily="34" charset="0"/>
-                <a:ea typeface="Inter" pitchFamily="34" charset="-122"/>
-                <a:cs typeface="Inter" pitchFamily="34" charset="-120"/>
-              </a:rPr>
-              <a:t>3. PLAN FEEDBACK → COMPLETE OR REVISE CER</a:t>
-            </a:r>
-            <a:endParaRPr lang="en-US" sz="2400" dirty="0"/>
-          </a:p>
-        </p:txBody>
-      </p:sp>
-      <p:sp>
-        <p:nvSpPr>
-          <p:cNvPr id="18" name="three-body"/>
-          <p:cNvSpPr/>
-          <p:nvPr/>
-        </p:nvSpPr>
-        <p:spPr>
-          <a:xfrm>
-            <a:off x="5181600" y="6007100"/>
-            <a:ext cx="9842500" cy="762000"/>
+          <p:cNvPr id="15" name="three"/>
+          <p:cNvSpPr/>
+          <p:nvPr/>
+        </p:nvSpPr>
+        <p:spPr>
+          <a:xfrm>
+            <a:off x="5181600" y="5537200"/>
+            <a:ext cx="9842500" cy="1181100"/>
           </a:xfrm>
           <a:prstGeom prst="rect">
             <a:avLst/>
@@ -5525,12 +5489,23 @@
           <a:p>
             <a:pPr algn="l" indent="0" marL="0">
               <a:lnSpc>
-                <a:spcPts val="2478"/>
+                <a:spcPts val="2400"/>
               </a:lnSpc>
               <a:buNone/>
             </a:pPr>
             <a:r>
-              <a:rPr lang="en-US" altLang="en-US" sz="2100" dirty="0">
+              <a:rPr lang="en-US" altLang="en-US" sz="2000" b="1" dirty="0">
+                <a:solidFill>
+                  <a:srgbClr val="C41220"/>
+                </a:solidFill>
+                <a:latin typeface="Inter" pitchFamily="34" charset="0"/>
+                <a:ea typeface="Inter" pitchFamily="34" charset="-122"/>
+                <a:cs typeface="Inter" pitchFamily="34" charset="-120"/>
+              </a:rPr>
+              <a:t>3. Every Day Question 4 — How will students experience the lesson?</a:t>
+            </a:r>
+            <a:r>
+              <a:rPr lang="en-US" altLang="en-US" sz="2000" dirty="0">
                 <a:solidFill>
                   <a:srgbClr val="3C4043"/>
                 </a:solidFill>
@@ -5538,15 +5513,15 @@
                 <a:ea typeface="Inter" pitchFamily="34" charset="-122"/>
                 <a:cs typeface="Inter" pitchFamily="34" charset="-120"/>
               </a:rPr>
-              <a:t>Write one prompt that sends students back to the evidence or science idea, then name the visible action: identify, complete, revise, add, explain, compare, or correct.</a:t>
-            </a:r>
-            <a:endParaRPr lang="en-US" sz="2100" dirty="0"/>
-          </a:p>
-        </p:txBody>
-      </p:sp>
-      <p:sp>
-        <p:nvSpPr>
-          <p:cNvPr id="19" name="page"/>
+              <a:t> Identify the access support, facilitation move, and feedback/revision opportunity students need while remaining responsible for the science thinking.</a:t>
+            </a:r>
+            <a:endParaRPr lang="en-US" sz="2000" dirty="0"/>
+          </a:p>
+        </p:txBody>
+      </p:sp>
+      <p:sp>
+        <p:nvSpPr>
+          <p:cNvPr id="16" name="page"/>
           <p:cNvSpPr/>
           <p:nvPr/>
         </p:nvSpPr>
@@ -5585,7 +5560,7 @@
       </p:sp>
       <p:sp>
         <p:nvSpPr>
-          <p:cNvPr id="20" name="worktime-shape-19"/>
+          <p:cNvPr id="17" name="worktime-shape-16"/>
           <p:cNvSpPr/>
           <p:nvPr/>
         </p:nvSpPr>
@@ -5617,7 +5592,7 @@
     <p:bg>
       <p:bgPr>
         <a:solidFill>
-          <a:srgbClr val="202124"/>
+          <a:srgbClr val="FFFFFF"/>
         </a:solidFill>
       </p:bgPr>
     </p:bg>
@@ -5644,27 +5619,27 @@
         <p:spPr>
           <a:xfrm>
             <a:off x="0" y="0"/>
-            <a:ext cx="355600" cy="9144000"/>
-          </a:xfrm>
-          <a:prstGeom prst="rect">
-            <a:avLst/>
-          </a:prstGeom>
-          <a:solidFill>
-            <a:srgbClr val="C41220"/>
-          </a:solidFill>
-          <a:ln/>
-        </p:spPr>
-      </p:sp>
-      <p:sp>
-        <p:nvSpPr>
-          <p:cNvPr id="3" name="close-kicker"/>
-          <p:cNvSpPr/>
-          <p:nvPr/>
-        </p:nvSpPr>
-        <p:spPr>
-          <a:xfrm>
-            <a:off x="889000" y="1168400"/>
-            <a:ext cx="10414000" cy="330200"/>
+            <a:ext cx="16256000" cy="1016000"/>
+          </a:xfrm>
+          <a:prstGeom prst="rect">
+            <a:avLst/>
+          </a:prstGeom>
+          <a:solidFill>
+            <a:srgbClr val="202124"/>
+          </a:solidFill>
+          <a:ln/>
+        </p:spPr>
+      </p:sp>
+      <p:sp>
+        <p:nvSpPr>
+          <p:cNvPr id="3" name="kicker"/>
+          <p:cNvSpPr/>
+          <p:nvPr/>
+        </p:nvSpPr>
+        <p:spPr>
+          <a:xfrm>
+            <a:off x="736600" y="342900"/>
+            <a:ext cx="11430000" cy="330200"/>
           </a:xfrm>
           <a:prstGeom prst="rect">
             <a:avLst/>
@@ -5680,29 +5655,29 @@
               <a:buNone/>
             </a:pPr>
             <a:r>
-              <a:rPr lang="en-US" altLang="en-US" sz="1700" dirty="0">
-                <a:solidFill>
-                  <a:srgbClr val="D1D5DB"/>
-                </a:solidFill>
-                <a:latin typeface="Inter" pitchFamily="34" charset="0"/>
-                <a:ea typeface="Inter" pitchFamily="34" charset="-122"/>
-                <a:cs typeface="Inter" pitchFamily="34" charset="-120"/>
-              </a:rPr>
-              <a:t>CLOSE + CARRY FORWARD  •  36:00–41:00  •  5 MIN</a:t>
-            </a:r>
-            <a:endParaRPr lang="en-US" sz="1700" dirty="0"/>
-          </a:p>
-        </p:txBody>
-      </p:sp>
-      <p:sp>
-        <p:nvSpPr>
-          <p:cNvPr id="4" name="close-title"/>
-          <p:cNvSpPr/>
-          <p:nvPr/>
-        </p:nvSpPr>
-        <p:spPr>
-          <a:xfrm>
-            <a:off x="889000" y="1917700"/>
+              <a:rPr lang="en-US" altLang="en-US" sz="1600" dirty="0">
+                <a:solidFill>
+                  <a:srgbClr val="F1F3F4"/>
+                </a:solidFill>
+                <a:latin typeface="Inter" pitchFamily="34" charset="0"/>
+                <a:ea typeface="Inter" pitchFamily="34" charset="-122"/>
+                <a:cs typeface="Inter" pitchFamily="34" charset="-120"/>
+              </a:rPr>
+              <a:t>CLOSE + CARRY FORWARD  •  39:00–41:00  •  2 MIN</a:t>
+            </a:r>
+            <a:endParaRPr lang="en-US" sz="1600" dirty="0"/>
+          </a:p>
+        </p:txBody>
+      </p:sp>
+      <p:sp>
+        <p:nvSpPr>
+          <p:cNvPr id="4" name="title"/>
+          <p:cNvSpPr/>
+          <p:nvPr/>
+        </p:nvSpPr>
+        <p:spPr>
+          <a:xfrm>
+            <a:off x="736600" y="1689100"/>
             <a:ext cx="13208000" cy="787400"/>
           </a:xfrm>
           <a:prstGeom prst="rect">
@@ -5719,17 +5694,17 @@
               <a:buNone/>
             </a:pPr>
             <a:r>
-              <a:rPr lang="en-US" altLang="en-US" sz="4400" dirty="0">
-                <a:solidFill>
-                  <a:srgbClr val="FFFFFF"/>
-                </a:solidFill>
-                <a:latin typeface="Inter" pitchFamily="34" charset="0"/>
-                <a:ea typeface="Inter" pitchFamily="34" charset="-122"/>
-                <a:cs typeface="Inter" pitchFamily="34" charset="-120"/>
-              </a:rPr>
-              <a:t>Keep the same task at the center of the week.</a:t>
-            </a:r>
-            <a:endParaRPr lang="en-US" sz="4400" dirty="0"/>
+              <a:rPr lang="en-US" altLang="en-US" sz="4300" dirty="0">
+                <a:solidFill>
+                  <a:srgbClr val="202124"/>
+                </a:solidFill>
+                <a:latin typeface="Inter" pitchFamily="34" charset="0"/>
+                <a:ea typeface="Inter" pitchFamily="34" charset="-122"/>
+                <a:cs typeface="Inter" pitchFamily="34" charset="-120"/>
+              </a:rPr>
+              <a:t>Bring the analysis forward. Tuesday turns it into instruction.</a:t>
+            </a:r>
+            <a:endParaRPr lang="en-US" sz="4300" dirty="0"/>
           </a:p>
         </p:txBody>
       </p:sp>
@@ -5741,18 +5716,18 @@
         </p:nvSpPr>
         <p:spPr>
           <a:xfrm>
-            <a:off x="889000" y="3263900"/>
-            <a:ext cx="13716000" cy="3733800"/>
-          </a:xfrm>
-          <a:prstGeom prst="rect">
-            <a:avLst/>
-          </a:prstGeom>
-          <a:solidFill>
-            <a:srgbClr val="2D2E31"/>
+            <a:off x="736600" y="3136900"/>
+            <a:ext cx="14706600" cy="3505200"/>
+          </a:xfrm>
+          <a:prstGeom prst="rect">
+            <a:avLst/>
+          </a:prstGeom>
+          <a:solidFill>
+            <a:srgbClr val="F3F4F6"/>
           </a:solidFill>
           <a:ln w="12700">
             <a:solidFill>
-              <a:srgbClr val="72777D"/>
+              <a:srgbClr val="D1D5DB"/>
             </a:solidFill>
             <a:prstDash val="solid"/>
           </a:ln>
@@ -5760,14 +5735,114 @@
       </p:sp>
       <p:sp>
         <p:nvSpPr>
-          <p:cNvPr id="6" name="close-list"/>
-          <p:cNvSpPr/>
-          <p:nvPr/>
-        </p:nvSpPr>
-        <p:spPr>
-          <a:xfrm>
-            <a:off x="1422400" y="3708400"/>
-            <a:ext cx="12522200" cy="2717800"/>
+          <p:cNvPr id="6" name="close-shape-5"/>
+          <p:cNvSpPr/>
+          <p:nvPr/>
+        </p:nvSpPr>
+        <p:spPr>
+          <a:xfrm>
+            <a:off x="1092200" y="3543300"/>
+            <a:ext cx="3200400" cy="2324100"/>
+          </a:xfrm>
+          <a:prstGeom prst="rect">
+            <a:avLst/>
+          </a:prstGeom>
+          <a:solidFill>
+            <a:srgbClr val="FCE8EA"/>
+          </a:solidFill>
+          <a:ln w="12700">
+            <a:solidFill>
+              <a:srgbClr val="C41220"/>
+            </a:solidFill>
+            <a:prstDash val="solid"/>
+          </a:ln>
+        </p:spPr>
+      </p:sp>
+      <p:sp>
+        <p:nvSpPr>
+          <p:cNvPr id="7" name="close-shape-6"/>
+          <p:cNvSpPr/>
+          <p:nvPr/>
+        </p:nvSpPr>
+        <p:spPr>
+          <a:xfrm>
+            <a:off x="4724400" y="3543300"/>
+            <a:ext cx="3200400" cy="2324100"/>
+          </a:xfrm>
+          <a:prstGeom prst="rect">
+            <a:avLst/>
+          </a:prstGeom>
+          <a:solidFill>
+            <a:srgbClr val="F8F9FA"/>
+          </a:solidFill>
+          <a:ln w="12700">
+            <a:solidFill>
+              <a:srgbClr val="D1D5DB"/>
+            </a:solidFill>
+            <a:prstDash val="solid"/>
+          </a:ln>
+        </p:spPr>
+      </p:sp>
+      <p:sp>
+        <p:nvSpPr>
+          <p:cNvPr id="8" name="close-shape-7"/>
+          <p:cNvSpPr/>
+          <p:nvPr/>
+        </p:nvSpPr>
+        <p:spPr>
+          <a:xfrm>
+            <a:off x="8356600" y="3543300"/>
+            <a:ext cx="3200400" cy="2324100"/>
+          </a:xfrm>
+          <a:prstGeom prst="rect">
+            <a:avLst/>
+          </a:prstGeom>
+          <a:solidFill>
+            <a:srgbClr val="F8F9FA"/>
+          </a:solidFill>
+          <a:ln w="12700">
+            <a:solidFill>
+              <a:srgbClr val="D1D5DB"/>
+            </a:solidFill>
+            <a:prstDash val="solid"/>
+          </a:ln>
+        </p:spPr>
+      </p:sp>
+      <p:sp>
+        <p:nvSpPr>
+          <p:cNvPr id="9" name="close-shape-8"/>
+          <p:cNvSpPr/>
+          <p:nvPr/>
+        </p:nvSpPr>
+        <p:spPr>
+          <a:xfrm>
+            <a:off x="11988800" y="3543300"/>
+            <a:ext cx="3098800" cy="2324100"/>
+          </a:xfrm>
+          <a:prstGeom prst="rect">
+            <a:avLst/>
+          </a:prstGeom>
+          <a:solidFill>
+            <a:srgbClr val="F8F9FA"/>
+          </a:solidFill>
+          <a:ln w="12700">
+            <a:solidFill>
+              <a:srgbClr val="D1D5DB"/>
+            </a:solidFill>
+            <a:prstDash val="solid"/>
+          </a:ln>
+        </p:spPr>
+      </p:sp>
+      <p:sp>
+        <p:nvSpPr>
+          <p:cNvPr id="10" name="item1"/>
+          <p:cNvSpPr/>
+          <p:nvPr/>
+        </p:nvSpPr>
+        <p:spPr>
+          <a:xfrm>
+            <a:off x="1346200" y="3835400"/>
+            <a:ext cx="2692400" cy="1714500"/>
           </a:xfrm>
           <a:prstGeom prst="rect">
             <a:avLst/>
@@ -5781,131 +5856,253 @@
           <a:p>
             <a:pPr algn="l" indent="0" marL="0">
               <a:lnSpc>
-                <a:spcPts val="2875"/>
+                <a:spcPts val="1680"/>
               </a:lnSpc>
               <a:buNone/>
             </a:pPr>
             <a:r>
-              <a:rPr lang="en-US" altLang="en-US" sz="2300" b="1" dirty="0">
-                <a:solidFill>
-                  <a:srgbClr val="F6B4BA"/>
-                </a:solidFill>
-                <a:latin typeface="Inter" pitchFamily="34" charset="0"/>
-                <a:ea typeface="Inter" pitchFamily="34" charset="-122"/>
-                <a:cs typeface="Inter" pitchFamily="34" charset="-120"/>
-              </a:rPr>
-              <a:t>Bring forward to Tuesday and Wednesday:</a:t>
-            </a:r>
-            <a:endParaRPr lang="en-US" sz="2300" dirty="0"/>
-          </a:p>
-          <a:p>
-            <a:pPr algn="l" marL="365125" indent="-365125">
+              <a:rPr lang="en-US" altLang="en-US" sz="1400" b="1" dirty="0">
+                <a:solidFill>
+                  <a:srgbClr val="C41220"/>
+                </a:solidFill>
+                <a:latin typeface="Inter" pitchFamily="34" charset="0"/>
+                <a:ea typeface="Inter" pitchFamily="34" charset="-122"/>
+                <a:cs typeface="Inter" pitchFamily="34" charset="-120"/>
+              </a:rPr>
+              <a:t>BRING</a:t>
+            </a:r>
+            <a:endParaRPr lang="en-US" sz="1900" dirty="0"/>
+          </a:p>
+          <a:p>
+            <a:pPr algn="l" indent="0" marL="0">
               <a:lnSpc>
-                <a:spcPts val="2875"/>
+                <a:spcPts val="2280"/>
               </a:lnSpc>
               <a:spcBef>
-                <a:spcPts val="10"/>
+                <a:spcPts val="900"/>
               </a:spcBef>
-              <a:buSzPct val="100000"/>
-              <a:buChar char="•"/>
-            </a:pPr>
-            <a:r>
-              <a:rPr lang="en-US" altLang="en-US" sz="2300" dirty="0">
-                <a:solidFill>
-                  <a:srgbClr val="FFFFFF"/>
-                </a:solidFill>
-                <a:latin typeface="Inter" pitchFamily="34" charset="0"/>
-                <a:ea typeface="Inter" pitchFamily="34" charset="-122"/>
-                <a:cs typeface="Inter" pitchFamily="34" charset="-120"/>
-              </a:rPr>
-              <a:t>the upcoming writing benchmark/task and annotated source or evidence;</a:t>
-            </a:r>
-            <a:endParaRPr lang="en-US" sz="2300" dirty="0"/>
-          </a:p>
-          <a:p>
-            <a:pPr algn="l" marL="365125" indent="-365125">
+              <a:buNone/>
+            </a:pPr>
+            <a:r>
+              <a:rPr lang="en-US" altLang="en-US" sz="1900" b="1" dirty="0">
+                <a:solidFill>
+                  <a:srgbClr val="3C4043"/>
+                </a:solidFill>
+                <a:latin typeface="Inter" pitchFamily="34" charset="0"/>
+                <a:ea typeface="Inter" pitchFamily="34" charset="-122"/>
+                <a:cs typeface="Inter" pitchFamily="34" charset="-120"/>
+              </a:rPr>
+              <a:t>Your completed benchmark or course-equivalent task analysis.</a:t>
+            </a:r>
+            <a:endParaRPr lang="en-US" sz="1900" dirty="0"/>
+          </a:p>
+        </p:txBody>
+      </p:sp>
+      <p:sp>
+        <p:nvSpPr>
+          <p:cNvPr id="11" name="item2"/>
+          <p:cNvSpPr/>
+          <p:nvPr/>
+        </p:nvSpPr>
+        <p:spPr>
+          <a:xfrm>
+            <a:off x="4978400" y="3835400"/>
+            <a:ext cx="2692400" cy="1714500"/>
+          </a:xfrm>
+          <a:prstGeom prst="rect">
+            <a:avLst/>
+          </a:prstGeom>
+          <a:noFill/>
+          <a:ln/>
+        </p:spPr>
+        <p:txBody>
+          <a:bodyPr wrap="square" lIns="0" tIns="0" rIns="0" bIns="0" rtlCol="0" anchor="t"/>
+          <a:lstStyle/>
+          <a:p>
+            <a:pPr algn="l" indent="0" marL="0">
               <a:lnSpc>
-                <a:spcPts val="2875"/>
+                <a:spcPts val="1680"/>
+              </a:lnSpc>
+              <a:buNone/>
+            </a:pPr>
+            <a:r>
+              <a:rPr lang="en-US" altLang="en-US" sz="1400" b="1" dirty="0">
+                <a:solidFill>
+                  <a:srgbClr val="C41220"/>
+                </a:solidFill>
+                <a:latin typeface="Inter" pitchFamily="34" charset="0"/>
+                <a:ea typeface="Inter" pitchFamily="34" charset="-122"/>
+                <a:cs typeface="Inter" pitchFamily="34" charset="-120"/>
+              </a:rPr>
+              <a:t>NAME</a:t>
+            </a:r>
+            <a:endParaRPr lang="en-US" sz="1900" dirty="0"/>
+          </a:p>
+          <a:p>
+            <a:pPr algn="l" indent="0" marL="0">
+              <a:lnSpc>
+                <a:spcPts val="2280"/>
               </a:lnSpc>
               <a:spcBef>
-                <a:spcPts val="10"/>
+                <a:spcPts val="900"/>
               </a:spcBef>
-              <a:buSzPct val="100000"/>
-              <a:buChar char="•"/>
-            </a:pPr>
-            <a:r>
-              <a:rPr lang="en-US" altLang="en-US" sz="2300" dirty="0">
-                <a:solidFill>
-                  <a:srgbClr val="FFFFFF"/>
-                </a:solidFill>
-                <a:latin typeface="Inter" pitchFamily="34" charset="0"/>
-                <a:ea typeface="Inter" pitchFamily="34" charset="-122"/>
-                <a:cs typeface="Inter" pitchFamily="34" charset="-120"/>
-              </a:rPr>
-              <a:t>one complete CER response that meets the bar and one anticipated partial response;</a:t>
-            </a:r>
-            <a:endParaRPr lang="en-US" sz="2300" dirty="0"/>
-          </a:p>
-          <a:p>
-            <a:pPr algn="l" marL="365125" indent="-365125">
+              <a:buNone/>
+            </a:pPr>
+            <a:r>
+              <a:rPr lang="en-US" altLang="en-US" sz="1900" b="1" dirty="0">
+                <a:solidFill>
+                  <a:srgbClr val="3C4043"/>
+                </a:solidFill>
+                <a:latin typeface="Inter" pitchFamily="34" charset="0"/>
+                <a:ea typeface="Inter" pitchFamily="34" charset="-122"/>
+                <a:cs typeface="Inter" pitchFamily="34" charset="-120"/>
+              </a:rPr>
+              <a:t>One anticipated student response, question, or mistake.</a:t>
+            </a:r>
+            <a:endParaRPr lang="en-US" sz="1900" dirty="0"/>
+          </a:p>
+        </p:txBody>
+      </p:sp>
+      <p:sp>
+        <p:nvSpPr>
+          <p:cNvPr id="12" name="item3"/>
+          <p:cNvSpPr/>
+          <p:nvPr/>
+        </p:nvSpPr>
+        <p:spPr>
+          <a:xfrm>
+            <a:off x="8610600" y="3835400"/>
+            <a:ext cx="2692400" cy="1714500"/>
+          </a:xfrm>
+          <a:prstGeom prst="rect">
+            <a:avLst/>
+          </a:prstGeom>
+          <a:noFill/>
+          <a:ln/>
+        </p:spPr>
+        <p:txBody>
+          <a:bodyPr wrap="square" lIns="0" tIns="0" rIns="0" bIns="0" rtlCol="0" anchor="t"/>
+          <a:lstStyle/>
+          <a:p>
+            <a:pPr algn="l" indent="0" marL="0">
               <a:lnSpc>
-                <a:spcPts val="2875"/>
+                <a:spcPts val="1680"/>
+              </a:lnSpc>
+              <a:buNone/>
+            </a:pPr>
+            <a:r>
+              <a:rPr lang="en-US" altLang="en-US" sz="1400" b="1" dirty="0">
+                <a:solidFill>
+                  <a:srgbClr val="C41220"/>
+                </a:solidFill>
+                <a:latin typeface="Inter" pitchFamily="34" charset="0"/>
+                <a:ea typeface="Inter" pitchFamily="34" charset="-122"/>
+                <a:cs typeface="Inter" pitchFamily="34" charset="-120"/>
+              </a:rPr>
+              <a:t>HOLD</a:t>
+            </a:r>
+            <a:endParaRPr lang="en-US" sz="1900" dirty="0"/>
+          </a:p>
+          <a:p>
+            <a:pPr algn="l" indent="0" marL="0">
+              <a:lnSpc>
+                <a:spcPts val="2280"/>
               </a:lnSpc>
               <a:spcBef>
-                <a:spcPts val="10"/>
+                <a:spcPts val="900"/>
               </a:spcBef>
-              <a:buSzPct val="100000"/>
-              <a:buChar char="•"/>
-            </a:pPr>
-            <a:r>
-              <a:rPr lang="en-US" altLang="en-US" sz="2300" dirty="0">
-                <a:solidFill>
-                  <a:srgbClr val="FFFFFF"/>
-                </a:solidFill>
-                <a:latin typeface="Inter" pitchFamily="34" charset="0"/>
-                <a:ea typeface="Inter" pitchFamily="34" charset="-122"/>
-                <a:cs typeface="Inter" pitchFamily="34" charset="-120"/>
-              </a:rPr>
-              <a:t>one feedback prompt and the student action it should produce; and</a:t>
-            </a:r>
-            <a:endParaRPr lang="en-US" sz="2300" dirty="0"/>
-          </a:p>
-          <a:p>
-            <a:pPr algn="l" marL="365125" indent="-365125">
+              <a:buNone/>
+            </a:pPr>
+            <a:r>
+              <a:rPr lang="en-US" altLang="en-US" sz="1900" b="1" dirty="0">
+                <a:solidFill>
+                  <a:srgbClr val="3C4043"/>
+                </a:solidFill>
+                <a:latin typeface="Inter" pitchFamily="34" charset="0"/>
+                <a:ea typeface="Inter" pitchFamily="34" charset="-122"/>
+                <a:cs typeface="Inter" pitchFamily="34" charset="-120"/>
+              </a:rPr>
+              <a:t>The standard, mastery bar, and task demand visible.</a:t>
+            </a:r>
+            <a:endParaRPr lang="en-US" sz="1900" dirty="0"/>
+          </a:p>
+        </p:txBody>
+      </p:sp>
+      <p:sp>
+        <p:nvSpPr>
+          <p:cNvPr id="13" name="item4"/>
+          <p:cNvSpPr/>
+          <p:nvPr/>
+        </p:nvSpPr>
+        <p:spPr>
+          <a:xfrm>
+            <a:off x="12242800" y="3835400"/>
+            <a:ext cx="2590800" cy="1714500"/>
+          </a:xfrm>
+          <a:prstGeom prst="rect">
+            <a:avLst/>
+          </a:prstGeom>
+          <a:noFill/>
+          <a:ln/>
+        </p:spPr>
+        <p:txBody>
+          <a:bodyPr wrap="square" lIns="0" tIns="0" rIns="0" bIns="0" rtlCol="0" anchor="t"/>
+          <a:lstStyle/>
+          <a:p>
+            <a:pPr algn="l" indent="0" marL="0">
               <a:lnSpc>
-                <a:spcPts val="2875"/>
+                <a:spcPts val="1680"/>
+              </a:lnSpc>
+              <a:buNone/>
+            </a:pPr>
+            <a:r>
+              <a:rPr lang="en-US" altLang="en-US" sz="1400" b="1" dirty="0">
+                <a:solidFill>
+                  <a:srgbClr val="C41220"/>
+                </a:solidFill>
+                <a:latin typeface="Inter" pitchFamily="34" charset="0"/>
+                <a:ea typeface="Inter" pitchFamily="34" charset="-122"/>
+                <a:cs typeface="Inter" pitchFamily="34" charset="-120"/>
+              </a:rPr>
+              <a:t>PLAN</a:t>
+            </a:r>
+            <a:endParaRPr lang="en-US" sz="1900" dirty="0"/>
+          </a:p>
+          <a:p>
+            <a:pPr algn="l" indent="0" marL="0">
+              <a:lnSpc>
+                <a:spcPts val="2280"/>
               </a:lnSpc>
               <a:spcBef>
-                <a:spcPts val="10"/>
+                <a:spcPts val="900"/>
               </a:spcBef>
-              <a:buSzPct val="100000"/>
-              <a:buChar char="•"/>
-            </a:pPr>
-            <a:r>
-              <a:rPr lang="en-US" altLang="en-US" sz="2300" dirty="0">
-                <a:solidFill>
-                  <a:srgbClr val="FFFFFF"/>
-                </a:solidFill>
-                <a:latin typeface="Inter" pitchFamily="34" charset="0"/>
-                <a:ea typeface="Inter" pitchFamily="34" charset="-122"/>
-                <a:cs typeface="Inter" pitchFamily="34" charset="-120"/>
-              </a:rPr>
-              <a:t>one small anonymized sample, exemplar, or calibration question.</a:t>
-            </a:r>
-            <a:endParaRPr lang="en-US" sz="2300" dirty="0"/>
-          </a:p>
-        </p:txBody>
-      </p:sp>
-      <p:sp>
-        <p:nvSpPr>
-          <p:cNvPr id="7" name="close-footer"/>
-          <p:cNvSpPr/>
-          <p:nvPr/>
-        </p:nvSpPr>
-        <p:spPr>
-          <a:xfrm>
-            <a:off x="889000" y="7442200"/>
-            <a:ext cx="12319000" cy="533400"/>
+              <a:buNone/>
+            </a:pPr>
+            <a:r>
+              <a:rPr lang="en-US" altLang="en-US" sz="1900" b="1" dirty="0">
+                <a:solidFill>
+                  <a:srgbClr val="3C4043"/>
+                </a:solidFill>
+                <a:latin typeface="Inter" pitchFamily="34" charset="0"/>
+                <a:ea typeface="Inter" pitchFamily="34" charset="-122"/>
+                <a:cs typeface="Inter" pitchFamily="34" charset="-120"/>
+              </a:rPr>
+              <a:t>One lesson, access, and feedback decision.</a:t>
+            </a:r>
+            <a:endParaRPr lang="en-US" sz="1900" dirty="0"/>
+          </a:p>
+        </p:txBody>
+      </p:sp>
+      <p:sp>
+        <p:nvSpPr>
+          <p:cNvPr id="14" name="footer"/>
+          <p:cNvSpPr/>
+          <p:nvPr/>
+        </p:nvSpPr>
+        <p:spPr>
+          <a:xfrm>
+            <a:off x="736600" y="7289800"/>
+            <a:ext cx="14198600" cy="457200"/>
           </a:xfrm>
           <a:prstGeom prst="rect">
             <a:avLst/>
@@ -5917,34 +6114,45 @@
           <a:bodyPr wrap="square" lIns="0" tIns="0" rIns="0" bIns="0" rtlCol="0" anchor="t"/>
           <a:lstStyle/>
           <a:p>
-            <a:pPr algn="l" indent="0" marL="0">
-              <a:buNone/>
-            </a:pPr>
-            <a:r>
-              <a:rPr lang="en-US" altLang="en-US" sz="2300" dirty="0">
-                <a:solidFill>
-                  <a:srgbClr val="F1F3F4"/>
-                </a:solidFill>
-                <a:latin typeface="Inter" pitchFamily="34" charset="0"/>
-                <a:ea typeface="Inter" pitchFamily="34" charset="-122"/>
-                <a:cs typeface="Inter" pitchFamily="34" charset="-120"/>
-              </a:rPr>
-              <a:t>Optional only if it helps: note the related unit-test standard/question evidence. The benchmark task remains the priority.</a:t>
-            </a:r>
-            <a:endParaRPr lang="en-US" sz="2300" dirty="0"/>
-          </a:p>
-        </p:txBody>
-      </p:sp>
-      <p:sp>
-        <p:nvSpPr>
-          <p:cNvPr id="8" name="page"/>
-          <p:cNvSpPr/>
-          <p:nvPr/>
-        </p:nvSpPr>
-        <p:spPr>
-          <a:xfrm>
-            <a:off x="14478000" y="8407400"/>
-            <a:ext cx="762000" cy="228600"/>
+            <a:pPr algn="ctr" indent="0" marL="0">
+              <a:buNone/>
+            </a:pPr>
+            <a:r>
+              <a:rPr lang="en-US" altLang="en-US" sz="2200" b="1" dirty="0">
+                <a:solidFill>
+                  <a:srgbClr val="C41220"/>
+                </a:solidFill>
+                <a:latin typeface="Inter" pitchFamily="34" charset="0"/>
+                <a:ea typeface="Inter" pitchFamily="34" charset="-122"/>
+                <a:cs typeface="Inter" pitchFamily="34" charset="-120"/>
+              </a:rPr>
+              <a:t>Tuesday:</a:t>
+            </a:r>
+            <a:r>
+              <a:rPr lang="en-US" altLang="en-US" sz="2200" dirty="0">
+                <a:solidFill>
+                  <a:srgbClr val="3C4043"/>
+                </a:solidFill>
+                <a:latin typeface="Inter" pitchFamily="34" charset="0"/>
+                <a:ea typeface="Inter" pitchFamily="34" charset="-122"/>
+                <a:cs typeface="Inter" pitchFamily="34" charset="-120"/>
+              </a:rPr>
+              <a:t> use Monday’s evidence to plan how students will learn, receive feedback, revise, and move toward standard mastery.</a:t>
+            </a:r>
+            <a:endParaRPr lang="en-US" sz="2200" dirty="0"/>
+          </a:p>
+        </p:txBody>
+      </p:sp>
+      <p:sp>
+        <p:nvSpPr>
+          <p:cNvPr id="15" name="page"/>
+          <p:cNvSpPr/>
+          <p:nvPr/>
+        </p:nvSpPr>
+        <p:spPr>
+          <a:xfrm>
+            <a:off x="14732000" y="8432800"/>
+            <a:ext cx="736600" cy="228600"/>
           </a:xfrm>
           <a:prstGeom prst="rect">
             <a:avLst/>
@@ -5962,7 +6170,7 @@
             <a:r>
               <a:rPr lang="en-US" altLang="en-US" sz="1300" dirty="0">
                 <a:solidFill>
-                  <a:srgbClr val="D1D5DB"/>
+                  <a:srgbClr val="6B7280"/>
                 </a:solidFill>
                 <a:latin typeface="Inter" pitchFamily="34" charset="0"/>
                 <a:ea typeface="Inter" pitchFamily="34" charset="-122"/>
@@ -5976,7 +6184,7 @@
       </p:sp>
       <p:sp>
         <p:nvSpPr>
-          <p:cNvPr id="9" name="close-shape-8"/>
+          <p:cNvPr id="16" name="close-shape-15"/>
           <p:cNvSpPr/>
           <p:nvPr/>
         </p:nvSpPr>

</xml_diff>